<commit_message>
Lesson sd-10-020: explain the eight paradigms from the Python, MDN, Spring, AspectJ, Reactive Streams, JDK and Go documentation instead of following the source definitions, with the figure, metadata and deck
Co-Authored-By: Claude Sonnet 5.5 <noreply@anthropic.com>
Claude-Session: https://claude.ai/code/session_011dmt3ZFdN8sjiTfDnyUVN7
</commit_message>
<xml_diff>
--- a/system-design-101/vi/lessons/sd-10-020/slides/sd-10-020.pptx
+++ b/system-design-101/vi/lessons/sd-10-020/slides/sd-10-020.pptx
@@ -4045,7 +4045,7 @@
               <a:buNone/>
             </a:pPr>
             <a:r>
-              <a:rPr lang="en-US" sz="1800" dirty="0" spc="-3" kern="0">
+              <a:rPr lang="en-US" sz="1800" dirty="0" spc="0" kern="0">
                 <a:solidFill>
                   <a:srgbClr val="9AA0B5"/>
                 </a:solidFill>
@@ -4053,10 +4053,10 @@
                 <a:ea typeface="Be Vietnam Pro" pitchFamily="34" charset="-122"/>
                 <a:cs typeface="Be Vietnam Pro" pitchFamily="34" charset="-120"/>
               </a:rPr>
-              <a:t>bài</a:t>
-            </a:r>
-            <a:r>
-              <a:rPr lang="en-US" sz="1800" dirty="0" spc="-4" kern="0">
+              <a:t>chỉ</a:t>
+            </a:r>
+            <a:r>
+              <a:rPr lang="en-US" sz="1800" dirty="0" spc="-7" kern="0">
                 <a:solidFill>
                   <a:srgbClr val="9AA0B5"/>
                 </a:solidFill>
@@ -4064,7 +4064,18 @@
                 <a:ea typeface="Be Vietnam Pro" pitchFamily="34" charset="-122"/>
                 <a:cs typeface="Be Vietnam Pro" pitchFamily="34" charset="-120"/>
               </a:rPr>
-              <a:t> nguồn,</a:t>
+              <a:t> lấy</a:t>
+            </a:r>
+            <a:r>
+              <a:rPr lang="en-US" sz="1800" dirty="0" spc="-13" kern="0">
+                <a:solidFill>
+                  <a:srgbClr val="9AA0B5"/>
+                </a:solidFill>
+                <a:latin typeface="Be Vietnam Pro" pitchFamily="34" charset="0"/>
+                <a:ea typeface="Be Vietnam Pro" pitchFamily="34" charset="-122"/>
+                <a:cs typeface="Be Vietnam Pro" pitchFamily="34" charset="-120"/>
+              </a:rPr>
+              <a:t> tên</a:t>
             </a:r>
             <a:r>
               <a:rPr lang="en-US" sz="1800" dirty="0" spc="-11" kern="0">
@@ -4078,6 +4089,17 @@
               <a:t> tám</a:t>
             </a:r>
             <a:r>
+              <a:rPr lang="en-US" sz="1800" dirty="0" spc="-1" kern="0">
+                <a:solidFill>
+                  <a:srgbClr val="9AA0B5"/>
+                </a:solidFill>
+                <a:latin typeface="Be Vietnam Pro" pitchFamily="34" charset="0"/>
+                <a:ea typeface="Be Vietnam Pro" pitchFamily="34" charset="-122"/>
+                <a:cs typeface="Be Vietnam Pro" pitchFamily="34" charset="-120"/>
+              </a:rPr>
+              <a:t> mô</a:t>
+            </a:r>
+            <a:r>
               <a:rPr lang="en-US" sz="1800" dirty="0" spc="-2" kern="0">
                 <a:solidFill>
                   <a:srgbClr val="9AA0B5"/>
@@ -4086,7 +4108,7 @@
                 <a:ea typeface="Be Vietnam Pro" pitchFamily="34" charset="-122"/>
                 <a:cs typeface="Be Vietnam Pro" pitchFamily="34" charset="-120"/>
               </a:rPr>
-              <a:t> mô hình</a:t>
+              <a:t> hình</a:t>
             </a:r>
             <a:endParaRPr lang="en-US" sz="1800" dirty="0"/>
           </a:p>
@@ -4546,7 +4568,29 @@
                 <a:ea typeface="Be Vietnam Pro" pitchFamily="34" charset="-122"/>
                 <a:cs typeface="Be Vietnam Pro" pitchFamily="34" charset="-120"/>
               </a:rPr>
-              <a:t> 2026-10-18.</a:t>
+              <a:t> 2026-10-19.</a:t>
+            </a:r>
+            <a:r>
+              <a:rPr lang="en-US" sz="1950" dirty="0" spc="-4" kern="0">
+                <a:solidFill>
+                  <a:srgbClr val="C4C8D6"/>
+                </a:solidFill>
+                <a:latin typeface="Be Vietnam Pro" pitchFamily="34" charset="0"/>
+                <a:ea typeface="Be Vietnam Pro" pitchFamily="34" charset="-122"/>
+                <a:cs typeface="Be Vietnam Pro" pitchFamily="34" charset="-120"/>
+              </a:rPr>
+              <a:t> Đọc</a:t>
+            </a:r>
+            <a:r>
+              <a:rPr lang="en-US" sz="1950" dirty="0" spc="-1" kern="0">
+                <a:solidFill>
+                  <a:srgbClr val="C4C8D6"/>
+                </a:solidFill>
+                <a:latin typeface="Be Vietnam Pro" pitchFamily="34" charset="0"/>
+                <a:ea typeface="Be Vietnam Pro" pitchFamily="34" charset="-122"/>
+                <a:cs typeface="Be Vietnam Pro" pitchFamily="34" charset="-120"/>
+              </a:rPr>
+              <a:t> thêm:</a:t>
             </a:r>
             <a:r>
               <a:rPr lang="en-US" sz="1950" dirty="0" spc="0" kern="0">
@@ -4557,10 +4601,10 @@
                 <a:ea typeface="Be Vietnam Pro" pitchFamily="34" charset="-122"/>
                 <a:cs typeface="Be Vietnam Pro" pitchFamily="34" charset="-120"/>
               </a:rPr>
-              <a:t> Hình</a:t>
-            </a:r>
-            <a:r>
-              <a:rPr lang="en-US" sz="1950" dirty="0" spc="2" kern="0">
+              <a:t> MDN,</a:t>
+            </a:r>
+            <a:r>
+              <a:rPr lang="en-US" sz="1950" dirty="0" spc="7" kern="0">
                 <a:solidFill>
                   <a:srgbClr val="C4C8D6"/>
                 </a:solidFill>
@@ -4568,7 +4612,18 @@
                 <a:ea typeface="Be Vietnam Pro" pitchFamily="34" charset="-122"/>
                 <a:cs typeface="Be Vietnam Pro" pitchFamily="34" charset="-120"/>
               </a:rPr>
-              <a:t> minh</a:t>
+              <a:t> Spring</a:t>
+            </a:r>
+            <a:r>
+              <a:rPr lang="en-US" sz="1950" dirty="0" spc="-15" kern="0">
+                <a:solidFill>
+                  <a:srgbClr val="C4C8D6"/>
+                </a:solidFill>
+                <a:latin typeface="Be Vietnam Pro" pitchFamily="34" charset="0"/>
+                <a:ea typeface="Be Vietnam Pro" pitchFamily="34" charset="-122"/>
+                <a:cs typeface="Be Vietnam Pro" pitchFamily="34" charset="-120"/>
+              </a:rPr>
+              <a:t> AOP,</a:t>
             </a:r>
             <a:r>
               <a:rPr lang="en-US" sz="1950" dirty="0" spc="-3" kern="0">
@@ -4579,10 +4634,10 @@
                 <a:ea typeface="Be Vietnam Pro" pitchFamily="34" charset="-122"/>
                 <a:cs typeface="Be Vietnam Pro" pitchFamily="34" charset="-120"/>
               </a:rPr>
-              <a:t> họa</a:t>
-            </a:r>
-            <a:r>
-              <a:rPr lang="en-US" sz="1950" dirty="0" spc="-2" kern="0">
+              <a:t> AspectJ,</a:t>
+            </a:r>
+            <a:r>
+              <a:rPr lang="en-US" sz="1950" dirty="0" spc="-16" kern="0">
                 <a:solidFill>
                   <a:srgbClr val="C4C8D6"/>
                 </a:solidFill>
@@ -4590,10 +4645,10 @@
                 <a:ea typeface="Be Vietnam Pro" pitchFamily="34" charset="-122"/>
                 <a:cs typeface="Be Vietnam Pro" pitchFamily="34" charset="-120"/>
               </a:rPr>
-              <a:t> là</a:t>
-            </a:r>
-            <a:r>
-              <a:rPr lang="en-US" sz="1950" dirty="0" spc="-4" kern="0">
+              <a:t> Reactive</a:t>
+            </a:r>
+            <a:r>
+              <a:rPr lang="en-US" sz="1950" dirty="0" spc="-8" kern="0">
                 <a:solidFill>
                   <a:srgbClr val="C4C8D6"/>
                 </a:solidFill>
@@ -4601,29 +4656,7 @@
                 <a:ea typeface="Be Vietnam Pro" pitchFamily="34" charset="-122"/>
                 <a:cs typeface="Be Vietnam Pro" pitchFamily="34" charset="-120"/>
               </a:rPr>
-              <a:t> thiết</a:t>
-            </a:r>
-            <a:r>
-              <a:rPr lang="en-US" sz="1950" dirty="0" spc="-32" kern="0">
-                <a:solidFill>
-                  <a:srgbClr val="C4C8D6"/>
-                </a:solidFill>
-                <a:latin typeface="Be Vietnam Pro" pitchFamily="34" charset="0"/>
-                <a:ea typeface="Be Vietnam Pro" pitchFamily="34" charset="-122"/>
-                <a:cs typeface="Be Vietnam Pro" pitchFamily="34" charset="-120"/>
-              </a:rPr>
-              <a:t> kế</a:t>
-            </a:r>
-            <a:r>
-              <a:rPr lang="en-US" sz="1950" dirty="0" spc="-1" kern="0">
-                <a:solidFill>
-                  <a:srgbClr val="C4C8D6"/>
-                </a:solidFill>
-                <a:latin typeface="Be Vietnam Pro" pitchFamily="34" charset="0"/>
-                <a:ea typeface="Be Vietnam Pro" pitchFamily="34" charset="-122"/>
-                <a:cs typeface="Be Vietnam Pro" pitchFamily="34" charset="-120"/>
-              </a:rPr>
-              <a:t> mới.</a:t>
+              <a:t> Streams.</a:t>
             </a:r>
             <a:endParaRPr lang="en-US" sz="1950" dirty="0"/>
           </a:p>
@@ -5059,39 +5092,6 @@
               <a:buNone/>
             </a:pPr>
             <a:r>
-              <a:rPr lang="en-US" sz="2100" dirty="0" spc="2" kern="0">
-                <a:solidFill>
-                  <a:srgbClr val="F3EEE3"/>
-                </a:solidFill>
-                <a:latin typeface="Be Vietnam Pro" pitchFamily="34" charset="0"/>
-                <a:ea typeface="Be Vietnam Pro" pitchFamily="34" charset="-122"/>
-                <a:cs typeface="Be Vietnam Pro" pitchFamily="34" charset="-120"/>
-              </a:rPr>
-              <a:t>tính</a:t>
-            </a:r>
-            <a:r>
-              <a:rPr lang="en-US" sz="2100" dirty="0" spc="-12" kern="0">
-                <a:solidFill>
-                  <a:srgbClr val="F3EEE3"/>
-                </a:solidFill>
-                <a:latin typeface="Be Vietnam Pro" pitchFamily="34" charset="0"/>
-                <a:ea typeface="Be Vietnam Pro" pitchFamily="34" charset="-122"/>
-                <a:cs typeface="Be Vietnam Pro" pitchFamily="34" charset="-120"/>
-              </a:rPr>
-              <a:t> toán</a:t>
-            </a:r>
-            <a:r>
-              <a:rPr lang="en-US" sz="2100" dirty="0" spc="-4" kern="0">
-                <a:solidFill>
-                  <a:srgbClr val="F3EEE3"/>
-                </a:solidFill>
-                <a:latin typeface="Be Vietnam Pro" pitchFamily="34" charset="0"/>
-                <a:ea typeface="Be Vietnam Pro" pitchFamily="34" charset="-122"/>
-                <a:cs typeface="Be Vietnam Pro" pitchFamily="34" charset="-120"/>
-              </a:rPr>
-              <a:t> là</a:t>
-            </a:r>
-            <a:r>
               <a:rPr lang="en-US" sz="2100" dirty="0" spc="0" kern="0">
                 <a:solidFill>
                   <a:srgbClr val="F3EEE3"/>
@@ -5100,7 +5100,18 @@
                 <a:ea typeface="Be Vietnam Pro" pitchFamily="34" charset="-122"/>
                 <a:cs typeface="Be Vietnam Pro" pitchFamily="34" charset="-120"/>
               </a:rPr>
-              <a:t> tính</a:t>
+              <a:t>chia</a:t>
+            </a:r>
+            <a:r>
+              <a:rPr lang="en-US" sz="2100" dirty="0" spc="-2" kern="0">
+                <a:solidFill>
+                  <a:srgbClr val="F3EEE3"/>
+                </a:solidFill>
+                <a:latin typeface="Be Vietnam Pro" pitchFamily="34" charset="0"/>
+                <a:ea typeface="Be Vietnam Pro" pitchFamily="34" charset="-122"/>
+                <a:cs typeface="Be Vietnam Pro" pitchFamily="34" charset="-120"/>
+              </a:rPr>
+              <a:t> việc</a:t>
             </a:r>
             <a:r>
               <a:rPr lang="en-US" sz="2100" dirty="0" spc="-1" kern="0">
@@ -5111,18 +5122,7 @@
                 <a:ea typeface="Be Vietnam Pro" pitchFamily="34" charset="-122"/>
                 <a:cs typeface="Be Vietnam Pro" pitchFamily="34" charset="-120"/>
               </a:rPr>
-              <a:t> giá</a:t>
-            </a:r>
-            <a:r>
-              <a:rPr lang="en-US" sz="2100" dirty="0" spc="10" kern="0">
-                <a:solidFill>
-                  <a:srgbClr val="F3EEE3"/>
-                </a:solidFill>
-                <a:latin typeface="Be Vietnam Pro" pitchFamily="34" charset="0"/>
-                <a:ea typeface="Be Vietnam Pro" pitchFamily="34" charset="-122"/>
-                <a:cs typeface="Be Vietnam Pro" pitchFamily="34" charset="-120"/>
-              </a:rPr>
-              <a:t> trị</a:t>
+              <a:t> thành</a:t>
             </a:r>
             <a:r>
               <a:rPr lang="en-US" sz="2100" dirty="0" spc="-2" kern="0">
@@ -7309,7 +7309,7 @@
               <a:t>Giữ</a:t>
             </a:r>
             <a:r>
-              <a:rPr lang="en-US" sz="2550" dirty="0" spc="21" kern="0">
+              <a:rPr lang="en-US" sz="2550" dirty="0" spc="-11" kern="0">
                 <a:solidFill>
                   <a:srgbClr val="14161C"/>
                 </a:solidFill>
@@ -7317,7 +7317,7 @@
                 <a:ea typeface="Be Vietnam Pro" pitchFamily="34" charset="-122"/>
                 <a:cs typeface="Be Vietnam Pro" pitchFamily="34" charset="-120"/>
               </a:rPr>
-              <a:t> định</a:t>
+              <a:t> tên tám</a:t>
             </a:r>
             <a:r>
               <a:rPr lang="en-US" sz="2550" dirty="0" spc="0" kern="0">
@@ -7328,7 +7328,7 @@
                 <a:ea typeface="Be Vietnam Pro" pitchFamily="34" charset="-122"/>
                 <a:cs typeface="Be Vietnam Pro" pitchFamily="34" charset="-120"/>
               </a:rPr>
-              <a:t> nghĩa</a:t>
+              <a:t> mô hình</a:t>
             </a:r>
             <a:r>
               <a:rPr lang="en-US" sz="2550" dirty="0" spc="-1" kern="0">
@@ -7342,7 +7342,7 @@
               <a:t> của</a:t>
             </a:r>
             <a:r>
-              <a:rPr lang="en-US" sz="2550" dirty="0" spc="1" kern="0">
+              <a:rPr lang="en-US" sz="2550" dirty="0" spc="0" kern="0">
                 <a:solidFill>
                   <a:srgbClr val="14161C"/>
                 </a:solidFill>
@@ -7351,50 +7351,6 @@
                 <a:cs typeface="Be Vietnam Pro" pitchFamily="34" charset="-120"/>
               </a:rPr>
               <a:t> nguồn</a:t>
-            </a:r>
-            <a:r>
-              <a:rPr lang="en-US" sz="2550" dirty="0" spc="-1" kern="0">
-                <a:solidFill>
-                  <a:srgbClr val="14161C"/>
-                </a:solidFill>
-                <a:latin typeface="Be Vietnam Pro" pitchFamily="34" charset="0"/>
-                <a:ea typeface="Be Vietnam Pro" pitchFamily="34" charset="-122"/>
-                <a:cs typeface="Be Vietnam Pro" pitchFamily="34" charset="-120"/>
-              </a:rPr>
-              <a:t> cho</a:t>
-            </a:r>
-            <a:r>
-              <a:rPr lang="en-US" sz="2550" dirty="0" spc="-11" kern="0">
-                <a:solidFill>
-                  <a:srgbClr val="14161C"/>
-                </a:solidFill>
-                <a:latin typeface="Be Vietnam Pro" pitchFamily="34" charset="0"/>
-                <a:ea typeface="Be Vietnam Pro" pitchFamily="34" charset="-122"/>
-                <a:cs typeface="Be Vietnam Pro" pitchFamily="34" charset="-120"/>
-              </a:rPr>
-              <a:t> tám</a:t>
-            </a:r>
-            <a:r>
-              <a:rPr lang="en-US" sz="2550" dirty="0" spc="1" kern="0">
-                <a:solidFill>
-                  <a:srgbClr val="14161C"/>
-                </a:solidFill>
-                <a:latin typeface="Be Vietnam Pro" pitchFamily="34" charset="0"/>
-                <a:ea typeface="Be Vietnam Pro" pitchFamily="34" charset="-122"/>
-                <a:cs typeface="Be Vietnam Pro" pitchFamily="34" charset="-120"/>
-              </a:rPr>
-              <a:t> mô</a:t>
-            </a:r>
-            <a:r>
-              <a:rPr lang="en-US" sz="2550" dirty="0" spc="0" kern="0">
-                <a:solidFill>
-                  <a:srgbClr val="14161C"/>
-                </a:solidFill>
-                <a:latin typeface="Be Vietnam Pro" pitchFamily="34" charset="0"/>
-                <a:ea typeface="Be Vietnam Pro" pitchFamily="34" charset="-122"/>
-                <a:cs typeface="Be Vietnam Pro" pitchFamily="34" charset="-120"/>
-              </a:rPr>
-              <a:t> hình</a:t>
             </a:r>
             <a:endParaRPr lang="en-US" sz="2550" dirty="0"/>
           </a:p>
@@ -7537,7 +7493,7 @@
               <a:t> chiếu</a:t>
             </a:r>
             <a:r>
-              <a:rPr lang="en-US" sz="2550" dirty="0" spc="-3" kern="0">
+              <a:rPr lang="en-US" sz="2550" dirty="0" spc="-15" kern="0">
                 <a:solidFill>
                   <a:srgbClr val="14161C"/>
                 </a:solidFill>
@@ -7545,10 +7501,10 @@
                 <a:ea typeface="Be Vietnam Pro" pitchFamily="34" charset="-122"/>
                 <a:cs typeface="Be Vietnam Pro" pitchFamily="34" charset="-120"/>
               </a:rPr>
-              <a:t> bốn</a:t>
-            </a:r>
-            <a:r>
-              <a:rPr lang="en-US" sz="2550" dirty="0" spc="0" kern="0">
+              <a:t> với</a:t>
+            </a:r>
+            <a:r>
+              <a:rPr lang="en-US" sz="2550" dirty="0" spc="-12" kern="0">
                 <a:solidFill>
                   <a:srgbClr val="14161C"/>
                 </a:solidFill>
@@ -7556,10 +7512,10 @@
                 <a:ea typeface="Be Vietnam Pro" pitchFamily="34" charset="-122"/>
                 <a:cs typeface="Be Vietnam Pro" pitchFamily="34" charset="-120"/>
               </a:rPr>
-              <a:t> mô hình</a:t>
-            </a:r>
-            <a:r>
-              <a:rPr lang="en-US" sz="2550" dirty="0" spc="-15" kern="0">
+              <a:t> tài</a:t>
+            </a:r>
+            <a:r>
+              <a:rPr lang="en-US" sz="2550" dirty="0" spc="2" kern="0">
                 <a:solidFill>
                   <a:srgbClr val="14161C"/>
                 </a:solidFill>
@@ -7567,32 +7523,10 @@
                 <a:ea typeface="Be Vietnam Pro" pitchFamily="34" charset="-122"/>
                 <a:cs typeface="Be Vietnam Pro" pitchFamily="34" charset="-120"/>
               </a:rPr>
-              <a:t> với</a:t>
-            </a:r>
-            <a:r>
-              <a:rPr lang="en-US" sz="2550" dirty="0" spc="-12" kern="0">
-                <a:solidFill>
-                  <a:srgbClr val="14161C"/>
-                </a:solidFill>
-                <a:latin typeface="Be Vietnam Pro" pitchFamily="34" charset="0"/>
-                <a:ea typeface="Be Vietnam Pro" pitchFamily="34" charset="-122"/>
-                <a:cs typeface="Be Vietnam Pro" pitchFamily="34" charset="-120"/>
-              </a:rPr>
-              <a:t> tài</a:t>
-            </a:r>
-            <a:r>
-              <a:rPr lang="en-US" sz="2550" dirty="0" spc="1" kern="0">
-                <a:solidFill>
-                  <a:srgbClr val="14161C"/>
-                </a:solidFill>
-                <a:latin typeface="Be Vietnam Pro" pitchFamily="34" charset="0"/>
-                <a:ea typeface="Be Vietnam Pro" pitchFamily="34" charset="-122"/>
-                <a:cs typeface="Be Vietnam Pro" pitchFamily="34" charset="-120"/>
-              </a:rPr>
               <a:t> liệu</a:t>
             </a:r>
             <a:r>
-              <a:rPr lang="en-US" sz="2550" dirty="0" spc="-15" kern="0">
+              <a:rPr lang="en-US" sz="2550" dirty="0" spc="-16" kern="0">
                 <a:solidFill>
                   <a:srgbClr val="14161C"/>
                 </a:solidFill>
@@ -8702,6 +8636,17 @@
               <a:buNone/>
             </a:pPr>
             <a:r>
+              <a:rPr lang="en-US" sz="2550" dirty="0" spc="-1" kern="0">
+                <a:solidFill>
+                  <a:srgbClr val="F3EEE3"/>
+                </a:solidFill>
+                <a:latin typeface="Be Vietnam Pro" pitchFamily="34" charset="0"/>
+                <a:ea typeface="Be Vietnam Pro" pitchFamily="34" charset="-122"/>
+                <a:cs typeface="Be Vietnam Pro" pitchFamily="34" charset="-120"/>
+              </a:rPr>
+              <a:t>Lisp,</a:t>
+            </a:r>
+            <a:r>
               <a:rPr lang="en-US" sz="2550" dirty="0" spc="0" kern="0">
                 <a:solidFill>
                   <a:srgbClr val="F3EEE3"/>
@@ -8710,7 +8655,29 @@
                 <a:ea typeface="Be Vietnam Pro" pitchFamily="34" charset="-122"/>
                 <a:cs typeface="Be Vietnam Pro" pitchFamily="34" charset="-120"/>
               </a:rPr>
-              <a:t>Hàm</a:t>
+              <a:t> C++,</a:t>
+            </a:r>
+            <a:r>
+              <a:rPr lang="en-US" sz="2550" dirty="0" spc="8" kern="0">
+                <a:solidFill>
+                  <a:srgbClr val="F3EEE3"/>
+                </a:solidFill>
+                <a:latin typeface="Be Vietnam Pro" pitchFamily="34" charset="0"/>
+                <a:ea typeface="Be Vietnam Pro" pitchFamily="34" charset="-122"/>
+                <a:cs typeface="Be Vietnam Pro" pitchFamily="34" charset="-120"/>
+              </a:rPr>
+              <a:t> Python</a:t>
+            </a:r>
+            <a:r>
+              <a:rPr lang="en-US" sz="2550" dirty="0" spc="-1" kern="0">
+                <a:solidFill>
+                  <a:srgbClr val="F3EEE3"/>
+                </a:solidFill>
+                <a:latin typeface="Be Vietnam Pro" pitchFamily="34" charset="0"/>
+                <a:ea typeface="Be Vietnam Pro" pitchFamily="34" charset="-122"/>
+                <a:cs typeface="Be Vietnam Pro" pitchFamily="34" charset="-120"/>
+              </a:rPr>
+              <a:t> pha</a:t>
             </a:r>
             <a:r>
               <a:rPr lang="en-US" sz="2550" dirty="0" spc="1" kern="0">
@@ -8721,18 +8688,7 @@
                 <a:ea typeface="Be Vietnam Pro" pitchFamily="34" charset="-122"/>
                 <a:cs typeface="Be Vietnam Pro" pitchFamily="34" charset="-120"/>
               </a:rPr>
-              <a:t> là</a:t>
-            </a:r>
-            <a:r>
-              <a:rPr lang="en-US" sz="2550" dirty="0" spc="-5" kern="0">
-                <a:solidFill>
-                  <a:srgbClr val="F3EEE3"/>
-                </a:solidFill>
-                <a:latin typeface="Be Vietnam Pro" pitchFamily="34" charset="0"/>
-                <a:ea typeface="Be Vietnam Pro" pitchFamily="34" charset="-122"/>
-                <a:cs typeface="Be Vietnam Pro" pitchFamily="34" charset="-120"/>
-              </a:rPr>
-              <a:t> một</a:t>
+              <a:t> nhiều</a:t>
             </a:r>
             <a:r>
               <a:rPr lang="en-US" sz="2550" dirty="0" spc="0" kern="0">
@@ -8743,40 +8699,7 @@
                 <a:ea typeface="Be Vietnam Pro" pitchFamily="34" charset="-122"/>
                 <a:cs typeface="Be Vietnam Pro" pitchFamily="34" charset="-120"/>
               </a:rPr>
-              <a:t> dạng phổ biến</a:t>
-            </a:r>
-            <a:r>
-              <a:rPr lang="en-US" sz="2550" dirty="0" spc="-2" kern="0">
-                <a:solidFill>
-                  <a:srgbClr val="F3EEE3"/>
-                </a:solidFill>
-                <a:latin typeface="Be Vietnam Pro" pitchFamily="34" charset="0"/>
-                <a:ea typeface="Be Vietnam Pro" pitchFamily="34" charset="-122"/>
-                <a:cs typeface="Be Vietnam Pro" pitchFamily="34" charset="-120"/>
-              </a:rPr>
-              <a:t> của</a:t>
-            </a:r>
-            <a:r>
-              <a:rPr lang="en-US" sz="2550" dirty="0" spc="0" kern="0">
-                <a:solidFill>
-                  <a:srgbClr val="F3EEE3"/>
-                </a:solidFill>
-                <a:latin typeface="Be Vietnam Pro" pitchFamily="34" charset="0"/>
-                <a:ea typeface="Be Vietnam Pro" pitchFamily="34" charset="-122"/>
-                <a:cs typeface="Be Vietnam Pro" pitchFamily="34" charset="-120"/>
-              </a:rPr>
-              <a:t> khai</a:t>
-            </a:r>
-            <a:r>
-              <a:rPr lang="en-US" sz="2550" dirty="0" spc="-2" kern="0">
-                <a:solidFill>
-                  <a:srgbClr val="F3EEE3"/>
-                </a:solidFill>
-                <a:latin typeface="Be Vietnam Pro" pitchFamily="34" charset="0"/>
-                <a:ea typeface="Be Vietnam Pro" pitchFamily="34" charset="-122"/>
-                <a:cs typeface="Be Vietnam Pro" pitchFamily="34" charset="-120"/>
-              </a:rPr>
-              <a:t> báo.</a:t>
+              <a:t> lối.</a:t>
             </a:r>
             <a:endParaRPr lang="en-US" sz="2550" dirty="0"/>
           </a:p>
@@ -8961,7 +8884,7 @@
               <a:buNone/>
             </a:pPr>
             <a:r>
-              <a:rPr lang="en-US" sz="2400" dirty="0" spc="-2" kern="0">
+              <a:rPr lang="en-US" sz="2400" dirty="0" spc="0" kern="0">
                 <a:solidFill>
                   <a:srgbClr val="C4C8D6"/>
                 </a:solidFill>
@@ -8969,10 +8892,10 @@
                 <a:ea typeface="Be Vietnam Pro" pitchFamily="34" charset="-122"/>
                 <a:cs typeface="Be Vietnam Pro" pitchFamily="34" charset="-120"/>
               </a:rPr>
-              <a:t>Chuỗi</a:t>
-            </a:r>
-            <a:r>
-              <a:rPr lang="en-US" sz="2400" dirty="0" spc="7" kern="0">
+              <a:t>Danh</a:t>
+            </a:r>
+            <a:r>
+              <a:rPr lang="en-US" sz="2400" dirty="0" spc="-6" kern="0">
                 <a:solidFill>
                   <a:srgbClr val="C4C8D6"/>
                 </a:solidFill>
@@ -8980,7 +8903,40 @@
                 <a:ea typeface="Be Vietnam Pro" pitchFamily="34" charset="-122"/>
                 <a:cs typeface="Be Vietnam Pro" pitchFamily="34" charset="-120"/>
               </a:rPr>
-              <a:t> bước</a:t>
+              <a:t> sách</a:t>
+            </a:r>
+            <a:r>
+              <a:rPr lang="en-US" sz="2400" dirty="0" spc="0" kern="0">
+                <a:solidFill>
+                  <a:srgbClr val="C4C8D6"/>
+                </a:solidFill>
+                <a:latin typeface="Be Vietnam Pro" pitchFamily="34" charset="0"/>
+                <a:ea typeface="Be Vietnam Pro" pitchFamily="34" charset="-122"/>
+                <a:cs typeface="Be Vietnam Pro" pitchFamily="34" charset="-120"/>
+              </a:rPr>
+              <a:t> lệnh</a:t>
+            </a:r>
+            <a:r>
+              <a:rPr lang="en-US" sz="2400" dirty="0" spc="1" kern="0">
+                <a:solidFill>
+                  <a:srgbClr val="C4C8D6"/>
+                </a:solidFill>
+                <a:latin typeface="Be Vietnam Pro" pitchFamily="34" charset="0"/>
+                <a:ea typeface="Be Vietnam Pro" pitchFamily="34" charset="-122"/>
+                <a:cs typeface="Be Vietnam Pro" pitchFamily="34" charset="-120"/>
+              </a:rPr>
+              <a:t> bảo</a:t>
+            </a:r>
+            <a:r>
+              <a:rPr lang="en-US" sz="2400" dirty="0" spc="-6" kern="0">
+                <a:solidFill>
+                  <a:srgbClr val="C4C8D6"/>
+                </a:solidFill>
+                <a:latin typeface="Be Vietnam Pro" pitchFamily="34" charset="0"/>
+                <a:ea typeface="Be Vietnam Pro" pitchFamily="34" charset="-122"/>
+                <a:cs typeface="Be Vietnam Pro" pitchFamily="34" charset="-120"/>
+              </a:rPr>
+              <a:t> máy</a:t>
             </a:r>
             <a:r>
               <a:rPr lang="en-US" sz="2400" dirty="0" spc="3" kern="0">
@@ -8994,7 +8950,7 @@
               <a:t> làm</a:t>
             </a:r>
             <a:r>
-              <a:rPr lang="en-US" sz="2400" dirty="0" spc="-6" kern="0">
+              <a:rPr lang="en-US" sz="2400" dirty="0" spc="1" kern="0">
                 <a:solidFill>
                   <a:srgbClr val="C4C8D6"/>
                 </a:solidFill>
@@ -9002,62 +8958,7 @@
                 <a:ea typeface="Be Vietnam Pro" pitchFamily="34" charset="-122"/>
                 <a:cs typeface="Be Vietnam Pro" pitchFamily="34" charset="-120"/>
               </a:rPr>
-              <a:t> thay</a:t>
-            </a:r>
-            <a:r>
-              <a:rPr lang="en-US" sz="2400" dirty="0" spc="12" kern="0">
-                <a:solidFill>
-                  <a:srgbClr val="C4C8D6"/>
-                </a:solidFill>
-                <a:latin typeface="Be Vietnam Pro" pitchFamily="34" charset="0"/>
-                <a:ea typeface="Be Vietnam Pro" pitchFamily="34" charset="-122"/>
-                <a:cs typeface="Be Vietnam Pro" pitchFamily="34" charset="-120"/>
-              </a:rPr>
-              <a:t> đổi</a:t>
-            </a:r>
-            <a:r>
-              <a:rPr lang="en-US" sz="2400" dirty="0" spc="-13" kern="0">
-                <a:solidFill>
-                  <a:srgbClr val="C4C8D6"/>
-                </a:solidFill>
-                <a:latin typeface="Be Vietnam Pro" pitchFamily="34" charset="0"/>
-                <a:ea typeface="Be Vietnam Pro" pitchFamily="34" charset="-122"/>
-                <a:cs typeface="Be Vietnam Pro" pitchFamily="34" charset="-120"/>
-              </a:rPr>
-              <a:t> trạng</a:t>
-            </a:r>
-            <a:r>
-              <a:rPr lang="en-US" sz="2400" dirty="0" spc="1" kern="0">
-                <a:solidFill>
-                  <a:srgbClr val="C4C8D6"/>
-                </a:solidFill>
-                <a:latin typeface="Be Vietnam Pro" pitchFamily="34" charset="0"/>
-                <a:ea typeface="Be Vietnam Pro" pitchFamily="34" charset="-122"/>
-                <a:cs typeface="Be Vietnam Pro" pitchFamily="34" charset="-120"/>
-              </a:rPr>
-              <a:t> thái</a:t>
-            </a:r>
-            <a:r>
-              <a:rPr lang="en-US" sz="2400" dirty="0" spc="5" kern="0">
-                <a:solidFill>
-                  <a:srgbClr val="C4C8D6"/>
-                </a:solidFill>
-                <a:latin typeface="Be Vietnam Pro" pitchFamily="34" charset="0"/>
-                <a:ea typeface="Be Vietnam Pro" pitchFamily="34" charset="-122"/>
-                <a:cs typeface="Be Vietnam Pro" pitchFamily="34" charset="-120"/>
-              </a:rPr>
-              <a:t> chương</a:t>
-            </a:r>
-            <a:r>
-              <a:rPr lang="en-US" sz="2400" dirty="0" spc="8" kern="0">
-                <a:solidFill>
-                  <a:srgbClr val="C4C8D6"/>
-                </a:solidFill>
-                <a:latin typeface="Be Vietnam Pro" pitchFamily="34" charset="0"/>
-                <a:ea typeface="Be Vietnam Pro" pitchFamily="34" charset="-122"/>
-                <a:cs typeface="Be Vietnam Pro" pitchFamily="34" charset="-120"/>
-              </a:rPr>
-              <a:t> trình.</a:t>
+              <a:t> gì.</a:t>
             </a:r>
             <a:endParaRPr lang="en-US" sz="2400" dirty="0"/>
           </a:p>
@@ -9088,7 +8989,7 @@
               <a:buNone/>
             </a:pPr>
             <a:r>
-              <a:rPr lang="en-US" sz="1950" b="1" dirty="0" spc="-6" kern="0">
+              <a:rPr lang="en-US" sz="1950" b="1" dirty="0" spc="1" kern="0">
                 <a:solidFill>
                   <a:srgbClr val="7C93FF"/>
                 </a:solidFill>
@@ -9096,7 +8997,29 @@
                 <a:ea typeface="Be Vietnam Pro" pitchFamily="34" charset="-122"/>
                 <a:cs typeface="Be Vietnam Pro" pitchFamily="34" charset="-120"/>
               </a:rPr>
-              <a:t>Nguồn</a:t>
+              <a:t>Python</a:t>
+            </a:r>
+            <a:r>
+              <a:rPr lang="en-US" sz="1950" b="1" dirty="0" spc="-5" kern="0">
+                <a:solidFill>
+                  <a:srgbClr val="7C93FF"/>
+                </a:solidFill>
+                <a:latin typeface="Be Vietnam Pro" pitchFamily="34" charset="0"/>
+                <a:ea typeface="Be Vietnam Pro" pitchFamily="34" charset="-122"/>
+                <a:cs typeface="Be Vietnam Pro" pitchFamily="34" charset="-120"/>
+              </a:rPr>
+              <a:t> gọi</a:t>
+            </a:r>
+            <a:r>
+              <a:rPr lang="en-US" sz="1950" b="1" dirty="0" spc="-3" kern="0">
+                <a:solidFill>
+                  <a:srgbClr val="7C93FF"/>
+                </a:solidFill>
+                <a:latin typeface="Be Vietnam Pro" pitchFamily="34" charset="0"/>
+                <a:ea typeface="Be Vietnam Pro" pitchFamily="34" charset="-122"/>
+                <a:cs typeface="Be Vietnam Pro" pitchFamily="34" charset="-120"/>
+              </a:rPr>
+              <a:t> là</a:t>
             </a:r>
             <a:r>
               <a:rPr lang="en-US" sz="1950" b="1" dirty="0" spc="-1" kern="0">
@@ -9107,10 +9030,10 @@
                 <a:ea typeface="Be Vietnam Pro" pitchFamily="34" charset="-122"/>
                 <a:cs typeface="Be Vietnam Pro" pitchFamily="34" charset="-120"/>
               </a:rPr>
-              <a:t> nêu:</a:t>
-            </a:r>
-            <a:r>
-              <a:rPr lang="en-US" sz="1950" b="1" dirty="0" spc="-2" kern="0">
+              <a:t> thủ</a:t>
+            </a:r>
+            <a:r>
+              <a:rPr lang="en-US" sz="1950" b="1" dirty="0" spc="0" kern="0">
                 <a:solidFill>
                   <a:srgbClr val="7C93FF"/>
                 </a:solidFill>
@@ -9118,10 +9041,10 @@
                 <a:ea typeface="Be Vietnam Pro" pitchFamily="34" charset="-122"/>
                 <a:cs typeface="Be Vietnam Pro" pitchFamily="34" charset="-120"/>
               </a:rPr>
-              <a:t> C,</a:t>
-            </a:r>
-            <a:r>
-              <a:rPr lang="en-US" sz="1950" b="1" dirty="0" spc="-3" kern="0">
+              <a:t> tục</a:t>
+            </a:r>
+            <a:r>
+              <a:rPr lang="en-US" sz="1950" b="1" dirty="0" spc="-9" kern="0">
                 <a:solidFill>
                   <a:srgbClr val="7C93FF"/>
                 </a:solidFill>
@@ -9129,29 +9052,7 @@
                 <a:ea typeface="Be Vietnam Pro" pitchFamily="34" charset="-122"/>
                 <a:cs typeface="Be Vietnam Pro" pitchFamily="34" charset="-120"/>
               </a:rPr>
-              <a:t> C++,</a:t>
-            </a:r>
-            <a:r>
-              <a:rPr lang="en-US" sz="1950" b="1" dirty="0" spc="-18" kern="0">
-                <a:solidFill>
-                  <a:srgbClr val="7C93FF"/>
-                </a:solidFill>
-                <a:latin typeface="Be Vietnam Pro" pitchFamily="34" charset="0"/>
-                <a:ea typeface="Be Vietnam Pro" pitchFamily="34" charset="-122"/>
-                <a:cs typeface="Be Vietnam Pro" pitchFamily="34" charset="-120"/>
-              </a:rPr>
-              <a:t> Java,</a:t>
-            </a:r>
-            <a:r>
-              <a:rPr lang="en-US" sz="1950" b="1" dirty="0" spc="1" kern="0">
-                <a:solidFill>
-                  <a:srgbClr val="7C93FF"/>
-                </a:solidFill>
-                <a:latin typeface="Be Vietnam Pro" pitchFamily="34" charset="0"/>
-                <a:ea typeface="Be Vietnam Pro" pitchFamily="34" charset="-122"/>
-                <a:cs typeface="Be Vietnam Pro" pitchFamily="34" charset="-120"/>
-              </a:rPr>
-              <a:t> Python</a:t>
+              <a:t> (procedural)</a:t>
             </a:r>
             <a:endParaRPr lang="en-US" sz="1950" dirty="0"/>
           </a:p>
@@ -9344,10 +9245,10 @@
                 <a:ea typeface="Be Vietnam Pro" pitchFamily="34" charset="-122"/>
                 <a:cs typeface="Be Vietnam Pro" pitchFamily="34" charset="-120"/>
               </a:rPr>
-              <a:t> logic</a:t>
-            </a:r>
-            <a:r>
-              <a:rPr lang="en-US" sz="2400" dirty="0" spc="-16" kern="0">
+              <a:t> bài</a:t>
+            </a:r>
+            <a:r>
+              <a:rPr lang="en-US" sz="2400" dirty="0" spc="-8" kern="0">
                 <a:solidFill>
                   <a:srgbClr val="C4C8D6"/>
                 </a:solidFill>
@@ -9355,10 +9256,10 @@
                 <a:ea typeface="Be Vietnam Pro" pitchFamily="34" charset="-122"/>
                 <a:cs typeface="Be Vietnam Pro" pitchFamily="34" charset="-120"/>
               </a:rPr>
-              <a:t> và</a:t>
-            </a:r>
-            <a:r>
-              <a:rPr lang="en-US" sz="2400" dirty="0" spc="7" kern="0">
+              <a:t> toán,</a:t>
+            </a:r>
+            <a:r>
+              <a:rPr lang="en-US" sz="2400" dirty="0" spc="0" kern="0">
                 <a:solidFill>
                   <a:srgbClr val="C4C8D6"/>
                 </a:solidFill>
@@ -9366,7 +9267,7 @@
                 <a:ea typeface="Be Vietnam Pro" pitchFamily="34" charset="-122"/>
                 <a:cs typeface="Be Vietnam Pro" pitchFamily="34" charset="-120"/>
               </a:rPr>
-              <a:t> chức</a:t>
+              <a:t> cài</a:t>
             </a:r>
             <a:r>
               <a:rPr lang="en-US" sz="2400" dirty="0" spc="3" kern="0">
@@ -9377,7 +9278,7 @@
                 <a:ea typeface="Be Vietnam Pro" pitchFamily="34" charset="-122"/>
                 <a:cs typeface="Be Vietnam Pro" pitchFamily="34" charset="-120"/>
               </a:rPr>
-              <a:t> năng,</a:t>
+              <a:t> đặt tự</a:t>
             </a:r>
             <a:r>
               <a:rPr lang="en-US" sz="2400" dirty="0" spc="0" kern="0">
@@ -9388,40 +9289,7 @@
                 <a:ea typeface="Be Vietnam Pro" pitchFamily="34" charset="-122"/>
                 <a:cs typeface="Be Vietnam Pro" pitchFamily="34" charset="-120"/>
               </a:rPr>
-              <a:t> không nêu</a:t>
-            </a:r>
-            <a:r>
-              <a:rPr lang="en-US" sz="2400" dirty="0" spc="1" kern="0">
-                <a:solidFill>
-                  <a:srgbClr val="C4C8D6"/>
-                </a:solidFill>
-                <a:latin typeface="Be Vietnam Pro" pitchFamily="34" charset="0"/>
-                <a:ea typeface="Be Vietnam Pro" pitchFamily="34" charset="-122"/>
-                <a:cs typeface="Be Vietnam Pro" pitchFamily="34" charset="-120"/>
-              </a:rPr>
-              <a:t> luồng</a:t>
-            </a:r>
-            <a:r>
-              <a:rPr lang="en-US" sz="2400" dirty="0" spc="18" kern="0">
-                <a:solidFill>
-                  <a:srgbClr val="C4C8D6"/>
-                </a:solidFill>
-                <a:latin typeface="Be Vietnam Pro" pitchFamily="34" charset="0"/>
-                <a:ea typeface="Be Vietnam Pro" pitchFamily="34" charset="-122"/>
-                <a:cs typeface="Be Vietnam Pro" pitchFamily="34" charset="-120"/>
-              </a:rPr>
-              <a:t> điều</a:t>
-            </a:r>
-            <a:r>
-              <a:rPr lang="en-US" sz="2400" dirty="0" spc="-2" kern="0">
-                <a:solidFill>
-                  <a:srgbClr val="C4C8D6"/>
-                </a:solidFill>
-                <a:latin typeface="Be Vietnam Pro" pitchFamily="34" charset="0"/>
-                <a:ea typeface="Be Vietnam Pro" pitchFamily="34" charset="-122"/>
-                <a:cs typeface="Be Vietnam Pro" pitchFamily="34" charset="-120"/>
-              </a:rPr>
-              <a:t> khiển.</a:t>
+              <a:t> chọn cách giải.</a:t>
             </a:r>
             <a:endParaRPr lang="en-US" sz="2400" dirty="0"/>
           </a:p>
@@ -9697,10 +9565,10 @@
                 <a:ea typeface="Be Vietnam Pro" pitchFamily="34" charset="-122"/>
                 <a:cs typeface="Be Vietnam Pro" pitchFamily="34" charset="-120"/>
               </a:rPr>
-              <a:t>Tính</a:t>
-            </a:r>
-            <a:r>
-              <a:rPr lang="en-US" sz="2400" dirty="0" spc="-9" kern="0">
+              <a:t>Chia</a:t>
+            </a:r>
+            <a:r>
+              <a:rPr lang="en-US" sz="2400" dirty="0" spc="-5" kern="0">
                 <a:solidFill>
                   <a:srgbClr val="C4C8D6"/>
                 </a:solidFill>
@@ -9708,7 +9576,7 @@
                 <a:ea typeface="Be Vietnam Pro" pitchFamily="34" charset="-122"/>
                 <a:cs typeface="Be Vietnam Pro" pitchFamily="34" charset="-120"/>
               </a:rPr>
-              <a:t> toán</a:t>
+              <a:t> việc</a:t>
             </a:r>
             <a:r>
               <a:rPr lang="en-US" sz="2400" dirty="0" spc="1" kern="0">
@@ -9719,7 +9587,7 @@
                 <a:ea typeface="Be Vietnam Pro" pitchFamily="34" charset="-122"/>
                 <a:cs typeface="Be Vietnam Pro" pitchFamily="34" charset="-120"/>
               </a:rPr>
-              <a:t> là tính</a:t>
+              <a:t> thành</a:t>
             </a:r>
             <a:r>
               <a:rPr lang="en-US" sz="2400" dirty="0" spc="3" kern="0">
@@ -9730,10 +9598,10 @@
                 <a:ea typeface="Be Vietnam Pro" pitchFamily="34" charset="-122"/>
                 <a:cs typeface="Be Vietnam Pro" pitchFamily="34" charset="-120"/>
               </a:rPr>
-              <a:t> hàm</a:t>
-            </a:r>
-            <a:r>
-              <a:rPr lang="en-US" sz="2400" dirty="0" spc="-10" kern="0">
+              <a:t> hàm:</a:t>
+            </a:r>
+            <a:r>
+              <a:rPr lang="en-US" sz="2400" dirty="0" spc="1" kern="0">
                 <a:solidFill>
                   <a:srgbClr val="C4C8D6"/>
                 </a:solidFill>
@@ -9741,10 +9609,10 @@
                 <a:ea typeface="Be Vietnam Pro" pitchFamily="34" charset="-122"/>
                 <a:cs typeface="Be Vietnam Pro" pitchFamily="34" charset="-120"/>
               </a:rPr>
-              <a:t> toán</a:t>
-            </a:r>
-            <a:r>
-              <a:rPr lang="en-US" sz="2400" dirty="0" spc="-2" kern="0">
+              <a:t> nhận</a:t>
+            </a:r>
+            <a:r>
+              <a:rPr lang="en-US" sz="2400" dirty="0" spc="-8" kern="0">
                 <a:solidFill>
                   <a:srgbClr val="C4C8D6"/>
                 </a:solidFill>
@@ -9752,10 +9620,10 @@
                 <a:ea typeface="Be Vietnam Pro" pitchFamily="34" charset="-122"/>
                 <a:cs typeface="Be Vietnam Pro" pitchFamily="34" charset="-120"/>
               </a:rPr>
-              <a:t> học,</a:t>
-            </a:r>
-            <a:r>
-              <a:rPr lang="en-US" sz="2400" dirty="0" spc="22" kern="0">
+              <a:t> vào,</a:t>
+            </a:r>
+            <a:r>
+              <a:rPr lang="en-US" sz="2400" dirty="0" spc="-21" kern="0">
                 <a:solidFill>
                   <a:srgbClr val="C4C8D6"/>
                 </a:solidFill>
@@ -9763,10 +9631,10 @@
                 <a:ea typeface="Be Vietnam Pro" pitchFamily="34" charset="-122"/>
                 <a:cs typeface="Be Vietnam Pro" pitchFamily="34" charset="-120"/>
               </a:rPr>
-              <a:t> ưu</a:t>
-            </a:r>
-            <a:r>
-              <a:rPr lang="en-US" sz="2400" dirty="0" spc="0" kern="0">
+              <a:t> trả</a:t>
+            </a:r>
+            <a:r>
+              <a:rPr lang="en-US" sz="2400" dirty="0" spc="-22" kern="0">
                 <a:solidFill>
                   <a:srgbClr val="C4C8D6"/>
                 </a:solidFill>
@@ -9774,51 +9642,7 @@
                 <a:ea typeface="Be Vietnam Pro" pitchFamily="34" charset="-122"/>
                 <a:cs typeface="Be Vietnam Pro" pitchFamily="34" charset="-120"/>
               </a:rPr>
-              <a:t> tiên</a:t>
-            </a:r>
-            <a:r>
-              <a:rPr lang="en-US" sz="2400" dirty="0" spc="3" kern="0">
-                <a:solidFill>
-                  <a:srgbClr val="C4C8D6"/>
-                </a:solidFill>
-                <a:latin typeface="Be Vietnam Pro" pitchFamily="34" charset="0"/>
-                <a:ea typeface="Be Vietnam Pro" pitchFamily="34" charset="-122"/>
-                <a:cs typeface="Be Vietnam Pro" pitchFamily="34" charset="-120"/>
-              </a:rPr>
-              <a:t> dữ</a:t>
-            </a:r>
-            <a:r>
-              <a:rPr lang="en-US" sz="2400" dirty="0" spc="-1" kern="0">
-                <a:solidFill>
-                  <a:srgbClr val="C4C8D6"/>
-                </a:solidFill>
-                <a:latin typeface="Be Vietnam Pro" pitchFamily="34" charset="0"/>
-                <a:ea typeface="Be Vietnam Pro" pitchFamily="34" charset="-122"/>
-                <a:cs typeface="Be Vietnam Pro" pitchFamily="34" charset="-120"/>
-              </a:rPr>
-              <a:t> liệu</a:t>
-            </a:r>
-            <a:r>
-              <a:rPr lang="en-US" sz="2400" dirty="0" spc="-12" kern="0">
-                <a:solidFill>
-                  <a:srgbClr val="C4C8D6"/>
-                </a:solidFill>
-                <a:latin typeface="Be Vietnam Pro" pitchFamily="34" charset="0"/>
-                <a:ea typeface="Be Vietnam Pro" pitchFamily="34" charset="-122"/>
-                <a:cs typeface="Be Vietnam Pro" pitchFamily="34" charset="-120"/>
-              </a:rPr>
-              <a:t> bất</a:t>
-            </a:r>
-            <a:r>
-              <a:rPr lang="en-US" sz="2400" dirty="0" spc="-1" kern="0">
-                <a:solidFill>
-                  <a:srgbClr val="C4C8D6"/>
-                </a:solidFill>
-                <a:latin typeface="Be Vietnam Pro" pitchFamily="34" charset="0"/>
-                <a:ea typeface="Be Vietnam Pro" pitchFamily="34" charset="-122"/>
-                <a:cs typeface="Be Vietnam Pro" pitchFamily="34" charset="-120"/>
-              </a:rPr>
-              <a:t> biến.</a:t>
+              <a:t> ra.</a:t>
             </a:r>
             <a:endParaRPr lang="en-US" sz="2400" dirty="0"/>
           </a:p>
@@ -9849,6 +9673,28 @@
               <a:buNone/>
             </a:pPr>
             <a:r>
+              <a:rPr lang="en-US" sz="1950" b="1" dirty="0" spc="1" kern="0">
+                <a:solidFill>
+                  <a:srgbClr val="7C93FF"/>
+                </a:solidFill>
+                <a:latin typeface="Be Vietnam Pro" pitchFamily="34" charset="0"/>
+                <a:ea typeface="Be Vietnam Pro" pitchFamily="34" charset="-122"/>
+                <a:cs typeface="Be Vietnam Pro" pitchFamily="34" charset="-120"/>
+              </a:rPr>
+              <a:t>Python</a:t>
+            </a:r>
+            <a:r>
+              <a:rPr lang="en-US" sz="1950" b="1" dirty="0" spc="-1" kern="0">
+                <a:solidFill>
+                  <a:srgbClr val="7C93FF"/>
+                </a:solidFill>
+                <a:latin typeface="Be Vietnam Pro" pitchFamily="34" charset="0"/>
+                <a:ea typeface="Be Vietnam Pro" pitchFamily="34" charset="-122"/>
+                <a:cs typeface="Be Vietnam Pro" pitchFamily="34" charset="-120"/>
+              </a:rPr>
+              <a:t> nêu:</a:t>
+            </a:r>
+            <a:r>
               <a:rPr lang="en-US" sz="1950" b="1" dirty="0" spc="-6" kern="0">
                 <a:solidFill>
                   <a:srgbClr val="7C93FF"/>
@@ -9857,7 +9703,7 @@
                 <a:ea typeface="Be Vietnam Pro" pitchFamily="34" charset="-122"/>
                 <a:cs typeface="Be Vietnam Pro" pitchFamily="34" charset="-120"/>
               </a:rPr>
-              <a:t>Nguồn</a:t>
+              <a:t> họ</a:t>
             </a:r>
             <a:r>
               <a:rPr lang="en-US" sz="1950" b="1" dirty="0" spc="-1" kern="0">
@@ -9868,10 +9714,10 @@
                 <a:ea typeface="Be Vietnam Pro" pitchFamily="34" charset="-122"/>
                 <a:cs typeface="Be Vietnam Pro" pitchFamily="34" charset="-120"/>
               </a:rPr>
-              <a:t> nêu:</a:t>
-            </a:r>
-            <a:r>
-              <a:rPr lang="en-US" sz="1950" b="1" dirty="0" spc="-12" kern="0">
+              <a:t> ML,</a:t>
+            </a:r>
+            <a:r>
+              <a:rPr lang="en-US" sz="1950" b="1" dirty="0" spc="-14" kern="0">
                 <a:solidFill>
                   <a:srgbClr val="7C93FF"/>
                 </a:solidFill>
@@ -9879,29 +9725,7 @@
                 <a:ea typeface="Be Vietnam Pro" pitchFamily="34" charset="-122"/>
                 <a:cs typeface="Be Vietnam Pro" pitchFamily="34" charset="-120"/>
               </a:rPr>
-              <a:t> Haskell,</a:t>
-            </a:r>
-            <a:r>
-              <a:rPr lang="en-US" sz="1950" b="1" dirty="0" spc="0" kern="0">
-                <a:solidFill>
-                  <a:srgbClr val="7C93FF"/>
-                </a:solidFill>
-                <a:latin typeface="Be Vietnam Pro" pitchFamily="34" charset="0"/>
-                <a:ea typeface="Be Vietnam Pro" pitchFamily="34" charset="-122"/>
-                <a:cs typeface="Be Vietnam Pro" pitchFamily="34" charset="-120"/>
-              </a:rPr>
-              <a:t> Lisp,</a:t>
-            </a:r>
-            <a:r>
-              <a:rPr lang="en-US" sz="1950" b="1" dirty="0" spc="-3" kern="0">
-                <a:solidFill>
-                  <a:srgbClr val="7C93FF"/>
-                </a:solidFill>
-                <a:latin typeface="Be Vietnam Pro" pitchFamily="34" charset="0"/>
-                <a:ea typeface="Be Vietnam Pro" pitchFamily="34" charset="-122"/>
-                <a:cs typeface="Be Vietnam Pro" pitchFamily="34" charset="-120"/>
-              </a:rPr>
-              <a:t> Erlang</a:t>
+              <a:t> Haskell</a:t>
             </a:r>
             <a:endParaRPr lang="en-US" sz="1950" dirty="0"/>
           </a:p>
@@ -10536,10 +10360,10 @@
                 <a:ea typeface="Be Vietnam Pro" pitchFamily="34" charset="-122"/>
                 <a:cs typeface="Be Vietnam Pro" pitchFamily="34" charset="-120"/>
               </a:rPr>
-              <a:t> là</a:t>
-            </a:r>
-            <a:r>
-              <a:rPr lang="en-US" sz="2550" dirty="0" spc="-5" kern="0">
+              <a:t> mở</a:t>
+            </a:r>
+            <a:r>
+              <a:rPr lang="en-US" sz="2550" dirty="0" spc="-21" kern="0">
                 <a:solidFill>
                   <a:srgbClr val="14161C"/>
                 </a:solidFill>
@@ -10547,10 +10371,10 @@
                 <a:ea typeface="Be Vietnam Pro" pitchFamily="34" charset="-122"/>
                 <a:cs typeface="Be Vietnam Pro" pitchFamily="34" charset="-120"/>
               </a:rPr>
-              <a:t> một</a:t>
-            </a:r>
-            <a:r>
-              <a:rPr lang="en-US" sz="2550" dirty="0" spc="-17" kern="0">
+              <a:t> rộng</a:t>
+            </a:r>
+            <a:r>
+              <a:rPr lang="en-US" sz="2550" dirty="0" spc="-22" kern="0">
                 <a:solidFill>
                   <a:srgbClr val="14161C"/>
                 </a:solidFill>
@@ -10558,10 +10382,10 @@
                 <a:ea typeface="Be Vietnam Pro" pitchFamily="34" charset="-122"/>
                 <a:cs typeface="Be Vietnam Pro" pitchFamily="34" charset="-120"/>
               </a:rPr>
-              <a:t> trong</a:t>
-            </a:r>
-            <a:r>
-              <a:rPr lang="en-US" sz="2550" dirty="0" spc="16" kern="0">
+              <a:t> Java</a:t>
+            </a:r>
+            <a:r>
+              <a:rPr lang="en-US" sz="2550" dirty="0" spc="-2" kern="0">
                 <a:solidFill>
                   <a:srgbClr val="14161C"/>
                 </a:solidFill>
@@ -10569,7 +10393,18 @@
                 <a:ea typeface="Be Vietnam Pro" pitchFamily="34" charset="-122"/>
                 <a:cs typeface="Be Vietnam Pro" pitchFamily="34" charset="-120"/>
               </a:rPr>
-              <a:t> những</a:t>
+              <a:t> theo</a:t>
+            </a:r>
+            <a:r>
+              <a:rPr lang="en-US" sz="2550" dirty="0" spc="5" kern="0">
+                <a:solidFill>
+                  <a:srgbClr val="14161C"/>
+                </a:solidFill>
+                <a:latin typeface="Be Vietnam Pro" pitchFamily="34" charset="0"/>
+                <a:ea typeface="Be Vietnam Pro" pitchFamily="34" charset="-122"/>
+                <a:cs typeface="Be Vietnam Pro" pitchFamily="34" charset="-120"/>
+              </a:rPr>
+              <a:t> hướng</a:t>
             </a:r>
             <a:r>
               <a:rPr lang="en-US" sz="2550" dirty="0" spc="1" kern="0">
@@ -10580,84 +10415,7 @@
                 <a:ea typeface="Be Vietnam Pro" pitchFamily="34" charset="-122"/>
                 <a:cs typeface="Be Vietnam Pro" pitchFamily="34" charset="-120"/>
               </a:rPr>
-              <a:t> khung</a:t>
-            </a:r>
-            <a:r>
-              <a:rPr lang="en-US" sz="2550" dirty="0" spc="-25" kern="0">
-                <a:solidFill>
-                  <a:srgbClr val="14161C"/>
-                </a:solidFill>
-                <a:latin typeface="Be Vietnam Pro" pitchFamily="34" charset="0"/>
-                <a:ea typeface="Be Vietnam Pro" pitchFamily="34" charset="-122"/>
-                <a:cs typeface="Be Vietnam Pro" pitchFamily="34" charset="-120"/>
-              </a:rPr>
-              <a:t> AOP</a:t>
-            </a:r>
-            <a:r>
-              <a:rPr lang="en-US" sz="2550" dirty="0" spc="-1" kern="0">
-                <a:solidFill>
-                  <a:srgbClr val="14161C"/>
-                </a:solidFill>
-                <a:latin typeface="Be Vietnam Pro" pitchFamily="34" charset="0"/>
-                <a:ea typeface="Be Vietnam Pro" pitchFamily="34" charset="-122"/>
-                <a:cs typeface="Be Vietnam Pro" pitchFamily="34" charset="-120"/>
-              </a:rPr>
-              <a:t> nổi</a:t>
-            </a:r>
-            <a:r>
-              <a:rPr lang="en-US" sz="2550" dirty="0" spc="1" kern="0">
-                <a:solidFill>
-                  <a:srgbClr val="14161C"/>
-                </a:solidFill>
-                <a:latin typeface="Be Vietnam Pro" pitchFamily="34" charset="0"/>
-                <a:ea typeface="Be Vietnam Pro" pitchFamily="34" charset="-122"/>
-                <a:cs typeface="Be Vietnam Pro" pitchFamily="34" charset="-120"/>
-              </a:rPr>
-              <a:t> tiếng</a:t>
-            </a:r>
-            <a:r>
-              <a:rPr lang="en-US" sz="2550" dirty="0" spc="-9" kern="0">
-                <a:solidFill>
-                  <a:srgbClr val="14161C"/>
-                </a:solidFill>
-                <a:latin typeface="Be Vietnam Pro" pitchFamily="34" charset="0"/>
-                <a:ea typeface="Be Vietnam Pro" pitchFamily="34" charset="-122"/>
-                <a:cs typeface="Be Vietnam Pro" pitchFamily="34" charset="-120"/>
-              </a:rPr>
-              <a:t> nhất,</a:t>
-            </a:r>
-            <a:r>
-              <a:rPr lang="en-US" sz="2550" dirty="0" spc="1" kern="0">
-                <a:solidFill>
-                  <a:srgbClr val="14161C"/>
-                </a:solidFill>
-                <a:latin typeface="Be Vietnam Pro" pitchFamily="34" charset="0"/>
-                <a:ea typeface="Be Vietnam Pro" pitchFamily="34" charset="-122"/>
-                <a:cs typeface="Be Vietnam Pro" pitchFamily="34" charset="-120"/>
-              </a:rPr>
-              <a:t> mở</a:t>
-            </a:r>
-            <a:r>
-              <a:rPr lang="en-US" sz="2550" dirty="0" spc="-20" kern="0">
-                <a:solidFill>
-                  <a:srgbClr val="14161C"/>
-                </a:solidFill>
-                <a:latin typeface="Be Vietnam Pro" pitchFamily="34" charset="0"/>
-                <a:ea typeface="Be Vietnam Pro" pitchFamily="34" charset="-122"/>
-                <a:cs typeface="Be Vietnam Pro" pitchFamily="34" charset="-120"/>
-              </a:rPr>
-              <a:t> rộng</a:t>
-            </a:r>
-            <a:r>
-              <a:rPr lang="en-US" sz="2550" dirty="0" spc="-18" kern="0">
-                <a:solidFill>
-                  <a:srgbClr val="14161C"/>
-                </a:solidFill>
-                <a:latin typeface="Be Vietnam Pro" pitchFamily="34" charset="0"/>
-                <a:ea typeface="Be Vietnam Pro" pitchFamily="34" charset="-122"/>
-                <a:cs typeface="Be Vietnam Pro" pitchFamily="34" charset="-120"/>
-              </a:rPr>
-              <a:t> Java.</a:t>
+              <a:t> khía cạnh.</a:t>
             </a:r>
             <a:endParaRPr lang="en-US" sz="2550" dirty="0"/>
           </a:p>
@@ -12312,15 +12070,37 @@
               <a:buNone/>
             </a:pPr>
             <a:r>
-              <a:rPr lang="en-US" sz="2700" dirty="0" spc="-5" kern="0">
-                <a:solidFill>
-                  <a:srgbClr val="F3EEE3"/>
-                </a:solidFill>
-                <a:latin typeface="Be Vietnam Pro" pitchFamily="34" charset="0"/>
-                <a:ea typeface="Be Vietnam Pro" pitchFamily="34" charset="-122"/>
-                <a:cs typeface="Be Vietnam Pro" pitchFamily="34" charset="-120"/>
-              </a:rPr>
-              <a:t>Viết</a:t>
+              <a:rPr lang="en-US" sz="2700" dirty="0" spc="-2" kern="0">
+                <a:solidFill>
+                  <a:srgbClr val="F3EEE3"/>
+                </a:solidFill>
+                <a:latin typeface="Be Vietnam Pro" pitchFamily="34" charset="0"/>
+                <a:ea typeface="Be Vietnam Pro" pitchFamily="34" charset="-122"/>
+                <a:cs typeface="Be Vietnam Pro" pitchFamily="34" charset="-120"/>
+              </a:rPr>
+              <a:t>Kiểu phần</a:t>
+            </a:r>
+            <a:r>
+              <a:rPr lang="en-US" sz="2700" dirty="0" spc="0" kern="0">
+                <a:solidFill>
+                  <a:srgbClr val="F3EEE3"/>
+                </a:solidFill>
+                <a:latin typeface="Be Vietnam Pro" pitchFamily="34" charset="0"/>
+                <a:ea typeface="Be Vietnam Pro" pitchFamily="34" charset="-122"/>
+                <a:cs typeface="Be Vietnam Pro" pitchFamily="34" charset="-120"/>
+              </a:rPr>
+              <a:t> tử</a:t>
+            </a:r>
+            <a:r>
+              <a:rPr lang="en-US" sz="2700" dirty="0" spc="-1" kern="0">
+                <a:solidFill>
+                  <a:srgbClr val="F3EEE3"/>
+                </a:solidFill>
+                <a:latin typeface="Be Vietnam Pro" pitchFamily="34" charset="0"/>
+                <a:ea typeface="Be Vietnam Pro" pitchFamily="34" charset="-122"/>
+                <a:cs typeface="Be Vietnam Pro" pitchFamily="34" charset="-120"/>
+              </a:rPr>
+              <a:t> là</a:t>
             </a:r>
             <a:r>
               <a:rPr lang="en-US" sz="2700" dirty="0" spc="-7" kern="0">
@@ -12331,62 +12111,7 @@
                 <a:ea typeface="Be Vietnam Pro" pitchFamily="34" charset="-122"/>
                 <a:cs typeface="Be Vietnam Pro" pitchFamily="34" charset="-120"/>
               </a:rPr>
-              <a:t> thuật</a:t>
-            </a:r>
-            <a:r>
-              <a:rPr lang="en-US" sz="2700" dirty="0" spc="-15" kern="0">
-                <a:solidFill>
-                  <a:srgbClr val="F3EEE3"/>
-                </a:solidFill>
-                <a:latin typeface="Be Vietnam Pro" pitchFamily="34" charset="0"/>
-                <a:ea typeface="Be Vietnam Pro" pitchFamily="34" charset="-122"/>
-                <a:cs typeface="Be Vietnam Pro" pitchFamily="34" charset="-120"/>
-              </a:rPr>
-              <a:t> toán</a:t>
-            </a:r>
-            <a:r>
-              <a:rPr lang="en-US" sz="2700" dirty="0" spc="-17" kern="0">
-                <a:solidFill>
-                  <a:srgbClr val="F3EEE3"/>
-                </a:solidFill>
-                <a:latin typeface="Be Vietnam Pro" pitchFamily="34" charset="0"/>
-                <a:ea typeface="Be Vietnam Pro" pitchFamily="34" charset="-122"/>
-                <a:cs typeface="Be Vietnam Pro" pitchFamily="34" charset="-120"/>
-              </a:rPr>
-              <a:t> và</a:t>
-            </a:r>
-            <a:r>
-              <a:rPr lang="en-US" sz="2700" dirty="0" spc="1" kern="0">
-                <a:solidFill>
-                  <a:srgbClr val="F3EEE3"/>
-                </a:solidFill>
-                <a:latin typeface="Be Vietnam Pro" pitchFamily="34" charset="0"/>
-                <a:ea typeface="Be Vietnam Pro" pitchFamily="34" charset="-122"/>
-                <a:cs typeface="Be Vietnam Pro" pitchFamily="34" charset="-120"/>
-              </a:rPr>
-              <a:t> cấu</a:t>
-            </a:r>
-            <a:r>
-              <a:rPr lang="en-US" sz="2700" dirty="0" spc="0" kern="0">
-                <a:solidFill>
-                  <a:srgbClr val="F3EEE3"/>
-                </a:solidFill>
-                <a:latin typeface="Be Vietnam Pro" pitchFamily="34" charset="0"/>
-                <a:ea typeface="Be Vietnam Pro" pitchFamily="34" charset="-122"/>
-                <a:cs typeface="Be Vietnam Pro" pitchFamily="34" charset="-120"/>
-              </a:rPr>
-              <a:t> trúc</a:t>
-            </a:r>
-            <a:r>
-              <a:rPr lang="en-US" sz="2700" dirty="0" spc="-4" kern="0">
-                <a:solidFill>
-                  <a:srgbClr val="F3EEE3"/>
-                </a:solidFill>
-                <a:latin typeface="Be Vietnam Pro" pitchFamily="34" charset="0"/>
-                <a:ea typeface="Be Vietnam Pro" pitchFamily="34" charset="-122"/>
-                <a:cs typeface="Be Vietnam Pro" pitchFamily="34" charset="-120"/>
-              </a:rPr>
-              <a:t> dữ</a:t>
+              <a:t> một</a:t>
             </a:r>
             <a:r>
               <a:rPr lang="en-US" sz="2700" dirty="0" spc="-1" kern="0">
@@ -12397,7 +12122,18 @@
                 <a:ea typeface="Be Vietnam Pro" pitchFamily="34" charset="-122"/>
                 <a:cs typeface="Be Vietnam Pro" pitchFamily="34" charset="-120"/>
               </a:rPr>
-              <a:t> liệu</a:t>
+              <a:t> tham</a:t>
+            </a:r>
+            <a:r>
+              <a:rPr lang="en-US" sz="2700" dirty="0" spc="-12" kern="0">
+                <a:solidFill>
+                  <a:srgbClr val="F3EEE3"/>
+                </a:solidFill>
+                <a:latin typeface="Be Vietnam Pro" pitchFamily="34" charset="0"/>
+                <a:ea typeface="Be Vietnam Pro" pitchFamily="34" charset="-122"/>
+                <a:cs typeface="Be Vietnam Pro" pitchFamily="34" charset="-120"/>
+              </a:rPr>
+              <a:t> số</a:t>
             </a:r>
             <a:r>
               <a:rPr lang="en-US" sz="2700" dirty="0" spc="-2" kern="0">
@@ -12408,29 +12144,7 @@
                 <a:ea typeface="Be Vietnam Pro" pitchFamily="34" charset="-122"/>
                 <a:cs typeface="Be Vietnam Pro" pitchFamily="34" charset="-120"/>
               </a:rPr>
-              <a:t> mà không nêu kiểu</a:t>
-            </a:r>
-            <a:r>
-              <a:rPr lang="en-US" sz="2700" dirty="0" spc="-1" kern="0">
-                <a:solidFill>
-                  <a:srgbClr val="F3EEE3"/>
-                </a:solidFill>
-                <a:latin typeface="Be Vietnam Pro" pitchFamily="34" charset="0"/>
-                <a:ea typeface="Be Vietnam Pro" pitchFamily="34" charset="-122"/>
-                <a:cs typeface="Be Vietnam Pro" pitchFamily="34" charset="-120"/>
-              </a:rPr>
-              <a:t> chúng làm</a:t>
-            </a:r>
-            <a:r>
-              <a:rPr lang="en-US" sz="2700" dirty="0" spc="-3" kern="0">
-                <a:solidFill>
-                  <a:srgbClr val="F3EEE3"/>
-                </a:solidFill>
-                <a:latin typeface="Be Vietnam Pro" pitchFamily="34" charset="0"/>
-                <a:ea typeface="Be Vietnam Pro" pitchFamily="34" charset="-122"/>
-                <a:cs typeface="Be Vietnam Pro" pitchFamily="34" charset="-120"/>
-              </a:rPr>
-              <a:t> việc.</a:t>
+              <a:t> của lớp.</a:t>
             </a:r>
             <a:endParaRPr lang="en-US" sz="2700" dirty="0"/>
           </a:p>
@@ -12706,6 +12420,72 @@
               <a:buNone/>
             </a:pPr>
             <a:r>
+              <a:rPr lang="en-US" sz="2550" dirty="0" spc="-4" kern="0">
+                <a:solidFill>
+                  <a:srgbClr val="F3EEE3"/>
+                </a:solidFill>
+                <a:latin typeface="Be Vietnam Pro" pitchFamily="34" charset="0"/>
+                <a:ea typeface="Be Vietnam Pro" pitchFamily="34" charset="-122"/>
+                <a:cs typeface="Be Vietnam Pro" pitchFamily="34" charset="-120"/>
+              </a:rPr>
+              <a:t>Thư</a:t>
+            </a:r>
+            <a:r>
+              <a:rPr lang="en-US" sz="2550" dirty="0" spc="-1" kern="0">
+                <a:solidFill>
+                  <a:srgbClr val="F3EEE3"/>
+                </a:solidFill>
+                <a:latin typeface="Be Vietnam Pro" pitchFamily="34" charset="0"/>
+                <a:ea typeface="Be Vietnam Pro" pitchFamily="34" charset="-122"/>
+                <a:cs typeface="Be Vietnam Pro" pitchFamily="34" charset="-120"/>
+              </a:rPr>
+              <a:t> viện</a:t>
+            </a:r>
+            <a:r>
+              <a:rPr lang="en-US" sz="2550" dirty="0" spc="-23" kern="0">
+                <a:solidFill>
+                  <a:srgbClr val="F3EEE3"/>
+                </a:solidFill>
+                <a:latin typeface="Be Vietnam Pro" pitchFamily="34" charset="0"/>
+                <a:ea typeface="Be Vietnam Pro" pitchFamily="34" charset="-122"/>
+                <a:cs typeface="Be Vietnam Pro" pitchFamily="34" charset="-120"/>
+              </a:rPr>
+              <a:t> Java</a:t>
+            </a:r>
+            <a:r>
+              <a:rPr lang="en-US" sz="2550" dirty="0" spc="-1" kern="0">
+                <a:solidFill>
+                  <a:srgbClr val="F3EEE3"/>
+                </a:solidFill>
+                <a:latin typeface="Be Vietnam Pro" pitchFamily="34" charset="0"/>
+                <a:ea typeface="Be Vietnam Pro" pitchFamily="34" charset="-122"/>
+                <a:cs typeface="Be Vietnam Pro" pitchFamily="34" charset="-120"/>
+              </a:rPr>
+              <a:t> dùng</a:t>
+            </a:r>
+            <a:r>
+              <a:rPr lang="en-US" sz="2550" dirty="0" spc="1" kern="0">
+                <a:solidFill>
+                  <a:srgbClr val="F3EEE3"/>
+                </a:solidFill>
+                <a:latin typeface="Be Vietnam Pro" pitchFamily="34" charset="0"/>
+                <a:ea typeface="Be Vietnam Pro" pitchFamily="34" charset="-122"/>
+                <a:cs typeface="Be Vietnam Pro" pitchFamily="34" charset="-120"/>
+              </a:rPr>
+              <a:t> tham</a:t>
+            </a:r>
+            <a:r>
+              <a:rPr lang="en-US" sz="2550" dirty="0" spc="-11" kern="0">
+                <a:solidFill>
+                  <a:srgbClr val="F3EEE3"/>
+                </a:solidFill>
+                <a:latin typeface="Be Vietnam Pro" pitchFamily="34" charset="0"/>
+                <a:ea typeface="Be Vietnam Pro" pitchFamily="34" charset="-122"/>
+                <a:cs typeface="Be Vietnam Pro" pitchFamily="34" charset="-120"/>
+              </a:rPr>
+              <a:t> số</a:t>
+            </a:r>
+            <a:r>
               <a:rPr lang="en-US" sz="2550" dirty="0" spc="2" kern="0">
                 <a:solidFill>
                   <a:srgbClr val="F3EEE3"/>
@@ -12714,29 +12494,7 @@
                 <a:ea typeface="Be Vietnam Pro" pitchFamily="34" charset="-122"/>
                 <a:cs typeface="Be Vietnam Pro" pitchFamily="34" charset="-120"/>
               </a:rPr>
-              <a:t>Nguồn</a:t>
-            </a:r>
-            <a:r>
-              <a:rPr lang="en-US" sz="2550" dirty="0" spc="-1" kern="0">
-                <a:solidFill>
-                  <a:srgbClr val="F3EEE3"/>
-                </a:solidFill>
-                <a:latin typeface="Be Vietnam Pro" pitchFamily="34" charset="0"/>
-                <a:ea typeface="Be Vietnam Pro" pitchFamily="34" charset="-122"/>
-                <a:cs typeface="Be Vietnam Pro" pitchFamily="34" charset="-120"/>
-              </a:rPr>
-              <a:t> nói</a:t>
-            </a:r>
-            <a:r>
-              <a:rPr lang="en-US" sz="2550" dirty="0" spc="1" kern="0">
-                <a:solidFill>
-                  <a:srgbClr val="F3EEE3"/>
-                </a:solidFill>
-                <a:latin typeface="Be Vietnam Pro" pitchFamily="34" charset="0"/>
-                <a:ea typeface="Be Vietnam Pro" pitchFamily="34" charset="-122"/>
-                <a:cs typeface="Be Vietnam Pro" pitchFamily="34" charset="-120"/>
-              </a:rPr>
-              <a:t> mô</a:t>
+              <a:t> kiểu</a:t>
             </a:r>
             <a:r>
               <a:rPr lang="en-US" sz="2550" dirty="0" spc="0" kern="0">
@@ -12747,106 +12505,18 @@
                 <a:ea typeface="Be Vietnam Pro" pitchFamily="34" charset="-122"/>
                 <a:cs typeface="Be Vietnam Pro" pitchFamily="34" charset="-120"/>
               </a:rPr>
-              <a:t> hình</a:t>
-            </a:r>
-            <a:r>
-              <a:rPr lang="en-US" sz="2550" dirty="0" spc="-10" kern="0">
-                <a:solidFill>
-                  <a:srgbClr val="F3EEE3"/>
-                </a:solidFill>
-                <a:latin typeface="Be Vietnam Pro" pitchFamily="34" charset="0"/>
-                <a:ea typeface="Be Vietnam Pro" pitchFamily="34" charset="-122"/>
-                <a:cs typeface="Be Vietnam Pro" pitchFamily="34" charset="-120"/>
-              </a:rPr>
-              <a:t> này</a:t>
-            </a:r>
-            <a:r>
-              <a:rPr lang="en-US" sz="2550" dirty="0" spc="6" kern="0">
-                <a:solidFill>
-                  <a:srgbClr val="F3EEE3"/>
-                </a:solidFill>
-                <a:latin typeface="Be Vietnam Pro" pitchFamily="34" charset="0"/>
-                <a:ea typeface="Be Vietnam Pro" pitchFamily="34" charset="-122"/>
-                <a:cs typeface="Be Vietnam Pro" pitchFamily="34" charset="-120"/>
-              </a:rPr>
-              <a:t> được</a:t>
-            </a:r>
-            <a:r>
-              <a:rPr lang="en-US" sz="2550" dirty="0" spc="-1" kern="0">
-                <a:solidFill>
-                  <a:srgbClr val="F3EEE3"/>
-                </a:solidFill>
-                <a:latin typeface="Be Vietnam Pro" pitchFamily="34" charset="0"/>
-                <a:ea typeface="Be Vietnam Pro" pitchFamily="34" charset="-122"/>
-                <a:cs typeface="Be Vietnam Pro" pitchFamily="34" charset="-120"/>
-              </a:rPr>
-              <a:t> dùng</a:t>
-            </a:r>
-            <a:r>
-              <a:rPr lang="en-US" sz="2550" dirty="0" spc="1" kern="0">
-                <a:solidFill>
-                  <a:srgbClr val="F3EEE3"/>
-                </a:solidFill>
-                <a:latin typeface="Be Vietnam Pro" pitchFamily="34" charset="0"/>
-                <a:ea typeface="Be Vietnam Pro" pitchFamily="34" charset="-122"/>
-                <a:cs typeface="Be Vietnam Pro" pitchFamily="34" charset="-120"/>
-              </a:rPr>
-              <a:t> nhiều</a:t>
-            </a:r>
-            <a:r>
-              <a:rPr lang="en-US" sz="2550" dirty="0" spc="-17" kern="0">
-                <a:solidFill>
-                  <a:srgbClr val="F3EEE3"/>
-                </a:solidFill>
-                <a:latin typeface="Be Vietnam Pro" pitchFamily="34" charset="0"/>
-                <a:ea typeface="Be Vietnam Pro" pitchFamily="34" charset="-122"/>
-                <a:cs typeface="Be Vietnam Pro" pitchFamily="34" charset="-120"/>
-              </a:rPr>
-              <a:t> trong</a:t>
-            </a:r>
-            <a:r>
-              <a:rPr lang="en-US" sz="2550" dirty="0" spc="0" kern="0">
-                <a:solidFill>
-                  <a:srgbClr val="F3EEE3"/>
-                </a:solidFill>
-                <a:latin typeface="Be Vietnam Pro" pitchFamily="34" charset="0"/>
-                <a:ea typeface="Be Vietnam Pro" pitchFamily="34" charset="-122"/>
-                <a:cs typeface="Be Vietnam Pro" pitchFamily="34" charset="-120"/>
-              </a:rPr>
-              <a:t> thư</a:t>
-            </a:r>
-            <a:r>
-              <a:rPr lang="en-US" sz="2550" dirty="0" spc="-2" kern="0">
-                <a:solidFill>
-                  <a:srgbClr val="F3EEE3"/>
-                </a:solidFill>
-                <a:latin typeface="Be Vietnam Pro" pitchFamily="34" charset="0"/>
-                <a:ea typeface="Be Vietnam Pro" pitchFamily="34" charset="-122"/>
-                <a:cs typeface="Be Vietnam Pro" pitchFamily="34" charset="-120"/>
-              </a:rPr>
-              <a:t> viện</a:t>
-            </a:r>
-            <a:r>
-              <a:rPr lang="en-US" sz="2550" dirty="0" spc="-18" kern="0">
-                <a:solidFill>
-                  <a:srgbClr val="F3EEE3"/>
-                </a:solidFill>
-                <a:latin typeface="Be Vietnam Pro" pitchFamily="34" charset="0"/>
-                <a:ea typeface="Be Vietnam Pro" pitchFamily="34" charset="-122"/>
-                <a:cs typeface="Be Vietnam Pro" pitchFamily="34" charset="-120"/>
-              </a:rPr>
-              <a:t> và</a:t>
-            </a:r>
-            <a:r>
-              <a:rPr lang="en-US" sz="2550" dirty="0" spc="2" kern="0">
-                <a:solidFill>
-                  <a:srgbClr val="F3EEE3"/>
-                </a:solidFill>
-                <a:latin typeface="Be Vietnam Pro" pitchFamily="34" charset="0"/>
-                <a:ea typeface="Be Vietnam Pro" pitchFamily="34" charset="-122"/>
-                <a:cs typeface="Be Vietnam Pro" pitchFamily="34" charset="-120"/>
-              </a:rPr>
-              <a:t> khung.</a:t>
+              <a:t> cho</a:t>
+            </a:r>
+            <a:r>
+              <a:rPr lang="en-US" sz="2550" dirty="0" spc="-4" kern="0">
+                <a:solidFill>
+                  <a:srgbClr val="F3EEE3"/>
+                </a:solidFill>
+                <a:latin typeface="Be Vietnam Pro" pitchFamily="34" charset="0"/>
+                <a:ea typeface="Be Vietnam Pro" pitchFamily="34" charset="-122"/>
+                <a:cs typeface="Be Vietnam Pro" pitchFamily="34" charset="-120"/>
+              </a:rPr>
+              <a:t> List.</a:t>
             </a:r>
             <a:endParaRPr lang="en-US" sz="2550" dirty="0"/>
           </a:p>
@@ -13419,7 +13089,7 @@
               <a:buNone/>
             </a:pPr>
             <a:r>
-              <a:rPr lang="en-US" sz="1800" b="1" spc="226" kern="0" dirty="0">
+              <a:rPr lang="en-US" sz="1800" b="1" spc="225" kern="0" dirty="0">
                 <a:solidFill>
                   <a:srgbClr val="FFB454"/>
                 </a:solidFill>
@@ -13427,10 +13097,10 @@
                 <a:ea typeface="Be Vietnam Pro" pitchFamily="34" charset="-122"/>
                 <a:cs typeface="Be Vietnam Pro" pitchFamily="34" charset="-120"/>
               </a:rPr>
-              <a:t>DÙNG</a:t>
-            </a:r>
-            <a:r>
-              <a:rPr lang="en-US" sz="1800" b="1" spc="222" kern="0" dirty="0">
+              <a:t>KIỂU</a:t>
+            </a:r>
+            <a:r>
+              <a:rPr lang="en-US" sz="1800" b="1" spc="191" kern="0" dirty="0">
                 <a:solidFill>
                   <a:srgbClr val="FFB454"/>
                 </a:solidFill>
@@ -13438,7 +13108,18 @@
                 <a:ea typeface="Be Vietnam Pro" pitchFamily="34" charset="-122"/>
                 <a:cs typeface="Be Vietnam Pro" pitchFamily="34" charset="-120"/>
               </a:rPr>
-              <a:t> LẠI</a:t>
+              <a:t> THAY</a:t>
+            </a:r>
+            <a:r>
+              <a:rPr lang="en-US" sz="1800" b="1" spc="229" kern="0" dirty="0">
+                <a:solidFill>
+                  <a:srgbClr val="FFB454"/>
+                </a:solidFill>
+                <a:latin typeface="Be Vietnam Pro" pitchFamily="34" charset="0"/>
+                <a:ea typeface="Be Vietnam Pro" pitchFamily="34" charset="-122"/>
+                <a:cs typeface="Be Vietnam Pro" pitchFamily="34" charset="-120"/>
+              </a:rPr>
+              <a:t> CHO</a:t>
             </a:r>
             <a:r>
               <a:rPr lang="en-US" sz="1800" b="1" spc="228" kern="0" dirty="0">
@@ -13449,7 +13130,7 @@
                 <a:ea typeface="Be Vietnam Pro" pitchFamily="34" charset="-122"/>
                 <a:cs typeface="Be Vietnam Pro" pitchFamily="34" charset="-120"/>
               </a:rPr>
-              <a:t> CHO</a:t>
+              <a:t> E</a:t>
             </a:r>
             <a:endParaRPr lang="en-US" sz="1800" dirty="0"/>
           </a:p>
@@ -13484,26 +13165,26 @@
               <a:buNone/>
             </a:pPr>
             <a:r>
-              <a:rPr lang="en-US" sz="2250" b="1" dirty="0" spc="4" kern="0">
-                <a:solidFill>
-                  <a:srgbClr val="F3EEE3"/>
-                </a:solidFill>
-                <a:latin typeface="Be Vietnam Pro" pitchFamily="34" charset="0"/>
-                <a:ea typeface="Be Vietnam Pro" pitchFamily="34" charset="-122"/>
-                <a:cs typeface="Be Vietnam Pro" pitchFamily="34" charset="-120"/>
-              </a:rPr>
-              <a:t>Danh</a:t>
-            </a:r>
-            <a:r>
-              <a:rPr lang="en-US" sz="2250" b="1" dirty="0" spc="3" kern="0">
-                <a:solidFill>
-                  <a:srgbClr val="F3EEE3"/>
-                </a:solidFill>
-                <a:latin typeface="Be Vietnam Pro" pitchFamily="34" charset="0"/>
-                <a:ea typeface="Be Vietnam Pro" pitchFamily="34" charset="-122"/>
-                <a:cs typeface="Be Vietnam Pro" pitchFamily="34" charset="-120"/>
-              </a:rPr>
-              <a:t> sách</a:t>
+              <a:rPr lang="en-US" sz="2250" b="1" dirty="0" spc="1" kern="0">
+                <a:solidFill>
+                  <a:srgbClr val="F3EEE3"/>
+                </a:solidFill>
+                <a:latin typeface="Be Vietnam Pro" pitchFamily="34" charset="0"/>
+                <a:ea typeface="Be Vietnam Pro" pitchFamily="34" charset="-122"/>
+                <a:cs typeface="Be Vietnam Pro" pitchFamily="34" charset="-120"/>
+              </a:rPr>
+              <a:t>Kiểu</a:t>
+            </a:r>
+            <a:r>
+              <a:rPr lang="en-US" sz="2250" b="1" dirty="0" spc="5" kern="0">
+                <a:solidFill>
+                  <a:srgbClr val="F3EEE3"/>
+                </a:solidFill>
+                <a:latin typeface="Be Vietnam Pro" pitchFamily="34" charset="0"/>
+                <a:ea typeface="Be Vietnam Pro" pitchFamily="34" charset="-122"/>
+                <a:cs typeface="Be Vietnam Pro" pitchFamily="34" charset="-120"/>
+              </a:rPr>
+              <a:t> A</a:t>
             </a:r>
             <a:endParaRPr lang="en-US" sz="2250" dirty="0"/>
           </a:p>
@@ -13538,26 +13219,26 @@
               <a:buNone/>
             </a:pPr>
             <a:r>
-              <a:rPr lang="en-US" sz="2250" b="1" dirty="0" spc="-8" kern="0">
-                <a:solidFill>
-                  <a:srgbClr val="F3EEE3"/>
-                </a:solidFill>
-                <a:latin typeface="Be Vietnam Pro" pitchFamily="34" charset="0"/>
-                <a:ea typeface="Be Vietnam Pro" pitchFamily="34" charset="-122"/>
-                <a:cs typeface="Be Vietnam Pro" pitchFamily="34" charset="-120"/>
-              </a:rPr>
-              <a:t>Ngăn</a:t>
-            </a:r>
-            <a:r>
-              <a:rPr lang="en-US" sz="2250" b="1" dirty="0" spc="-19" kern="0">
-                <a:solidFill>
-                  <a:srgbClr val="F3EEE3"/>
-                </a:solidFill>
-                <a:latin typeface="Be Vietnam Pro" pitchFamily="34" charset="0"/>
-                <a:ea typeface="Be Vietnam Pro" pitchFamily="34" charset="-122"/>
-                <a:cs typeface="Be Vietnam Pro" pitchFamily="34" charset="-120"/>
-              </a:rPr>
-              <a:t> xếp</a:t>
+              <a:rPr lang="en-US" sz="2250" b="1" dirty="0" spc="1" kern="0">
+                <a:solidFill>
+                  <a:srgbClr val="F3EEE3"/>
+                </a:solidFill>
+                <a:latin typeface="Be Vietnam Pro" pitchFamily="34" charset="0"/>
+                <a:ea typeface="Be Vietnam Pro" pitchFamily="34" charset="-122"/>
+                <a:cs typeface="Be Vietnam Pro" pitchFamily="34" charset="-120"/>
+              </a:rPr>
+              <a:t>Kiểu</a:t>
+            </a:r>
+            <a:r>
+              <a:rPr lang="en-US" sz="2250" b="1" dirty="0" spc="0" kern="0">
+                <a:solidFill>
+                  <a:srgbClr val="F3EEE3"/>
+                </a:solidFill>
+                <a:latin typeface="Be Vietnam Pro" pitchFamily="34" charset="0"/>
+                <a:ea typeface="Be Vietnam Pro" pitchFamily="34" charset="-122"/>
+                <a:cs typeface="Be Vietnam Pro" pitchFamily="34" charset="-120"/>
+              </a:rPr>
+              <a:t> B</a:t>
             </a:r>
             <a:endParaRPr lang="en-US" sz="2250" dirty="0"/>
           </a:p>
@@ -13592,26 +13273,26 @@
               <a:buNone/>
             </a:pPr>
             <a:r>
-              <a:rPr lang="en-US" sz="2250" b="1" dirty="0" spc="-7" kern="0">
-                <a:solidFill>
-                  <a:srgbClr val="F3EEE3"/>
-                </a:solidFill>
-                <a:latin typeface="Be Vietnam Pro" pitchFamily="34" charset="0"/>
-                <a:ea typeface="Be Vietnam Pro" pitchFamily="34" charset="-122"/>
-                <a:cs typeface="Be Vietnam Pro" pitchFamily="34" charset="-120"/>
-              </a:rPr>
-              <a:t>Hàng</a:t>
-            </a:r>
-            <a:r>
-              <a:rPr lang="en-US" sz="2250" b="1" dirty="0" spc="13" kern="0">
-                <a:solidFill>
-                  <a:srgbClr val="F3EEE3"/>
-                </a:solidFill>
-                <a:latin typeface="Be Vietnam Pro" pitchFamily="34" charset="0"/>
-                <a:ea typeface="Be Vietnam Pro" pitchFamily="34" charset="-122"/>
-                <a:cs typeface="Be Vietnam Pro" pitchFamily="34" charset="-120"/>
-              </a:rPr>
-              <a:t> đợi</a:t>
+              <a:rPr lang="en-US" sz="2250" b="1" dirty="0" spc="1" kern="0">
+                <a:solidFill>
+                  <a:srgbClr val="F3EEE3"/>
+                </a:solidFill>
+                <a:latin typeface="Be Vietnam Pro" pitchFamily="34" charset="0"/>
+                <a:ea typeface="Be Vietnam Pro" pitchFamily="34" charset="-122"/>
+                <a:cs typeface="Be Vietnam Pro" pitchFamily="34" charset="-120"/>
+              </a:rPr>
+              <a:t>Kiểu</a:t>
+            </a:r>
+            <a:r>
+              <a:rPr lang="en-US" sz="2250" b="1" dirty="0" spc="4" kern="0">
+                <a:solidFill>
+                  <a:srgbClr val="F3EEE3"/>
+                </a:solidFill>
+                <a:latin typeface="Be Vietnam Pro" pitchFamily="34" charset="0"/>
+                <a:ea typeface="Be Vietnam Pro" pitchFamily="34" charset="-122"/>
+                <a:cs typeface="Be Vietnam Pro" pitchFamily="34" charset="-120"/>
+              </a:rPr>
+              <a:t> C</a:t>
             </a:r>
             <a:endParaRPr lang="en-US" sz="2250" dirty="0"/>
           </a:p>
@@ -13646,26 +13327,26 @@
               <a:buNone/>
             </a:pPr>
             <a:r>
-              <a:rPr lang="en-US" sz="2250" b="1" dirty="0" spc="4" kern="0">
-                <a:solidFill>
-                  <a:srgbClr val="F3EEE3"/>
-                </a:solidFill>
-                <a:latin typeface="Be Vietnam Pro" pitchFamily="34" charset="0"/>
-                <a:ea typeface="Be Vietnam Pro" pitchFamily="34" charset="-122"/>
-                <a:cs typeface="Be Vietnam Pro" pitchFamily="34" charset="-120"/>
-              </a:rPr>
-              <a:t>Sắp</a:t>
-            </a:r>
-            <a:r>
-              <a:rPr lang="en-US" sz="2250" b="1" dirty="0" spc="-19" kern="0">
-                <a:solidFill>
-                  <a:srgbClr val="F3EEE3"/>
-                </a:solidFill>
-                <a:latin typeface="Be Vietnam Pro" pitchFamily="34" charset="0"/>
-                <a:ea typeface="Be Vietnam Pro" pitchFamily="34" charset="-122"/>
-                <a:cs typeface="Be Vietnam Pro" pitchFamily="34" charset="-120"/>
-              </a:rPr>
-              <a:t> xếp</a:t>
+              <a:rPr lang="en-US" sz="2250" b="1" dirty="0" spc="1" kern="0">
+                <a:solidFill>
+                  <a:srgbClr val="F3EEE3"/>
+                </a:solidFill>
+                <a:latin typeface="Be Vietnam Pro" pitchFamily="34" charset="0"/>
+                <a:ea typeface="Be Vietnam Pro" pitchFamily="34" charset="-122"/>
+                <a:cs typeface="Be Vietnam Pro" pitchFamily="34" charset="-120"/>
+              </a:rPr>
+              <a:t>Kiểu</a:t>
+            </a:r>
+            <a:r>
+              <a:rPr lang="en-US" sz="2250" b="1" dirty="0" spc="3" kern="0">
+                <a:solidFill>
+                  <a:srgbClr val="F3EEE3"/>
+                </a:solidFill>
+                <a:latin typeface="Be Vietnam Pro" pitchFamily="34" charset="0"/>
+                <a:ea typeface="Be Vietnam Pro" pitchFamily="34" charset="-122"/>
+                <a:cs typeface="Be Vietnam Pro" pitchFamily="34" charset="-120"/>
+              </a:rPr>
+              <a:t> D</a:t>
             </a:r>
             <a:endParaRPr lang="en-US" sz="2250" dirty="0"/>
           </a:p>
@@ -13700,26 +13381,26 @@
               <a:buNone/>
             </a:pPr>
             <a:r>
-              <a:rPr lang="en-US" sz="2250" b="1" dirty="0" spc="5" kern="0">
-                <a:solidFill>
-                  <a:srgbClr val="F3EEE3"/>
-                </a:solidFill>
-                <a:latin typeface="Be Vietnam Pro" pitchFamily="34" charset="0"/>
-                <a:ea typeface="Be Vietnam Pro" pitchFamily="34" charset="-122"/>
-                <a:cs typeface="Be Vietnam Pro" pitchFamily="34" charset="-120"/>
-              </a:rPr>
-              <a:t>Tìm</a:t>
-            </a:r>
-            <a:r>
-              <a:rPr lang="en-US" sz="2250" b="1" dirty="0" spc="0" kern="0">
-                <a:solidFill>
-                  <a:srgbClr val="F3EEE3"/>
-                </a:solidFill>
-                <a:latin typeface="Be Vietnam Pro" pitchFamily="34" charset="0"/>
-                <a:ea typeface="Be Vietnam Pro" pitchFamily="34" charset="-122"/>
-                <a:cs typeface="Be Vietnam Pro" pitchFamily="34" charset="-120"/>
-              </a:rPr>
-              <a:t> kiếm</a:t>
+              <a:rPr lang="en-US" sz="2250" b="1" dirty="0" spc="1" kern="0">
+                <a:solidFill>
+                  <a:srgbClr val="F3EEE3"/>
+                </a:solidFill>
+                <a:latin typeface="Be Vietnam Pro" pitchFamily="34" charset="0"/>
+                <a:ea typeface="Be Vietnam Pro" pitchFamily="34" charset="-122"/>
+                <a:cs typeface="Be Vietnam Pro" pitchFamily="34" charset="-120"/>
+              </a:rPr>
+              <a:t>Kiểu</a:t>
+            </a:r>
+            <a:r>
+              <a:rPr lang="en-US" sz="2250" b="1" dirty="0" spc="-1" kern="0">
+                <a:solidFill>
+                  <a:srgbClr val="F3EEE3"/>
+                </a:solidFill>
+                <a:latin typeface="Be Vietnam Pro" pitchFamily="34" charset="0"/>
+                <a:ea typeface="Be Vietnam Pro" pitchFamily="34" charset="-122"/>
+                <a:cs typeface="Be Vietnam Pro" pitchFamily="34" charset="-120"/>
+              </a:rPr>
+              <a:t> E</a:t>
             </a:r>
             <a:endParaRPr lang="en-US" sz="2250" dirty="0"/>
           </a:p>
@@ -14527,7 +14208,7 @@
               <a:t>Phản</a:t>
             </a:r>
             <a:r>
-              <a:rPr lang="en-US" sz="2700" dirty="0" spc="23" kern="0">
+              <a:rPr lang="en-US" sz="2700" dirty="0" spc="18" kern="0">
                 <a:solidFill>
                   <a:srgbClr val="14161C"/>
                 </a:solidFill>
@@ -14535,7 +14216,73 @@
                 <a:ea typeface="Be Vietnam Pro" pitchFamily="34" charset="-122"/>
                 <a:cs typeface="Be Vietnam Pro" pitchFamily="34" charset="-120"/>
               </a:rPr>
-              <a:t> ứng</a:t>
+              <a:t> ứng:</a:t>
+            </a:r>
+            <a:r>
+              <a:rPr lang="en-US" sz="2700" dirty="0" spc="-1" kern="0">
+                <a:solidFill>
+                  <a:srgbClr val="14161C"/>
+                </a:solidFill>
+                <a:latin typeface="Be Vietnam Pro" pitchFamily="34" charset="0"/>
+                <a:ea typeface="Be Vietnam Pro" pitchFamily="34" charset="-122"/>
+                <a:cs typeface="Be Vietnam Pro" pitchFamily="34" charset="-120"/>
+              </a:rPr>
+              <a:t> luồng</a:t>
+            </a:r>
+            <a:r>
+              <a:rPr lang="en-US" sz="2700" dirty="0" spc="0" kern="0">
+                <a:solidFill>
+                  <a:srgbClr val="14161C"/>
+                </a:solidFill>
+                <a:latin typeface="Be Vietnam Pro" pitchFamily="34" charset="0"/>
+                <a:ea typeface="Be Vietnam Pro" pitchFamily="34" charset="-122"/>
+                <a:cs typeface="Be Vietnam Pro" pitchFamily="34" charset="-120"/>
+              </a:rPr>
+              <a:t> có</a:t>
+            </a:r>
+            <a:r>
+              <a:rPr lang="en-US" sz="2700" dirty="0" spc="20" kern="0">
+                <a:solidFill>
+                  <a:srgbClr val="14161C"/>
+                </a:solidFill>
+                <a:latin typeface="Be Vietnam Pro" pitchFamily="34" charset="0"/>
+                <a:ea typeface="Be Vietnam Pro" pitchFamily="34" charset="-122"/>
+                <a:cs typeface="Be Vietnam Pro" pitchFamily="34" charset="-120"/>
+              </a:rPr>
+              <a:t> điều</a:t>
+            </a:r>
+            <a:r>
+              <a:rPr lang="en-US" sz="2700" dirty="0" spc="-5" kern="0">
+                <a:solidFill>
+                  <a:srgbClr val="14161C"/>
+                </a:solidFill>
+                <a:latin typeface="Be Vietnam Pro" pitchFamily="34" charset="0"/>
+                <a:ea typeface="Be Vietnam Pro" pitchFamily="34" charset="-122"/>
+                <a:cs typeface="Be Vietnam Pro" pitchFamily="34" charset="-120"/>
+              </a:rPr>
+              <a:t> tiết</a:t>
+            </a:r>
+            <a:r>
+              <a:rPr lang="en-US" sz="2700" dirty="0" spc="22" kern="0">
+                <a:solidFill>
+                  <a:srgbClr val="14161C"/>
+                </a:solidFill>
+                <a:latin typeface="Be Vietnam Pro" pitchFamily="34" charset="0"/>
+                <a:ea typeface="Be Vietnam Pro" pitchFamily="34" charset="-122"/>
+                <a:cs typeface="Be Vietnam Pro" pitchFamily="34" charset="-120"/>
+              </a:rPr>
+              <a:t> lưu</a:t>
+            </a:r>
+            <a:r>
+              <a:rPr lang="en-US" sz="2700" dirty="0" spc="5" kern="0">
+                <a:solidFill>
+                  <a:srgbClr val="14161C"/>
+                </a:solidFill>
+                <a:latin typeface="Be Vietnam Pro" pitchFamily="34" charset="0"/>
+                <a:ea typeface="Be Vietnam Pro" pitchFamily="34" charset="-122"/>
+                <a:cs typeface="Be Vietnam Pro" pitchFamily="34" charset="-120"/>
+              </a:rPr>
+              <a:t> lượng.</a:t>
             </a:r>
             <a:r>
               <a:rPr lang="en-US" sz="2700" dirty="0" spc="-2" kern="0">
@@ -14546,10 +14293,10 @@
                 <a:ea typeface="Be Vietnam Pro" pitchFamily="34" charset="-122"/>
                 <a:cs typeface="Be Vietnam Pro" pitchFamily="34" charset="-120"/>
               </a:rPr>
-              <a:t> lan</a:t>
-            </a:r>
-            <a:r>
-              <a:rPr lang="en-US" sz="2700" dirty="0" spc="-15" kern="0">
+              <a:t> Đồng</a:t>
+            </a:r>
+            <a:r>
+              <a:rPr lang="en-US" sz="2700" dirty="0" spc="-1" kern="0">
                 <a:solidFill>
                   <a:srgbClr val="14161C"/>
                 </a:solidFill>
@@ -14557,10 +14304,10 @@
                 <a:ea typeface="Be Vietnam Pro" pitchFamily="34" charset="-122"/>
                 <a:cs typeface="Be Vietnam Pro" pitchFamily="34" charset="-120"/>
               </a:rPr>
-              <a:t> truyền</a:t>
-            </a:r>
-            <a:r>
-              <a:rPr lang="en-US" sz="2700" dirty="0" spc="-9" kern="0">
+              <a:t> thời:</a:t>
+            </a:r>
+            <a:r>
+              <a:rPr lang="en-US" sz="2700" dirty="0" spc="2" kern="0">
                 <a:solidFill>
                   <a:srgbClr val="14161C"/>
                 </a:solidFill>
@@ -14568,10 +14315,10 @@
                 <a:ea typeface="Be Vietnam Pro" pitchFamily="34" charset="-122"/>
                 <a:cs typeface="Be Vietnam Pro" pitchFamily="34" charset="-120"/>
               </a:rPr>
-              <a:t> thay</a:t>
-            </a:r>
-            <a:r>
-              <a:rPr lang="en-US" sz="2700" dirty="0" spc="9" kern="0">
+              <a:t> các</a:t>
+            </a:r>
+            <a:r>
+              <a:rPr lang="en-US" sz="2700" dirty="0" spc="-2" kern="0">
                 <a:solidFill>
                   <a:srgbClr val="14161C"/>
                 </a:solidFill>
@@ -14579,7 +14326,29 @@
                 <a:ea typeface="Be Vietnam Pro" pitchFamily="34" charset="-122"/>
                 <a:cs typeface="Be Vietnam Pro" pitchFamily="34" charset="-120"/>
               </a:rPr>
-              <a:t> đổi.</a:t>
+              <a:t> phần</a:t>
+            </a:r>
+            <a:r>
+              <a:rPr lang="en-US" sz="2700" dirty="0" spc="-8" kern="0">
+                <a:solidFill>
+                  <a:srgbClr val="14161C"/>
+                </a:solidFill>
+                <a:latin typeface="Be Vietnam Pro" pitchFamily="34" charset="0"/>
+                <a:ea typeface="Be Vietnam Pro" pitchFamily="34" charset="-122"/>
+                <a:cs typeface="Be Vietnam Pro" pitchFamily="34" charset="-120"/>
+              </a:rPr>
+              <a:t> chạy</a:t>
+            </a:r>
+            <a:r>
+              <a:rPr lang="en-US" sz="2700" dirty="0" spc="10" kern="0">
+                <a:solidFill>
+                  <a:srgbClr val="14161C"/>
+                </a:solidFill>
+                <a:latin typeface="Be Vietnam Pro" pitchFamily="34" charset="0"/>
+                <a:ea typeface="Be Vietnam Pro" pitchFamily="34" charset="-122"/>
+                <a:cs typeface="Be Vietnam Pro" pitchFamily="34" charset="-120"/>
+              </a:rPr>
+              <a:t> độc</a:t>
             </a:r>
             <a:r>
               <a:rPr lang="en-US" sz="2700" dirty="0" spc="-1" kern="0">
@@ -14590,84 +14359,7 @@
                 <a:ea typeface="Be Vietnam Pro" pitchFamily="34" charset="-122"/>
                 <a:cs typeface="Be Vietnam Pro" pitchFamily="34" charset="-120"/>
               </a:rPr>
-              <a:t> Đồng</a:t>
-            </a:r>
-            <a:r>
-              <a:rPr lang="en-US" sz="2700" dirty="0" spc="0" kern="0">
-                <a:solidFill>
-                  <a:srgbClr val="14161C"/>
-                </a:solidFill>
-                <a:latin typeface="Be Vietnam Pro" pitchFamily="34" charset="0"/>
-                <a:ea typeface="Be Vietnam Pro" pitchFamily="34" charset="-122"/>
-                <a:cs typeface="Be Vietnam Pro" pitchFamily="34" charset="-120"/>
-              </a:rPr>
-              <a:t> thời</a:t>
-            </a:r>
-            <a:r>
-              <a:rPr lang="en-US" sz="2700" dirty="0" spc="-9" kern="0">
-                <a:solidFill>
-                  <a:srgbClr val="14161C"/>
-                </a:solidFill>
-                <a:latin typeface="Be Vietnam Pro" pitchFamily="34" charset="0"/>
-                <a:ea typeface="Be Vietnam Pro" pitchFamily="34" charset="-122"/>
-                <a:cs typeface="Be Vietnam Pro" pitchFamily="34" charset="-120"/>
-              </a:rPr>
-              <a:t> chạy</a:t>
-            </a:r>
-            <a:r>
-              <a:rPr lang="en-US" sz="2700" dirty="0" spc="-1" kern="0">
-                <a:solidFill>
-                  <a:srgbClr val="14161C"/>
-                </a:solidFill>
-                <a:latin typeface="Be Vietnam Pro" pitchFamily="34" charset="0"/>
-                <a:ea typeface="Be Vietnam Pro" pitchFamily="34" charset="-122"/>
-                <a:cs typeface="Be Vietnam Pro" pitchFamily="34" charset="-120"/>
-              </a:rPr>
-              <a:t> nhiều</a:t>
-            </a:r>
-            <a:r>
-              <a:rPr lang="en-US" sz="2700" dirty="0" spc="-12" kern="0">
-                <a:solidFill>
-                  <a:srgbClr val="14161C"/>
-                </a:solidFill>
-                <a:latin typeface="Be Vietnam Pro" pitchFamily="34" charset="0"/>
-                <a:ea typeface="Be Vietnam Pro" pitchFamily="34" charset="-122"/>
-                <a:cs typeface="Be Vietnam Pro" pitchFamily="34" charset="-120"/>
-              </a:rPr>
-              <a:t> tác</a:t>
-            </a:r>
-            <a:r>
-              <a:rPr lang="en-US" sz="2700" dirty="0" spc="-1" kern="0">
-                <a:solidFill>
-                  <a:srgbClr val="14161C"/>
-                </a:solidFill>
-                <a:latin typeface="Be Vietnam Pro" pitchFamily="34" charset="0"/>
-                <a:ea typeface="Be Vietnam Pro" pitchFamily="34" charset="-122"/>
-                <a:cs typeface="Be Vietnam Pro" pitchFamily="34" charset="-120"/>
-              </a:rPr>
-              <a:t> vụ</a:t>
-            </a:r>
-            <a:r>
-              <a:rPr lang="en-US" sz="2700" dirty="0" spc="-2" kern="0">
-                <a:solidFill>
-                  <a:srgbClr val="14161C"/>
-                </a:solidFill>
-                <a:latin typeface="Be Vietnam Pro" pitchFamily="34" charset="0"/>
-                <a:ea typeface="Be Vietnam Pro" pitchFamily="34" charset="-122"/>
-                <a:cs typeface="Be Vietnam Pro" pitchFamily="34" charset="-120"/>
-              </a:rPr>
-              <a:t> cùng</a:t>
-            </a:r>
-            <a:r>
-              <a:rPr lang="en-US" sz="2700" dirty="0" spc="-1" kern="0">
-                <a:solidFill>
-                  <a:srgbClr val="14161C"/>
-                </a:solidFill>
-                <a:latin typeface="Be Vietnam Pro" pitchFamily="34" charset="0"/>
-                <a:ea typeface="Be Vietnam Pro" pitchFamily="34" charset="-122"/>
-                <a:cs typeface="Be Vietnam Pro" pitchFamily="34" charset="-120"/>
-              </a:rPr>
-              <a:t> lúc.</a:t>
+              <a:t> lập.</a:t>
             </a:r>
             <a:endParaRPr lang="en-US" sz="2700" dirty="0"/>
           </a:p>
@@ -14878,7 +14570,7 @@
               <a:buNone/>
             </a:pPr>
             <a:r>
-              <a:rPr lang="en-US" sz="2550" dirty="0" spc="0" kern="0">
+              <a:rPr lang="en-US" sz="2550" dirty="0" spc="-23" kern="0">
                 <a:solidFill>
                   <a:srgbClr val="14161C"/>
                 </a:solidFill>
@@ -14886,10 +14578,10 @@
                 <a:ea typeface="Be Vietnam Pro" pitchFamily="34" charset="-122"/>
                 <a:cs typeface="Be Vietnam Pro" pitchFamily="34" charset="-120"/>
               </a:rPr>
-              <a:t>Ứng</a:t>
-            </a:r>
-            <a:r>
-              <a:rPr lang="en-US" sz="2550" dirty="0" spc="-1" kern="0">
+              <a:t>Reactive</a:t>
+            </a:r>
+            <a:r>
+              <a:rPr lang="en-US" sz="2550" dirty="0" spc="-13" kern="0">
                 <a:solidFill>
                   <a:srgbClr val="14161C"/>
                 </a:solidFill>
@@ -14897,10 +14589,10 @@
                 <a:ea typeface="Be Vietnam Pro" pitchFamily="34" charset="-122"/>
                 <a:cs typeface="Be Vietnam Pro" pitchFamily="34" charset="-120"/>
               </a:rPr>
-              <a:t> dụng</a:t>
-            </a:r>
-            <a:r>
-              <a:rPr lang="en-US" sz="2550" dirty="0" spc="5" kern="0">
+              <a:t> Streams:</a:t>
+            </a:r>
+            <a:r>
+              <a:rPr lang="en-US" sz="2550" dirty="0" spc="1" kern="0">
                 <a:solidFill>
                   <a:srgbClr val="14161C"/>
                 </a:solidFill>
@@ -14908,10 +14600,10 @@
                 <a:ea typeface="Be Vietnam Pro" pitchFamily="34" charset="-122"/>
                 <a:cs typeface="Be Vietnam Pro" pitchFamily="34" charset="-120"/>
               </a:rPr>
-              <a:t> hướng</a:t>
-            </a:r>
-            <a:r>
-              <a:rPr lang="en-US" sz="2550" dirty="0" spc="-3" kern="0">
+              <a:t> luồng</a:t>
+            </a:r>
+            <a:r>
+              <a:rPr lang="en-US" sz="2550" dirty="0" spc="-15" kern="0">
                 <a:solidFill>
                   <a:srgbClr val="14161C"/>
                 </a:solidFill>
@@ -14919,10 +14611,10 @@
                 <a:ea typeface="Be Vietnam Pro" pitchFamily="34" charset="-122"/>
                 <a:cs typeface="Be Vietnam Pro" pitchFamily="34" charset="-120"/>
               </a:rPr>
-              <a:t> sự</a:t>
-            </a:r>
-            <a:r>
-              <a:rPr lang="en-US" sz="2550" dirty="0" spc="0" kern="0">
+              <a:t> bất</a:t>
+            </a:r>
+            <a:r>
+              <a:rPr lang="en-US" sz="2550" dirty="0" spc="11" kern="0">
                 <a:solidFill>
                   <a:srgbClr val="14161C"/>
                 </a:solidFill>
@@ -14930,10 +14622,10 @@
                 <a:ea typeface="Be Vietnam Pro" pitchFamily="34" charset="-122"/>
                 <a:cs typeface="Be Vietnam Pro" pitchFamily="34" charset="-120"/>
               </a:rPr>
-              <a:t> kiện</a:t>
-            </a:r>
-            <a:r>
-              <a:rPr lang="en-US" sz="2550" dirty="0" spc="5" kern="0">
+              <a:t> đồng</a:t>
+            </a:r>
+            <a:r>
+              <a:rPr lang="en-US" sz="2550" dirty="0" spc="-4" kern="0">
                 <a:solidFill>
                   <a:srgbClr val="14161C"/>
                 </a:solidFill>
@@ -14941,10 +14633,10 @@
                 <a:ea typeface="Be Vietnam Pro" pitchFamily="34" charset="-122"/>
                 <a:cs typeface="Be Vietnam Pro" pitchFamily="34" charset="-120"/>
               </a:rPr>
-              <a:t> hưởng</a:t>
-            </a:r>
-            <a:r>
-              <a:rPr lang="en-US" sz="2550" dirty="0" spc="0" kern="0">
+              <a:t> bộ,</a:t>
+            </a:r>
+            <a:r>
+              <a:rPr lang="en-US" sz="2550" dirty="0" spc="-15" kern="0">
                 <a:solidFill>
                   <a:srgbClr val="14161C"/>
                 </a:solidFill>
@@ -14952,40 +14644,7 @@
                 <a:ea typeface="Be Vietnam Pro" pitchFamily="34" charset="-122"/>
                 <a:cs typeface="Be Vietnam Pro" pitchFamily="34" charset="-120"/>
               </a:rPr>
-              <a:t> lợi</a:t>
-            </a:r>
-            <a:r>
-              <a:rPr lang="en-US" sz="2550" dirty="0" spc="-1" kern="0">
-                <a:solidFill>
-                  <a:srgbClr val="14161C"/>
-                </a:solidFill>
-                <a:latin typeface="Be Vietnam Pro" pitchFamily="34" charset="0"/>
-                <a:ea typeface="Be Vietnam Pro" pitchFamily="34" charset="-122"/>
-                <a:cs typeface="Be Vietnam Pro" pitchFamily="34" charset="-120"/>
-              </a:rPr>
-              <a:t> từ</a:t>
-            </a:r>
-            <a:r>
-              <a:rPr lang="en-US" sz="2550" dirty="0" spc="0" kern="0">
-                <a:solidFill>
-                  <a:srgbClr val="14161C"/>
-                </a:solidFill>
-                <a:latin typeface="Be Vietnam Pro" pitchFamily="34" charset="0"/>
-                <a:ea typeface="Be Vietnam Pro" pitchFamily="34" charset="-122"/>
-                <a:cs typeface="Be Vietnam Pro" pitchFamily="34" charset="-120"/>
-              </a:rPr>
-              <a:t> mô hình phản</a:t>
-            </a:r>
-            <a:r>
-              <a:rPr lang="en-US" sz="2550" dirty="0" spc="20" kern="0">
-                <a:solidFill>
-                  <a:srgbClr val="14161C"/>
-                </a:solidFill>
-                <a:latin typeface="Be Vietnam Pro" pitchFamily="34" charset="0"/>
-                <a:ea typeface="Be Vietnam Pro" pitchFamily="34" charset="-122"/>
-                <a:cs typeface="Be Vietnam Pro" pitchFamily="34" charset="-120"/>
-              </a:rPr>
-              <a:t> ứng.</a:t>
+              <a:t> backpressure.</a:t>
             </a:r>
             <a:endParaRPr lang="en-US" sz="2550" dirty="0"/>
           </a:p>
@@ -15475,7 +15134,7 @@
               <a:t> ·</a:t>
             </a:r>
             <a:r>
-              <a:rPr lang="en-US" sz="1800" b="1" spc="226" kern="0" dirty="0">
+              <a:rPr lang="en-US" sz="1800" b="1" spc="193" kern="0" dirty="0">
                 <a:solidFill>
                   <a:srgbClr val="0F766E"/>
                 </a:solidFill>
@@ -15483,10 +15142,10 @@
                 <a:ea typeface="Be Vietnam Pro" pitchFamily="34" charset="-122"/>
                 <a:cs typeface="Be Vietnam Pro" pitchFamily="34" charset="-120"/>
               </a:rPr>
-              <a:t> NHIỀU</a:t>
-            </a:r>
-            <a:r>
-              <a:rPr lang="en-US" sz="1800" b="1" spc="165" kern="0" dirty="0">
+              <a:t> CÁC</a:t>
+            </a:r>
+            <a:r>
+              <a:rPr lang="en-US" sz="1800" b="1" spc="225" kern="0" dirty="0">
                 <a:solidFill>
                   <a:srgbClr val="0F766E"/>
                 </a:solidFill>
@@ -15494,10 +15153,10 @@
                 <a:ea typeface="Be Vietnam Pro" pitchFamily="34" charset="-122"/>
                 <a:cs typeface="Be Vietnam Pro" pitchFamily="34" charset="-120"/>
               </a:rPr>
-              <a:t> TÁC</a:t>
-            </a:r>
-            <a:r>
-              <a:rPr lang="en-US" sz="1800" b="1" spc="229" kern="0" dirty="0">
+              <a:t> PHẦN</a:t>
+            </a:r>
+            <a:r>
+              <a:rPr lang="en-US" sz="1800" b="1" spc="192" kern="0" dirty="0">
                 <a:solidFill>
                   <a:srgbClr val="0F766E"/>
                 </a:solidFill>
@@ -15505,10 +15164,10 @@
                 <a:ea typeface="Be Vietnam Pro" pitchFamily="34" charset="-122"/>
                 <a:cs typeface="Be Vietnam Pro" pitchFamily="34" charset="-120"/>
               </a:rPr>
-              <a:t> VỤ</a:t>
-            </a:r>
-            <a:r>
-              <a:rPr lang="en-US" sz="1800" b="1" spc="226" kern="0" dirty="0">
+              <a:t> CHẠY</a:t>
+            </a:r>
+            <a:r>
+              <a:rPr lang="en-US" sz="1800" b="1" spc="227" kern="0" dirty="0">
                 <a:solidFill>
                   <a:srgbClr val="0F766E"/>
                 </a:solidFill>
@@ -15516,10 +15175,10 @@
                 <a:ea typeface="Be Vietnam Pro" pitchFamily="34" charset="-122"/>
                 <a:cs typeface="Be Vietnam Pro" pitchFamily="34" charset="-120"/>
               </a:rPr>
-              <a:t> CÙNG</a:t>
-            </a:r>
-            <a:r>
-              <a:rPr lang="en-US" sz="1800" b="1" spc="227" kern="0" dirty="0">
+              <a:t> ĐỘC</a:t>
+            </a:r>
+            <a:r>
+              <a:rPr lang="en-US" sz="1800" b="1" spc="222" kern="0" dirty="0">
                 <a:solidFill>
                   <a:srgbClr val="0F766E"/>
                 </a:solidFill>
@@ -15527,7 +15186,7 @@
                 <a:ea typeface="Be Vietnam Pro" pitchFamily="34" charset="-122"/>
                 <a:cs typeface="Be Vietnam Pro" pitchFamily="34" charset="-120"/>
               </a:rPr>
-              <a:t> LÚC</a:t>
+              <a:t> LẬP</a:t>
             </a:r>
             <a:endParaRPr lang="en-US" sz="1800" dirty="0"/>
           </a:p>
@@ -15974,7 +15633,7 @@
               <a:buNone/>
             </a:pPr>
             <a:r>
-              <a:rPr lang="en-US" sz="1950" dirty="0" spc="0" kern="0">
+              <a:rPr lang="en-US" sz="1950" dirty="0" spc="-2" kern="0">
                 <a:solidFill>
                   <a:srgbClr val="6B6A66"/>
                 </a:solidFill>
@@ -15982,10 +15641,10 @@
                 <a:ea typeface="Be Vietnam Pro" pitchFamily="34" charset="-122"/>
                 <a:cs typeface="Be Vietnam Pro" pitchFamily="34" charset="-120"/>
               </a:rPr>
-              <a:t>Mục</a:t>
-            </a:r>
-            <a:r>
-              <a:rPr lang="en-US" sz="1950" dirty="0" spc="12" kern="0">
+              <a:t>Cách</a:t>
+            </a:r>
+            <a:r>
+              <a:rPr lang="en-US" sz="1950" dirty="0" spc="-1" kern="0">
                 <a:solidFill>
                   <a:srgbClr val="6B6A66"/>
                 </a:solidFill>
@@ -15993,7 +15652,51 @@
                 <a:ea typeface="Be Vietnam Pro" pitchFamily="34" charset="-122"/>
                 <a:cs typeface="Be Vietnam Pro" pitchFamily="34" charset="-120"/>
               </a:rPr>
-              <a:t> đích:</a:t>
+              <a:t> cấu trúc</a:t>
+            </a:r>
+            <a:r>
+              <a:rPr lang="en-US" sz="1950" dirty="0" spc="4" kern="0">
+                <a:solidFill>
+                  <a:srgbClr val="6B6A66"/>
+                </a:solidFill>
+                <a:latin typeface="Be Vietnam Pro" pitchFamily="34" charset="0"/>
+                <a:ea typeface="Be Vietnam Pro" pitchFamily="34" charset="-122"/>
+                <a:cs typeface="Be Vietnam Pro" pitchFamily="34" charset="-120"/>
+              </a:rPr>
+              <a:t> chương</a:t>
+            </a:r>
+            <a:r>
+              <a:rPr lang="en-US" sz="1950" dirty="0" spc="7" kern="0">
+                <a:solidFill>
+                  <a:srgbClr val="6B6A66"/>
+                </a:solidFill>
+                <a:latin typeface="Be Vietnam Pro" pitchFamily="34" charset="0"/>
+                <a:ea typeface="Be Vietnam Pro" pitchFamily="34" charset="-122"/>
+                <a:cs typeface="Be Vietnam Pro" pitchFamily="34" charset="-120"/>
+              </a:rPr>
+              <a:t> trình,</a:t>
+            </a:r>
+            <a:r>
+              <a:rPr lang="en-US" sz="1950" dirty="0" spc="-3" kern="0">
+                <a:solidFill>
+                  <a:srgbClr val="6B6A66"/>
+                </a:solidFill>
+                <a:latin typeface="Be Vietnam Pro" pitchFamily="34" charset="0"/>
+                <a:ea typeface="Be Vietnam Pro" pitchFamily="34" charset="-122"/>
+                <a:cs typeface="Be Vietnam Pro" pitchFamily="34" charset="-120"/>
+              </a:rPr>
+              <a:t> khác</a:t>
+            </a:r>
+            <a:r>
+              <a:rPr lang="en-US" sz="1950" dirty="0" spc="-1" kern="0">
+                <a:solidFill>
+                  <a:srgbClr val="6B6A66"/>
+                </a:solidFill>
+                <a:latin typeface="Be Vietnam Pro" pitchFamily="34" charset="0"/>
+                <a:ea typeface="Be Vietnam Pro" pitchFamily="34" charset="-122"/>
+                <a:cs typeface="Be Vietnam Pro" pitchFamily="34" charset="-120"/>
+              </a:rPr>
+              <a:t> song</a:t>
             </a:r>
             <a:r>
               <a:rPr lang="en-US" sz="1950" dirty="0" spc="-2" kern="0">
@@ -16004,84 +15707,7 @@
                 <a:ea typeface="Be Vietnam Pro" pitchFamily="34" charset="-122"/>
                 <a:cs typeface="Be Vietnam Pro" pitchFamily="34" charset="-120"/>
               </a:rPr>
-              <a:t> cải</a:t>
-            </a:r>
-            <a:r>
-              <a:rPr lang="en-US" sz="1950" dirty="0" spc="0" kern="0">
-                <a:solidFill>
-                  <a:srgbClr val="6B6A66"/>
-                </a:solidFill>
-                <a:latin typeface="Be Vietnam Pro" pitchFamily="34" charset="0"/>
-                <a:ea typeface="Be Vietnam Pro" pitchFamily="34" charset="-122"/>
-                <a:cs typeface="Be Vietnam Pro" pitchFamily="34" charset="-120"/>
-              </a:rPr>
-              <a:t> thiện</a:t>
-            </a:r>
-            <a:r>
-              <a:rPr lang="en-US" sz="1950" dirty="0" spc="1" kern="0">
-                <a:solidFill>
-                  <a:srgbClr val="6B6A66"/>
-                </a:solidFill>
-                <a:latin typeface="Be Vietnam Pro" pitchFamily="34" charset="0"/>
-                <a:ea typeface="Be Vietnam Pro" pitchFamily="34" charset="-122"/>
-                <a:cs typeface="Be Vietnam Pro" pitchFamily="34" charset="-120"/>
-              </a:rPr>
-              <a:t> hiệu</a:t>
-            </a:r>
-            <a:r>
-              <a:rPr lang="en-US" sz="1950" dirty="0" spc="2" kern="0">
-                <a:solidFill>
-                  <a:srgbClr val="6B6A66"/>
-                </a:solidFill>
-                <a:latin typeface="Be Vietnam Pro" pitchFamily="34" charset="0"/>
-                <a:ea typeface="Be Vietnam Pro" pitchFamily="34" charset="-122"/>
-                <a:cs typeface="Be Vietnam Pro" pitchFamily="34" charset="-120"/>
-              </a:rPr>
-              <a:t> năng,</a:t>
-            </a:r>
-            <a:r>
-              <a:rPr lang="en-US" sz="1950" dirty="0" spc="-9" kern="0">
-                <a:solidFill>
-                  <a:srgbClr val="6B6A66"/>
-                </a:solidFill>
-                <a:latin typeface="Be Vietnam Pro" pitchFamily="34" charset="0"/>
-                <a:ea typeface="Be Vietnam Pro" pitchFamily="34" charset="-122"/>
-                <a:cs typeface="Be Vietnam Pro" pitchFamily="34" charset="-120"/>
-              </a:rPr>
-              <a:t> tận</a:t>
-            </a:r>
-            <a:r>
-              <a:rPr lang="en-US" sz="1950" dirty="0" spc="1" kern="0">
-                <a:solidFill>
-                  <a:srgbClr val="6B6A66"/>
-                </a:solidFill>
-                <a:latin typeface="Be Vietnam Pro" pitchFamily="34" charset="0"/>
-                <a:ea typeface="Be Vietnam Pro" pitchFamily="34" charset="-122"/>
-                <a:cs typeface="Be Vietnam Pro" pitchFamily="34" charset="-120"/>
-              </a:rPr>
-              <a:t> dụng</a:t>
-            </a:r>
-            <a:r>
-              <a:rPr lang="en-US" sz="1950" dirty="0" spc="-11" kern="0">
-                <a:solidFill>
-                  <a:srgbClr val="6B6A66"/>
-                </a:solidFill>
-                <a:latin typeface="Be Vietnam Pro" pitchFamily="34" charset="0"/>
-                <a:ea typeface="Be Vietnam Pro" pitchFamily="34" charset="-122"/>
-                <a:cs typeface="Be Vietnam Pro" pitchFamily="34" charset="-120"/>
-              </a:rPr>
-              <a:t> tài</a:t>
-            </a:r>
-            <a:r>
-              <a:rPr lang="en-US" sz="1950" dirty="0" spc="-7" kern="0">
-                <a:solidFill>
-                  <a:srgbClr val="6B6A66"/>
-                </a:solidFill>
-                <a:latin typeface="Be Vietnam Pro" pitchFamily="34" charset="0"/>
-                <a:ea typeface="Be Vietnam Pro" pitchFamily="34" charset="-122"/>
-                <a:cs typeface="Be Vietnam Pro" pitchFamily="34" charset="-120"/>
-              </a:rPr>
-              <a:t> nguyên.</a:t>
+              <a:t> song.</a:t>
             </a:r>
             <a:endParaRPr lang="en-US" sz="1950" dirty="0"/>
           </a:p>
@@ -16751,7 +16377,7 @@
               <a:t>Python,</a:t>
             </a:r>
             <a:r>
-              <a:rPr lang="en-US" sz="3300" b="1" dirty="0" spc="-27" kern="0">
+              <a:rPr lang="en-US" sz="3300" b="1" dirty="0" spc="1" kern="0">
                 <a:solidFill>
                   <a:srgbClr val="C4C8D6"/>
                 </a:solidFill>
@@ -16759,7 +16385,18 @@
                 <a:ea typeface="Be Vietnam Pro" pitchFamily="34" charset="-122"/>
                 <a:cs typeface="Be Vietnam Pro" pitchFamily="34" charset="-120"/>
               </a:rPr>
-              <a:t> Java,</a:t>
+              <a:t> MDN,</a:t>
+            </a:r>
+            <a:r>
+              <a:rPr lang="en-US" sz="3300" b="1" dirty="0" spc="4" kern="0">
+                <a:solidFill>
+                  <a:srgbClr val="C4C8D6"/>
+                </a:solidFill>
+                <a:latin typeface="Be Vietnam Pro" pitchFamily="34" charset="0"/>
+                <a:ea typeface="Be Vietnam Pro" pitchFamily="34" charset="-122"/>
+                <a:cs typeface="Be Vietnam Pro" pitchFamily="34" charset="-120"/>
+              </a:rPr>
+              <a:t> Spring, JDK,</a:t>
             </a:r>
             <a:r>
               <a:rPr lang="en-US" sz="3300" b="1" dirty="0" spc="-5" kern="0">
@@ -16801,6 +16438,28 @@
               <a:buNone/>
             </a:pPr>
             <a:r>
+              <a:rPr lang="en-US" sz="2700" dirty="0" spc="0" kern="0">
+                <a:solidFill>
+                  <a:srgbClr val="F3EEE3"/>
+                </a:solidFill>
+                <a:latin typeface="Be Vietnam Pro" pitchFamily="34" charset="0"/>
+                <a:ea typeface="Be Vietnam Pro" pitchFamily="34" charset="-122"/>
+                <a:cs typeface="Be Vietnam Pro" pitchFamily="34" charset="-120"/>
+              </a:rPr>
+              <a:t>Mỗi</a:t>
+            </a:r>
+            <a:r>
+              <a:rPr lang="en-US" sz="2700" dirty="0" spc="-2" kern="0">
+                <a:solidFill>
+                  <a:srgbClr val="F3EEE3"/>
+                </a:solidFill>
+                <a:latin typeface="Be Vietnam Pro" pitchFamily="34" charset="0"/>
+                <a:ea typeface="Be Vietnam Pro" pitchFamily="34" charset="-122"/>
+                <a:cs typeface="Be Vietnam Pro" pitchFamily="34" charset="-120"/>
+              </a:rPr>
+              <a:t> mô</a:t>
+            </a:r>
+            <a:r>
               <a:rPr lang="en-US" sz="2700" dirty="0" spc="-3" kern="0">
                 <a:solidFill>
                   <a:srgbClr val="F3EEE3"/>
@@ -16809,7 +16468,51 @@
                 <a:ea typeface="Be Vietnam Pro" pitchFamily="34" charset="-122"/>
                 <a:cs typeface="Be Vietnam Pro" pitchFamily="34" charset="-120"/>
               </a:rPr>
-              <a:t>Bốn mô hình</a:t>
+              <a:t> hình</a:t>
+            </a:r>
+            <a:r>
+              <a:rPr lang="en-US" sz="2700" dirty="0" spc="-15" kern="0">
+                <a:solidFill>
+                  <a:srgbClr val="F3EEE3"/>
+                </a:solidFill>
+                <a:latin typeface="Be Vietnam Pro" pitchFamily="34" charset="0"/>
+                <a:ea typeface="Be Vietnam Pro" pitchFamily="34" charset="-122"/>
+                <a:cs typeface="Be Vietnam Pro" pitchFamily="34" charset="-120"/>
+              </a:rPr>
+              <a:t> gặp</a:t>
+            </a:r>
+            <a:r>
+              <a:rPr lang="en-US" sz="2700" dirty="0" spc="0" kern="0">
+                <a:solidFill>
+                  <a:srgbClr val="F3EEE3"/>
+                </a:solidFill>
+                <a:latin typeface="Be Vietnam Pro" pitchFamily="34" charset="0"/>
+                <a:ea typeface="Be Vietnam Pro" pitchFamily="34" charset="-122"/>
+                <a:cs typeface="Be Vietnam Pro" pitchFamily="34" charset="-120"/>
+              </a:rPr>
+              <a:t> lại</a:t>
+            </a:r>
+            <a:r>
+              <a:rPr lang="en-US" sz="2700" dirty="0" spc="-20" kern="0">
+                <a:solidFill>
+                  <a:srgbClr val="F3EEE3"/>
+                </a:solidFill>
+                <a:latin typeface="Be Vietnam Pro" pitchFamily="34" charset="0"/>
+                <a:ea typeface="Be Vietnam Pro" pitchFamily="34" charset="-122"/>
+                <a:cs typeface="Be Vietnam Pro" pitchFamily="34" charset="-120"/>
+              </a:rPr>
+              <a:t> trong</a:t>
+            </a:r>
+            <a:r>
+              <a:rPr lang="en-US" sz="2700" dirty="0" spc="-13" kern="0">
+                <a:solidFill>
+                  <a:srgbClr val="F3EEE3"/>
+                </a:solidFill>
+                <a:latin typeface="Be Vietnam Pro" pitchFamily="34" charset="0"/>
+                <a:ea typeface="Be Vietnam Pro" pitchFamily="34" charset="-122"/>
+                <a:cs typeface="Be Vietnam Pro" pitchFamily="34" charset="-120"/>
+              </a:rPr>
+              <a:t> tài</a:t>
             </a:r>
             <a:r>
               <a:rPr lang="en-US" sz="2700" dirty="0" spc="-1" kern="0">
@@ -16820,18 +16523,7 @@
                 <a:ea typeface="Be Vietnam Pro" pitchFamily="34" charset="-122"/>
                 <a:cs typeface="Be Vietnam Pro" pitchFamily="34" charset="-120"/>
               </a:rPr>
-              <a:t> của</a:t>
-            </a:r>
-            <a:r>
-              <a:rPr lang="en-US" sz="2700" dirty="0" spc="-5" kern="0">
-                <a:solidFill>
-                  <a:srgbClr val="F3EEE3"/>
-                </a:solidFill>
-                <a:latin typeface="Be Vietnam Pro" pitchFamily="34" charset="0"/>
-                <a:ea typeface="Be Vietnam Pro" pitchFamily="34" charset="-122"/>
-                <a:cs typeface="Be Vietnam Pro" pitchFamily="34" charset="-120"/>
-              </a:rPr>
-              <a:t> bài</a:t>
+              <a:t> liệu</a:t>
             </a:r>
             <a:r>
               <a:rPr lang="en-US" sz="2700" dirty="0" spc="-15" kern="0">
@@ -16842,95 +16534,7 @@
                 <a:ea typeface="Be Vietnam Pro" pitchFamily="34" charset="-122"/>
                 <a:cs typeface="Be Vietnam Pro" pitchFamily="34" charset="-120"/>
               </a:rPr>
-              <a:t> gặp</a:t>
-            </a:r>
-            <a:r>
-              <a:rPr lang="en-US" sz="2700" dirty="0" spc="-1" kern="0">
-                <a:solidFill>
-                  <a:srgbClr val="F3EEE3"/>
-                </a:solidFill>
-                <a:latin typeface="Be Vietnam Pro" pitchFamily="34" charset="0"/>
-                <a:ea typeface="Be Vietnam Pro" pitchFamily="34" charset="-122"/>
-                <a:cs typeface="Be Vietnam Pro" pitchFamily="34" charset="-120"/>
-              </a:rPr>
-              <a:t> lại</a:t>
-            </a:r>
-            <a:r>
-              <a:rPr lang="en-US" sz="2700" dirty="0" spc="-20" kern="0">
-                <a:solidFill>
-                  <a:srgbClr val="F3EEE3"/>
-                </a:solidFill>
-                <a:latin typeface="Be Vietnam Pro" pitchFamily="34" charset="0"/>
-                <a:ea typeface="Be Vietnam Pro" pitchFamily="34" charset="-122"/>
-                <a:cs typeface="Be Vietnam Pro" pitchFamily="34" charset="-120"/>
-              </a:rPr>
-              <a:t> trong</a:t>
-            </a:r>
-            <a:r>
-              <a:rPr lang="en-US" sz="2700" dirty="0" spc="-12" kern="0">
-                <a:solidFill>
-                  <a:srgbClr val="F3EEE3"/>
-                </a:solidFill>
-                <a:latin typeface="Be Vietnam Pro" pitchFamily="34" charset="0"/>
-                <a:ea typeface="Be Vietnam Pro" pitchFamily="34" charset="-122"/>
-                <a:cs typeface="Be Vietnam Pro" pitchFamily="34" charset="-120"/>
-              </a:rPr>
-              <a:t> tài</a:t>
-            </a:r>
-            <a:r>
-              <a:rPr lang="en-US" sz="2700" dirty="0" spc="-1" kern="0">
-                <a:solidFill>
-                  <a:srgbClr val="F3EEE3"/>
-                </a:solidFill>
-                <a:latin typeface="Be Vietnam Pro" pitchFamily="34" charset="0"/>
-                <a:ea typeface="Be Vietnam Pro" pitchFamily="34" charset="-122"/>
-                <a:cs typeface="Be Vietnam Pro" pitchFamily="34" charset="-120"/>
-              </a:rPr>
-              <a:t> liệu</a:t>
-            </a:r>
-            <a:r>
-              <a:rPr lang="en-US" sz="2700" dirty="0" spc="-2" kern="0">
-                <a:solidFill>
-                  <a:srgbClr val="F3EEE3"/>
-                </a:solidFill>
-                <a:latin typeface="Be Vietnam Pro" pitchFamily="34" charset="0"/>
-                <a:ea typeface="Be Vietnam Pro" pitchFamily="34" charset="-122"/>
-                <a:cs typeface="Be Vietnam Pro" pitchFamily="34" charset="-120"/>
-              </a:rPr>
-              <a:t> của</a:t>
-            </a:r>
-            <a:r>
-              <a:rPr lang="en-US" sz="2700" dirty="0" spc="-8" kern="0">
-                <a:solidFill>
-                  <a:srgbClr val="F3EEE3"/>
-                </a:solidFill>
-                <a:latin typeface="Be Vietnam Pro" pitchFamily="34" charset="0"/>
-                <a:ea typeface="Be Vietnam Pro" pitchFamily="34" charset="-122"/>
-                <a:cs typeface="Be Vietnam Pro" pitchFamily="34" charset="-120"/>
-              </a:rPr>
-              <a:t> ba</a:t>
-            </a:r>
-            <a:r>
-              <a:rPr lang="en-US" sz="2700" dirty="0" spc="-14" kern="0">
-                <a:solidFill>
-                  <a:srgbClr val="F3EEE3"/>
-                </a:solidFill>
-                <a:latin typeface="Be Vietnam Pro" pitchFamily="34" charset="0"/>
-                <a:ea typeface="Be Vietnam Pro" pitchFamily="34" charset="-122"/>
-                <a:cs typeface="Be Vietnam Pro" pitchFamily="34" charset="-120"/>
-              </a:rPr>
-              <a:t> ngôn</a:t>
-            </a:r>
-            <a:r>
-              <a:rPr lang="en-US" sz="2700" dirty="0" spc="-3" kern="0">
-                <a:solidFill>
-                  <a:srgbClr val="F3EEE3"/>
-                </a:solidFill>
-                <a:latin typeface="Be Vietnam Pro" pitchFamily="34" charset="0"/>
-                <a:ea typeface="Be Vietnam Pro" pitchFamily="34" charset="-122"/>
-                <a:cs typeface="Be Vietnam Pro" pitchFamily="34" charset="-120"/>
-              </a:rPr>
-              <a:t> ngữ.</a:t>
+              <a:t> gốc.</a:t>
             </a:r>
             <a:endParaRPr lang="en-US" sz="2700" dirty="0"/>
           </a:p>
@@ -19731,6 +19335,28 @@
               <a:t> ngữ</a:t>
             </a:r>
             <a:r>
+              <a:rPr lang="en-US" sz="2550" dirty="0" spc="-1" kern="0">
+                <a:solidFill>
+                  <a:srgbClr val="14161C"/>
+                </a:solidFill>
+                <a:latin typeface="Be Vietnam Pro" pitchFamily="34" charset="0"/>
+                <a:ea typeface="Be Vietnam Pro" pitchFamily="34" charset="-122"/>
+                <a:cs typeface="Be Vietnam Pro" pitchFamily="34" charset="-120"/>
+              </a:rPr>
+              <a:t> của</a:t>
+            </a:r>
+            <a:r>
+              <a:rPr lang="en-US" sz="2550" dirty="0" spc="0" kern="0">
+                <a:solidFill>
+                  <a:srgbClr val="14161C"/>
+                </a:solidFill>
+                <a:latin typeface="Be Vietnam Pro" pitchFamily="34" charset="0"/>
+                <a:ea typeface="Be Vietnam Pro" pitchFamily="34" charset="-122"/>
+                <a:cs typeface="Be Vietnam Pro" pitchFamily="34" charset="-120"/>
+              </a:rPr>
+              <a:t> nguồn</a:t>
+            </a:r>
+            <a:r>
               <a:rPr lang="en-US" sz="2550" dirty="0" spc="1" kern="0">
                 <a:solidFill>
                   <a:srgbClr val="14161C"/>
@@ -19739,10 +19365,10 @@
                 <a:ea typeface="Be Vietnam Pro" pitchFamily="34" charset="-122"/>
                 <a:cs typeface="Be Vietnam Pro" pitchFamily="34" charset="-120"/>
               </a:rPr>
-              <a:t> là</a:t>
-            </a:r>
-            <a:r>
-              <a:rPr lang="en-US" sz="2550" dirty="0" spc="-1" kern="0">
+              <a:t> không</a:t>
+            </a:r>
+            <a:r>
+              <a:rPr lang="en-US" sz="2550" dirty="0" spc="6" kern="0">
                 <a:solidFill>
                   <a:srgbClr val="14161C"/>
                 </a:solidFill>
@@ -19750,10 +19376,10 @@
                 <a:ea typeface="Be Vietnam Pro" pitchFamily="34" charset="-122"/>
                 <a:cs typeface="Be Vietnam Pro" pitchFamily="34" charset="-120"/>
               </a:rPr>
-              <a:t> ví</a:t>
-            </a:r>
-            <a:r>
-              <a:rPr lang="en-US" sz="2550" dirty="0" spc="-2" kern="0">
+              <a:t> được</a:t>
+            </a:r>
+            <a:r>
+              <a:rPr lang="en-US" sz="2550" dirty="0" spc="1" kern="0">
                 <a:solidFill>
                   <a:srgbClr val="14161C"/>
                 </a:solidFill>
@@ -19761,84 +19387,7 @@
                 <a:ea typeface="Be Vietnam Pro" pitchFamily="34" charset="-122"/>
                 <a:cs typeface="Be Vietnam Pro" pitchFamily="34" charset="-120"/>
               </a:rPr>
-              <a:t> dụ của</a:t>
-            </a:r>
-            <a:r>
-              <a:rPr lang="en-US" sz="2550" dirty="0" spc="0" kern="0">
-                <a:solidFill>
-                  <a:srgbClr val="14161C"/>
-                </a:solidFill>
-                <a:latin typeface="Be Vietnam Pro" pitchFamily="34" charset="0"/>
-                <a:ea typeface="Be Vietnam Pro" pitchFamily="34" charset="-122"/>
-                <a:cs typeface="Be Vietnam Pro" pitchFamily="34" charset="-120"/>
-              </a:rPr>
-              <a:t> nguồn,</a:t>
-            </a:r>
-            <a:r>
-              <a:rPr lang="en-US" sz="2550" dirty="0" spc="-3" kern="0">
-                <a:solidFill>
-                  <a:srgbClr val="14161C"/>
-                </a:solidFill>
-                <a:latin typeface="Be Vietnam Pro" pitchFamily="34" charset="0"/>
-                <a:ea typeface="Be Vietnam Pro" pitchFamily="34" charset="-122"/>
-                <a:cs typeface="Be Vietnam Pro" pitchFamily="34" charset="-120"/>
-              </a:rPr>
-              <a:t> bài</a:t>
-            </a:r>
-            <a:r>
-              <a:rPr lang="en-US" sz="2550" dirty="0" spc="6" kern="0">
-                <a:solidFill>
-                  <a:srgbClr val="14161C"/>
-                </a:solidFill>
-                <a:latin typeface="Be Vietnam Pro" pitchFamily="34" charset="0"/>
-                <a:ea typeface="Be Vietnam Pro" pitchFamily="34" charset="-122"/>
-                <a:cs typeface="Be Vietnam Pro" pitchFamily="34" charset="-120"/>
-              </a:rPr>
-              <a:t> chưa</a:t>
-            </a:r>
-            <a:r>
-              <a:rPr lang="en-US" sz="2550" dirty="0" spc="1" kern="0">
-                <a:solidFill>
-                  <a:srgbClr val="14161C"/>
-                </a:solidFill>
-                <a:latin typeface="Be Vietnam Pro" pitchFamily="34" charset="0"/>
-                <a:ea typeface="Be Vietnam Pro" pitchFamily="34" charset="-122"/>
-                <a:cs typeface="Be Vietnam Pro" pitchFamily="34" charset="-120"/>
-              </a:rPr>
-              <a:t> kiểm</a:t>
-            </a:r>
-            <a:r>
-              <a:rPr lang="en-US" sz="2550" dirty="0" spc="-24" kern="0">
-                <a:solidFill>
-                  <a:srgbClr val="14161C"/>
-                </a:solidFill>
-                <a:latin typeface="Be Vietnam Pro" pitchFamily="34" charset="0"/>
-                <a:ea typeface="Be Vietnam Pro" pitchFamily="34" charset="-122"/>
-                <a:cs typeface="Be Vietnam Pro" pitchFamily="34" charset="-120"/>
-              </a:rPr>
-              <a:t> tra</a:t>
-            </a:r>
-            <a:r>
-              <a:rPr lang="en-US" sz="2550" dirty="0" spc="20" kern="0">
-                <a:solidFill>
-                  <a:srgbClr val="14161C"/>
-                </a:solidFill>
-                <a:latin typeface="Be Vietnam Pro" pitchFamily="34" charset="0"/>
-                <a:ea typeface="Be Vietnam Pro" pitchFamily="34" charset="-122"/>
-                <a:cs typeface="Be Vietnam Pro" pitchFamily="34" charset="-120"/>
-              </a:rPr>
-              <a:t> từng</a:t>
-            </a:r>
-            <a:r>
-              <a:rPr lang="en-US" sz="2550" dirty="0" spc="1" kern="0">
-                <a:solidFill>
-                  <a:srgbClr val="14161C"/>
-                </a:solidFill>
-                <a:latin typeface="Be Vietnam Pro" pitchFamily="34" charset="0"/>
-                <a:ea typeface="Be Vietnam Pro" pitchFamily="34" charset="-122"/>
-                <a:cs typeface="Be Vietnam Pro" pitchFamily="34" charset="-120"/>
-              </a:rPr>
-              <a:t> cái.</a:t>
+              <a:t> lặp lại.</a:t>
             </a:r>
             <a:endParaRPr lang="en-US" sz="2550" dirty="0"/>
           </a:p>
@@ -22037,15 +21586,15 @@
               <a:t> nào</a:t>
             </a:r>
             <a:r>
-              <a:rPr lang="en-US" sz="2700" dirty="0" spc="-21" kern="0">
-                <a:solidFill>
-                  <a:srgbClr val="F3EEE3"/>
-                </a:solidFill>
-                <a:latin typeface="Be Vietnam Pro" pitchFamily="34" charset="0"/>
-                <a:ea typeface="Be Vietnam Pro" pitchFamily="34" charset="-122"/>
-                <a:cs typeface="Be Vietnam Pro" pitchFamily="34" charset="-120"/>
-              </a:rPr>
-              <a:t> xem</a:t>
+              <a:rPr lang="en-US" sz="2700" dirty="0" spc="-1" kern="0">
+                <a:solidFill>
+                  <a:srgbClr val="F3EEE3"/>
+                </a:solidFill>
+                <a:latin typeface="Be Vietnam Pro" pitchFamily="34" charset="0"/>
+                <a:ea typeface="Be Vietnam Pro" pitchFamily="34" charset="-122"/>
+                <a:cs typeface="Be Vietnam Pro" pitchFamily="34" charset="-120"/>
+              </a:rPr>
+              <a:t> chia</a:t>
             </a:r>
             <a:r>
               <a:rPr lang="en-US" sz="2700" dirty="0" spc="-2" kern="0">
@@ -22056,7 +21605,51 @@
                 <a:ea typeface="Be Vietnam Pro" pitchFamily="34" charset="-122"/>
                 <a:cs typeface="Be Vietnam Pro" pitchFamily="34" charset="-120"/>
               </a:rPr>
-              <a:t> tính</a:t>
+              <a:t> việc</a:t>
+            </a:r>
+            <a:r>
+              <a:rPr lang="en-US" sz="2700" dirty="0" spc="-1" kern="0">
+                <a:solidFill>
+                  <a:srgbClr val="F3EEE3"/>
+                </a:solidFill>
+                <a:latin typeface="Be Vietnam Pro" pitchFamily="34" charset="0"/>
+                <a:ea typeface="Be Vietnam Pro" pitchFamily="34" charset="-122"/>
+                <a:cs typeface="Be Vietnam Pro" pitchFamily="34" charset="-120"/>
+              </a:rPr>
+              <a:t> thành</a:t>
+            </a:r>
+            <a:r>
+              <a:rPr lang="en-US" sz="2700" dirty="0" spc="2" kern="0">
+                <a:solidFill>
+                  <a:srgbClr val="F3EEE3"/>
+                </a:solidFill>
+                <a:latin typeface="Be Vietnam Pro" pitchFamily="34" charset="0"/>
+                <a:ea typeface="Be Vietnam Pro" pitchFamily="34" charset="-122"/>
+                <a:cs typeface="Be Vietnam Pro" pitchFamily="34" charset="-120"/>
+              </a:rPr>
+              <a:t> các</a:t>
+            </a:r>
+            <a:r>
+              <a:rPr lang="en-US" sz="2700" dirty="0" spc="-1" kern="0">
+                <a:solidFill>
+                  <a:srgbClr val="F3EEE3"/>
+                </a:solidFill>
+                <a:latin typeface="Be Vietnam Pro" pitchFamily="34" charset="0"/>
+                <a:ea typeface="Be Vietnam Pro" pitchFamily="34" charset="-122"/>
+                <a:cs typeface="Be Vietnam Pro" pitchFamily="34" charset="-120"/>
+              </a:rPr>
+              <a:t> hàm chỉ</a:t>
+            </a:r>
+            <a:r>
+              <a:rPr lang="en-US" sz="2700" dirty="0" spc="-2" kern="0">
+                <a:solidFill>
+                  <a:srgbClr val="F3EEE3"/>
+                </a:solidFill>
+                <a:latin typeface="Be Vietnam Pro" pitchFamily="34" charset="0"/>
+                <a:ea typeface="Be Vietnam Pro" pitchFamily="34" charset="-122"/>
+                <a:cs typeface="Be Vietnam Pro" pitchFamily="34" charset="-120"/>
+              </a:rPr>
+              <a:t> nhận</a:t>
             </a:r>
             <a:r>
               <a:rPr lang="en-US" sz="2700" dirty="0" spc="-14" kern="0">
@@ -22067,106 +21660,40 @@
                 <a:ea typeface="Be Vietnam Pro" pitchFamily="34" charset="-122"/>
                 <a:cs typeface="Be Vietnam Pro" pitchFamily="34" charset="-120"/>
               </a:rPr>
-              <a:t> toán</a:t>
-            </a:r>
-            <a:r>
-              <a:rPr lang="en-US" sz="2700" dirty="0" spc="-1" kern="0">
-                <a:solidFill>
-                  <a:srgbClr val="F3EEE3"/>
-                </a:solidFill>
-                <a:latin typeface="Be Vietnam Pro" pitchFamily="34" charset="0"/>
-                <a:ea typeface="Be Vietnam Pro" pitchFamily="34" charset="-122"/>
-                <a:cs typeface="Be Vietnam Pro" pitchFamily="34" charset="-120"/>
-              </a:rPr>
-              <a:t> là tính giá</a:t>
-            </a:r>
-            <a:r>
-              <a:rPr lang="en-US" sz="2700" dirty="0" spc="11" kern="0">
-                <a:solidFill>
-                  <a:srgbClr val="F3EEE3"/>
-                </a:solidFill>
-                <a:latin typeface="Be Vietnam Pro" pitchFamily="34" charset="0"/>
-                <a:ea typeface="Be Vietnam Pro" pitchFamily="34" charset="-122"/>
-                <a:cs typeface="Be Vietnam Pro" pitchFamily="34" charset="-120"/>
-              </a:rPr>
-              <a:t> trị</a:t>
-            </a:r>
-            <a:r>
-              <a:rPr lang="en-US" sz="2700" dirty="0" spc="0" kern="0">
-                <a:solidFill>
-                  <a:srgbClr val="F3EEE3"/>
-                </a:solidFill>
-                <a:latin typeface="Be Vietnam Pro" pitchFamily="34" charset="0"/>
-                <a:ea typeface="Be Vietnam Pro" pitchFamily="34" charset="-122"/>
-                <a:cs typeface="Be Vietnam Pro" pitchFamily="34" charset="-120"/>
-              </a:rPr>
-              <a:t> hàm,</a:t>
-            </a:r>
-            <a:r>
-              <a:rPr lang="en-US" sz="2700" dirty="0" spc="29" kern="0">
-                <a:solidFill>
-                  <a:srgbClr val="F3EEE3"/>
-                </a:solidFill>
-                <a:latin typeface="Be Vietnam Pro" pitchFamily="34" charset="0"/>
-                <a:ea typeface="Be Vietnam Pro" pitchFamily="34" charset="-122"/>
-                <a:cs typeface="Be Vietnam Pro" pitchFamily="34" charset="-120"/>
-              </a:rPr>
-              <a:t> ưu</a:t>
-            </a:r>
-            <a:r>
-              <a:rPr lang="en-US" sz="2700" dirty="0" spc="-2" kern="0">
-                <a:solidFill>
-                  <a:srgbClr val="F3EEE3"/>
-                </a:solidFill>
-                <a:latin typeface="Be Vietnam Pro" pitchFamily="34" charset="0"/>
-                <a:ea typeface="Be Vietnam Pro" pitchFamily="34" charset="-122"/>
-                <a:cs typeface="Be Vietnam Pro" pitchFamily="34" charset="-120"/>
-              </a:rPr>
-              <a:t> tiên</a:t>
-            </a:r>
-            <a:r>
-              <a:rPr lang="en-US" sz="2700" dirty="0" spc="-3" kern="0">
-                <a:solidFill>
-                  <a:srgbClr val="F3EEE3"/>
-                </a:solidFill>
-                <a:latin typeface="Be Vietnam Pro" pitchFamily="34" charset="0"/>
-                <a:ea typeface="Be Vietnam Pro" pitchFamily="34" charset="-122"/>
-                <a:cs typeface="Be Vietnam Pro" pitchFamily="34" charset="-120"/>
-              </a:rPr>
-              <a:t> dữ</a:t>
-            </a:r>
-            <a:r>
-              <a:rPr lang="en-US" sz="2700" dirty="0" spc="-1" kern="0">
-                <a:solidFill>
-                  <a:srgbClr val="F3EEE3"/>
-                </a:solidFill>
-                <a:latin typeface="Be Vietnam Pro" pitchFamily="34" charset="0"/>
-                <a:ea typeface="Be Vietnam Pro" pitchFamily="34" charset="-122"/>
-                <a:cs typeface="Be Vietnam Pro" pitchFamily="34" charset="-120"/>
-              </a:rPr>
-              <a:t> liệu</a:t>
-            </a:r>
-            <a:r>
-              <a:rPr lang="en-US" sz="2700" dirty="0" spc="-17" kern="0">
-                <a:solidFill>
-                  <a:srgbClr val="F3EEE3"/>
-                </a:solidFill>
-                <a:latin typeface="Be Vietnam Pro" pitchFamily="34" charset="0"/>
-                <a:ea typeface="Be Vietnam Pro" pitchFamily="34" charset="-122"/>
-                <a:cs typeface="Be Vietnam Pro" pitchFamily="34" charset="-120"/>
-              </a:rPr>
-              <a:t> bất</a:t>
-            </a:r>
-            <a:r>
-              <a:rPr lang="en-US" sz="2700" dirty="0" spc="-3" kern="0">
-                <a:solidFill>
-                  <a:srgbClr val="F3EEE3"/>
-                </a:solidFill>
-                <a:latin typeface="Be Vietnam Pro" pitchFamily="34" charset="0"/>
-                <a:ea typeface="Be Vietnam Pro" pitchFamily="34" charset="-122"/>
-                <a:cs typeface="Be Vietnam Pro" pitchFamily="34" charset="-120"/>
-              </a:rPr>
-              <a:t> biến?</a:t>
+              <a:t> vào</a:t>
+            </a:r>
+            <a:r>
+              <a:rPr lang="en-US" sz="2700" dirty="0" spc="-18" kern="0">
+                <a:solidFill>
+                  <a:srgbClr val="F3EEE3"/>
+                </a:solidFill>
+                <a:latin typeface="Be Vietnam Pro" pitchFamily="34" charset="0"/>
+                <a:ea typeface="Be Vietnam Pro" pitchFamily="34" charset="-122"/>
+                <a:cs typeface="Be Vietnam Pro" pitchFamily="34" charset="-120"/>
+              </a:rPr>
+              <a:t> và</a:t>
+            </a:r>
+            <a:r>
+              <a:rPr lang="en-US" sz="2700" dirty="0" spc="-27" kern="0">
+                <a:solidFill>
+                  <a:srgbClr val="F3EEE3"/>
+                </a:solidFill>
+                <a:latin typeface="Be Vietnam Pro" pitchFamily="34" charset="0"/>
+                <a:ea typeface="Be Vietnam Pro" pitchFamily="34" charset="-122"/>
+                <a:cs typeface="Be Vietnam Pro" pitchFamily="34" charset="-120"/>
+              </a:rPr>
+              <a:t> trả</a:t>
+            </a:r>
+            <a:r>
+              <a:rPr lang="en-US" sz="2700" dirty="0" spc="-31" kern="0">
+                <a:solidFill>
+                  <a:srgbClr val="F3EEE3"/>
+                </a:solidFill>
+                <a:latin typeface="Be Vietnam Pro" pitchFamily="34" charset="0"/>
+                <a:ea typeface="Be Vietnam Pro" pitchFamily="34" charset="-122"/>
+                <a:cs typeface="Be Vietnam Pro" pitchFamily="34" charset="-120"/>
+              </a:rPr>
+              <a:t> ra?</a:t>
             </a:r>
             <a:endParaRPr lang="en-US" sz="2700" dirty="0"/>
           </a:p>
@@ -22714,6 +22241,39 @@
               <a:buNone/>
             </a:pPr>
             <a:r>
+              <a:rPr lang="en-US" sz="2250" dirty="0" spc="-5" kern="0">
+                <a:solidFill>
+                  <a:srgbClr val="C4C8D6"/>
+                </a:solidFill>
+                <a:latin typeface="Be Vietnam Pro" pitchFamily="34" charset="0"/>
+                <a:ea typeface="Be Vietnam Pro" pitchFamily="34" charset="-122"/>
+                <a:cs typeface="Be Vietnam Pro" pitchFamily="34" charset="-120"/>
+              </a:rPr>
+              <a:t>Chia</a:t>
+            </a:r>
+            <a:r>
+              <a:rPr lang="en-US" sz="2250" dirty="0" spc="-3" kern="0">
+                <a:solidFill>
+                  <a:srgbClr val="C4C8D6"/>
+                </a:solidFill>
+                <a:latin typeface="Be Vietnam Pro" pitchFamily="34" charset="0"/>
+                <a:ea typeface="Be Vietnam Pro" pitchFamily="34" charset="-122"/>
+                <a:cs typeface="Be Vietnam Pro" pitchFamily="34" charset="-120"/>
+              </a:rPr>
+              <a:t> việc</a:t>
+            </a:r>
+            <a:r>
+              <a:rPr lang="en-US" sz="2250" dirty="0" spc="0" kern="0">
+                <a:solidFill>
+                  <a:srgbClr val="C4C8D6"/>
+                </a:solidFill>
+                <a:latin typeface="Be Vietnam Pro" pitchFamily="34" charset="0"/>
+                <a:ea typeface="Be Vietnam Pro" pitchFamily="34" charset="-122"/>
+                <a:cs typeface="Be Vietnam Pro" pitchFamily="34" charset="-120"/>
+              </a:rPr>
+              <a:t> thành</a:t>
+            </a:r>
+            <a:r>
               <a:rPr lang="en-US" sz="2250" dirty="0" spc="-1" kern="0">
                 <a:solidFill>
                   <a:srgbClr val="C4C8D6"/>
@@ -22722,10 +22282,10 @@
                 <a:ea typeface="Be Vietnam Pro" pitchFamily="34" charset="-122"/>
                 <a:cs typeface="Be Vietnam Pro" pitchFamily="34" charset="-120"/>
               </a:rPr>
-              <a:t>Tính</a:t>
-            </a:r>
-            <a:r>
-              <a:rPr lang="en-US" sz="2250" dirty="0" spc="-2" kern="0">
+              <a:t> hàm</a:t>
+            </a:r>
+            <a:r>
+              <a:rPr lang="en-US" sz="2250" dirty="0" spc="0" kern="0">
                 <a:solidFill>
                   <a:srgbClr val="C4C8D6"/>
                 </a:solidFill>
@@ -22733,10 +22293,10 @@
                 <a:ea typeface="Be Vietnam Pro" pitchFamily="34" charset="-122"/>
                 <a:cs typeface="Be Vietnam Pro" pitchFamily="34" charset="-120"/>
               </a:rPr>
-              <a:t> giá</a:t>
-            </a:r>
-            <a:r>
-              <a:rPr lang="en-US" sz="2250" dirty="0" spc="10" kern="0">
+              <a:t> nhận</a:t>
+            </a:r>
+            <a:r>
+              <a:rPr lang="en-US" sz="2250" dirty="0" spc="-12" kern="0">
                 <a:solidFill>
                   <a:srgbClr val="C4C8D6"/>
                 </a:solidFill>
@@ -22744,10 +22304,10 @@
                 <a:ea typeface="Be Vietnam Pro" pitchFamily="34" charset="-122"/>
                 <a:cs typeface="Be Vietnam Pro" pitchFamily="34" charset="-120"/>
               </a:rPr>
-              <a:t> trị</a:t>
-            </a:r>
-            <a:r>
-              <a:rPr lang="en-US" sz="2250" dirty="0" spc="2" kern="0">
+              <a:t> vào,</a:t>
+            </a:r>
+            <a:r>
+              <a:rPr lang="en-US" sz="2250" dirty="0" spc="-24" kern="0">
                 <a:solidFill>
                   <a:srgbClr val="C4C8D6"/>
                 </a:solidFill>
@@ -22755,10 +22315,10 @@
                 <a:ea typeface="Be Vietnam Pro" pitchFamily="34" charset="-122"/>
                 <a:cs typeface="Be Vietnam Pro" pitchFamily="34" charset="-120"/>
               </a:rPr>
-              <a:t> các</a:t>
-            </a:r>
-            <a:r>
-              <a:rPr lang="en-US" sz="2250" dirty="0" spc="-1" kern="0">
+              <a:t> trả</a:t>
+            </a:r>
+            <a:r>
+              <a:rPr lang="en-US" sz="2250" dirty="0" spc="-22" kern="0">
                 <a:solidFill>
                   <a:srgbClr val="C4C8D6"/>
                 </a:solidFill>
@@ -22766,84 +22326,7 @@
                 <a:ea typeface="Be Vietnam Pro" pitchFamily="34" charset="-122"/>
                 <a:cs typeface="Be Vietnam Pro" pitchFamily="34" charset="-120"/>
               </a:rPr>
-              <a:t> hàm</a:t>
-            </a:r>
-            <a:r>
-              <a:rPr lang="en-US" sz="2250" dirty="0" spc="-12" kern="0">
-                <a:solidFill>
-                  <a:srgbClr val="C4C8D6"/>
-                </a:solidFill>
-                <a:latin typeface="Be Vietnam Pro" pitchFamily="34" charset="0"/>
-                <a:ea typeface="Be Vietnam Pro" pitchFamily="34" charset="-122"/>
-                <a:cs typeface="Be Vietnam Pro" pitchFamily="34" charset="-120"/>
-              </a:rPr>
-              <a:t> toán</a:t>
-            </a:r>
-            <a:r>
-              <a:rPr lang="en-US" sz="2250" dirty="0" spc="-1" kern="0">
-                <a:solidFill>
-                  <a:srgbClr val="C4C8D6"/>
-                </a:solidFill>
-                <a:latin typeface="Be Vietnam Pro" pitchFamily="34" charset="0"/>
-                <a:ea typeface="Be Vietnam Pro" pitchFamily="34" charset="-122"/>
-                <a:cs typeface="Be Vietnam Pro" pitchFamily="34" charset="-120"/>
-              </a:rPr>
-              <a:t> học,</a:t>
-            </a:r>
-            <a:r>
-              <a:rPr lang="en-US" sz="2250" dirty="0" spc="0" kern="0">
-                <a:solidFill>
-                  <a:srgbClr val="C4C8D6"/>
-                </a:solidFill>
-                <a:latin typeface="Be Vietnam Pro" pitchFamily="34" charset="0"/>
-                <a:ea typeface="Be Vietnam Pro" pitchFamily="34" charset="-122"/>
-                <a:cs typeface="Be Vietnam Pro" pitchFamily="34" charset="-120"/>
-              </a:rPr>
-              <a:t> nhấn mạnh</a:t>
-            </a:r>
-            <a:r>
-              <a:rPr lang="en-US" sz="2250" dirty="0" spc="4" kern="0">
-                <a:solidFill>
-                  <a:srgbClr val="C4C8D6"/>
-                </a:solidFill>
-                <a:latin typeface="Be Vietnam Pro" pitchFamily="34" charset="0"/>
-                <a:ea typeface="Be Vietnam Pro" pitchFamily="34" charset="-122"/>
-                <a:cs typeface="Be Vietnam Pro" pitchFamily="34" charset="-120"/>
-              </a:rPr>
-              <a:t> dữ</a:t>
-            </a:r>
-            <a:r>
-              <a:rPr lang="en-US" sz="2250" dirty="0" spc="-2" kern="0">
-                <a:solidFill>
-                  <a:srgbClr val="C4C8D6"/>
-                </a:solidFill>
-                <a:latin typeface="Be Vietnam Pro" pitchFamily="34" charset="0"/>
-                <a:ea typeface="Be Vietnam Pro" pitchFamily="34" charset="-122"/>
-                <a:cs typeface="Be Vietnam Pro" pitchFamily="34" charset="-120"/>
-              </a:rPr>
-              <a:t> liệu</a:t>
-            </a:r>
-            <a:r>
-              <a:rPr lang="en-US" sz="2250" dirty="0" spc="-12" kern="0">
-                <a:solidFill>
-                  <a:srgbClr val="C4C8D6"/>
-                </a:solidFill>
-                <a:latin typeface="Be Vietnam Pro" pitchFamily="34" charset="0"/>
-                <a:ea typeface="Be Vietnam Pro" pitchFamily="34" charset="-122"/>
-                <a:cs typeface="Be Vietnam Pro" pitchFamily="34" charset="-120"/>
-              </a:rPr>
-              <a:t> bất</a:t>
-            </a:r>
-            <a:r>
-              <a:rPr lang="en-US" sz="2250" dirty="0" spc="1" kern="0">
-                <a:solidFill>
-                  <a:srgbClr val="C4C8D6"/>
-                </a:solidFill>
-                <a:latin typeface="Be Vietnam Pro" pitchFamily="34" charset="0"/>
-                <a:ea typeface="Be Vietnam Pro" pitchFamily="34" charset="-122"/>
-                <a:cs typeface="Be Vietnam Pro" pitchFamily="34" charset="-120"/>
-              </a:rPr>
-              <a:t> biến.</a:t>
+              <a:t> ra.</a:t>
             </a:r>
             <a:endParaRPr lang="en-US" sz="2250" dirty="0"/>
           </a:p>
@@ -23424,10 +22907,10 @@
                 <a:ea typeface="Be Vietnam Pro" pitchFamily="34" charset="-122"/>
                 <a:cs typeface="Be Vietnam Pro" pitchFamily="34" charset="-120"/>
               </a:rPr>
-              <a:t>Nêu</a:t>
-            </a:r>
-            <a:r>
-              <a:rPr lang="en-US" sz="2250" dirty="0" spc="-1" kern="0">
+              <a:t>Nêu bài</a:t>
+            </a:r>
+            <a:r>
+              <a:rPr lang="en-US" sz="2250" dirty="0" spc="-11" kern="0">
                 <a:solidFill>
                   <a:srgbClr val="C4C8D6"/>
                 </a:solidFill>
@@ -23435,18 +22918,7 @@
                 <a:ea typeface="Be Vietnam Pro" pitchFamily="34" charset="-122"/>
                 <a:cs typeface="Be Vietnam Pro" pitchFamily="34" charset="-120"/>
               </a:rPr>
-              <a:t> cái</a:t>
-            </a:r>
-            <a:r>
-              <a:rPr lang="en-US" sz="2250" dirty="0" spc="2" kern="0">
-                <a:solidFill>
-                  <a:srgbClr val="C4C8D6"/>
-                </a:solidFill>
-                <a:latin typeface="Be Vietnam Pro" pitchFamily="34" charset="0"/>
-                <a:ea typeface="Be Vietnam Pro" pitchFamily="34" charset="-122"/>
-                <a:cs typeface="Be Vietnam Pro" pitchFamily="34" charset="-120"/>
-              </a:rPr>
-              <a:t> cần có,</a:t>
+              <a:t> toán,</a:t>
             </a:r>
             <a:endParaRPr lang="en-US" sz="2250" dirty="0"/>
           </a:p>
@@ -23455,7 +22927,7 @@
               <a:buNone/>
             </a:pPr>
             <a:r>
-              <a:rPr lang="en-US" sz="2250" dirty="0" spc="0" kern="0">
+              <a:rPr lang="en-US" sz="2250" dirty="0" spc="21" kern="0">
                 <a:solidFill>
                   <a:srgbClr val="C4C8D6"/>
                 </a:solidFill>
@@ -23463,7 +22935,18 @@
                 <a:ea typeface="Be Vietnam Pro" pitchFamily="34" charset="-122"/>
                 <a:cs typeface="Be Vietnam Pro" pitchFamily="34" charset="-120"/>
               </a:rPr>
-              <a:t>không nêu</a:t>
+              <a:t>để</a:t>
+            </a:r>
+            <a:r>
+              <a:rPr lang="en-US" sz="2250" dirty="0" spc="-1" kern="0">
+                <a:solidFill>
+                  <a:srgbClr val="C4C8D6"/>
+                </a:solidFill>
+                <a:latin typeface="Be Vietnam Pro" pitchFamily="34" charset="0"/>
+                <a:ea typeface="Be Vietnam Pro" pitchFamily="34" charset="-122"/>
+                <a:cs typeface="Be Vietnam Pro" pitchFamily="34" charset="-120"/>
+              </a:rPr>
+              <a:t> cài</a:t>
             </a:r>
             <a:r>
               <a:rPr lang="en-US" sz="2250" dirty="0" spc="1" kern="0">
@@ -23474,10 +22957,10 @@
                 <a:ea typeface="Be Vietnam Pro" pitchFamily="34" charset="-122"/>
                 <a:cs typeface="Be Vietnam Pro" pitchFamily="34" charset="-120"/>
               </a:rPr>
-              <a:t> luồng</a:t>
-            </a:r>
-            <a:r>
-              <a:rPr lang="en-US" sz="2250" dirty="0" spc="17" kern="0">
+              <a:t> đặt</a:t>
+            </a:r>
+            <a:r>
+              <a:rPr lang="en-US" sz="2250" dirty="0" spc="3" kern="0">
                 <a:solidFill>
                   <a:srgbClr val="C4C8D6"/>
                 </a:solidFill>
@@ -23485,10 +22968,10 @@
                 <a:ea typeface="Be Vietnam Pro" pitchFamily="34" charset="-122"/>
                 <a:cs typeface="Be Vietnam Pro" pitchFamily="34" charset="-120"/>
               </a:rPr>
-              <a:t> điều</a:t>
-            </a:r>
-            <a:r>
-              <a:rPr lang="en-US" sz="2250" dirty="0" spc="0" kern="0">
+              <a:t> chọn</a:t>
+            </a:r>
+            <a:r>
+              <a:rPr lang="en-US" sz="2250" dirty="0" spc="1" kern="0">
                 <a:solidFill>
                   <a:srgbClr val="C4C8D6"/>
                 </a:solidFill>
@@ -23496,7 +22979,18 @@
                 <a:ea typeface="Be Vietnam Pro" pitchFamily="34" charset="-122"/>
                 <a:cs typeface="Be Vietnam Pro" pitchFamily="34" charset="-120"/>
               </a:rPr>
-              <a:t> khiển.</a:t>
+              <a:t> cách</a:t>
+            </a:r>
+            <a:r>
+              <a:rPr lang="en-US" sz="2250" dirty="0" spc="-1" kern="0">
+                <a:solidFill>
+                  <a:srgbClr val="C4C8D6"/>
+                </a:solidFill>
+                <a:latin typeface="Be Vietnam Pro" pitchFamily="34" charset="0"/>
+                <a:ea typeface="Be Vietnam Pro" pitchFamily="34" charset="-122"/>
+                <a:cs typeface="Be Vietnam Pro" pitchFamily="34" charset="-120"/>
+              </a:rPr>
+              <a:t> giải.</a:t>
             </a:r>
             <a:endParaRPr lang="en-US" sz="2250" dirty="0"/>
           </a:p>
@@ -23527,7 +23021,7 @@
               <a:buNone/>
             </a:pPr>
             <a:r>
-              <a:rPr lang="en-US" sz="2250" dirty="0" spc="0" kern="0">
+              <a:rPr lang="en-US" sz="2250" dirty="0" spc="-5" kern="0">
                 <a:solidFill>
                   <a:srgbClr val="C4C8D6"/>
                 </a:solidFill>
@@ -23535,10 +23029,10 @@
                 <a:ea typeface="Be Vietnam Pro" pitchFamily="34" charset="-122"/>
                 <a:cs typeface="Be Vietnam Pro" pitchFamily="34" charset="-120"/>
               </a:rPr>
-              <a:t>Nguồn</a:t>
-            </a:r>
-            <a:r>
-              <a:rPr lang="en-US" sz="2250" dirty="0" spc="1" kern="0">
+              <a:t>Hàm</a:t>
+            </a:r>
+            <a:r>
+              <a:rPr lang="en-US" sz="2250" dirty="0" spc="-16" kern="0">
                 <a:solidFill>
                   <a:srgbClr val="C4C8D6"/>
                 </a:solidFill>
@@ -23546,10 +23040,10 @@
                 <a:ea typeface="Be Vietnam Pro" pitchFamily="34" charset="-122"/>
                 <a:cs typeface="Be Vietnam Pro" pitchFamily="34" charset="-120"/>
               </a:rPr>
-              <a:t> nói</a:t>
-            </a:r>
-            <a:r>
-              <a:rPr lang="en-US" sz="2250" dirty="0" spc="-1" kern="0">
+              <a:t> và</a:t>
+            </a:r>
+            <a:r>
+              <a:rPr lang="en-US" sz="2250" dirty="0" spc="-2" kern="0">
                 <a:solidFill>
                   <a:srgbClr val="C4C8D6"/>
                 </a:solidFill>
@@ -23557,10 +23051,10 @@
                 <a:ea typeface="Be Vietnam Pro" pitchFamily="34" charset="-122"/>
                 <a:cs typeface="Be Vietnam Pro" pitchFamily="34" charset="-120"/>
               </a:rPr>
-              <a:t> hàm là</a:t>
-            </a:r>
-            <a:r>
-              <a:rPr lang="en-US" sz="2250" dirty="0" spc="-4" kern="0">
+              <a:t> khai</a:t>
+            </a:r>
+            <a:r>
+              <a:rPr lang="en-US" sz="2250" dirty="0" spc="-3" kern="0">
                 <a:solidFill>
                   <a:srgbClr val="C4C8D6"/>
                 </a:solidFill>
@@ -23568,10 +23062,10 @@
                 <a:ea typeface="Be Vietnam Pro" pitchFamily="34" charset="-122"/>
                 <a:cs typeface="Be Vietnam Pro" pitchFamily="34" charset="-120"/>
               </a:rPr>
-              <a:t> một</a:t>
-            </a:r>
-            <a:r>
-              <a:rPr lang="en-US" sz="2250" dirty="0" spc="0" kern="0">
+              <a:t> báo</a:t>
+            </a:r>
+            <a:r>
+              <a:rPr lang="en-US" sz="2250" dirty="0" spc="2" kern="0">
                 <a:solidFill>
                   <a:srgbClr val="C4C8D6"/>
                 </a:solidFill>
@@ -23579,7 +23073,7 @@
                 <a:ea typeface="Be Vietnam Pro" pitchFamily="34" charset="-122"/>
                 <a:cs typeface="Be Vietnam Pro" pitchFamily="34" charset="-120"/>
               </a:rPr>
-              <a:t> dạng</a:t>
+              <a:t> cùng nhóm</a:t>
             </a:r>
             <a:endParaRPr lang="en-US" sz="2250" dirty="0"/>
           </a:p>
@@ -23588,7 +23082,7 @@
               <a:buNone/>
             </a:pPr>
             <a:r>
-              <a:rPr lang="en-US" sz="2250" dirty="0" spc="3" kern="0">
+              <a:rPr lang="en-US" sz="2250" dirty="0" spc="-5" kern="0">
                 <a:solidFill>
                   <a:srgbClr val="C4C8D6"/>
                 </a:solidFill>
@@ -23596,10 +23090,10 @@
                 <a:ea typeface="Be Vietnam Pro" pitchFamily="34" charset="-122"/>
                 <a:cs typeface="Be Vietnam Pro" pitchFamily="34" charset="-120"/>
               </a:rPr>
-              <a:t>phổ</a:t>
-            </a:r>
-            <a:r>
-              <a:rPr lang="en-US" sz="2250" dirty="0" spc="0" kern="0">
+              <a:t>theo</a:t>
+            </a:r>
+            <a:r>
+              <a:rPr lang="en-US" sz="2250" dirty="0" spc="2" kern="0">
                 <a:solidFill>
                   <a:srgbClr val="C4C8D6"/>
                 </a:solidFill>
@@ -23607,7 +23101,18 @@
                 <a:ea typeface="Be Vietnam Pro" pitchFamily="34" charset="-122"/>
                 <a:cs typeface="Be Vietnam Pro" pitchFamily="34" charset="-120"/>
               </a:rPr>
-              <a:t> biến</a:t>
+              <a:t> cách</a:t>
+            </a:r>
+            <a:r>
+              <a:rPr lang="en-US" sz="2250" dirty="0" spc="-1" kern="0">
+                <a:solidFill>
+                  <a:srgbClr val="C4C8D6"/>
+                </a:solidFill>
+                <a:latin typeface="Be Vietnam Pro" pitchFamily="34" charset="0"/>
+                <a:ea typeface="Be Vietnam Pro" pitchFamily="34" charset="-122"/>
+                <a:cs typeface="Be Vietnam Pro" pitchFamily="34" charset="-120"/>
+              </a:rPr>
+              <a:t> chia</a:t>
             </a:r>
             <a:r>
               <a:rPr lang="en-US" sz="2250" dirty="0" spc="2" kern="0">
@@ -23621,7 +23126,7 @@
               <a:t> của</a:t>
             </a:r>
             <a:r>
-              <a:rPr lang="en-US" sz="2250" dirty="0" spc="-2" kern="0">
+              <a:rPr lang="en-US" sz="2250" dirty="0" spc="-1" kern="0">
                 <a:solidFill>
                   <a:srgbClr val="C4C8D6"/>
                 </a:solidFill>
@@ -23629,18 +23134,7 @@
                 <a:ea typeface="Be Vietnam Pro" pitchFamily="34" charset="-122"/>
                 <a:cs typeface="Be Vietnam Pro" pitchFamily="34" charset="-120"/>
               </a:rPr>
-              <a:t> khai</a:t>
-            </a:r>
-            <a:r>
-              <a:rPr lang="en-US" sz="2250" dirty="0" spc="-1" kern="0">
-                <a:solidFill>
-                  <a:srgbClr val="C4C8D6"/>
-                </a:solidFill>
-                <a:latin typeface="Be Vietnam Pro" pitchFamily="34" charset="0"/>
-                <a:ea typeface="Be Vietnam Pro" pitchFamily="34" charset="-122"/>
-                <a:cs typeface="Be Vietnam Pro" pitchFamily="34" charset="-120"/>
-              </a:rPr>
-              <a:t> báo.</a:t>
+              <a:t> bài.</a:t>
             </a:r>
             <a:endParaRPr lang="en-US" sz="2250" dirty="0"/>
           </a:p>

</xml_diff>

<commit_message>
Lessons sd-10-017, 019, 020, 021: describe abstract base classes as more than an interface, present Reactive Streams as one example of reactive programming, record what was checked for the language descriptions and say the lesson does not copy the source list, with the figure and decks
Co-Authored-By: Claude Sonnet 5.5 <noreply@anthropic.com>
Claude-Session: https://claude.ai/code/session_011dmt3ZFdN8sjiTfDnyUVN7
</commit_message>
<xml_diff>
--- a/system-design-101/vi/lessons/sd-10-020/slides/sd-10-020.pptx
+++ b/system-design-101/vi/lessons/sd-10-020/slides/sd-10-020.pptx
@@ -14219,6 +14219,39 @@
               <a:t> ứng:</a:t>
             </a:r>
             <a:r>
+              <a:rPr lang="en-US" sz="2700" dirty="0" spc="-8" kern="0">
+                <a:solidFill>
+                  <a:srgbClr val="14161C"/>
+                </a:solidFill>
+                <a:latin typeface="Be Vietnam Pro" pitchFamily="34" charset="0"/>
+                <a:ea typeface="Be Vietnam Pro" pitchFamily="34" charset="-122"/>
+                <a:cs typeface="Be Vietnam Pro" pitchFamily="34" charset="-120"/>
+              </a:rPr>
+              <a:t> chạy</a:t>
+            </a:r>
+            <a:r>
+              <a:rPr lang="en-US" sz="2700" dirty="0" spc="-2" kern="0">
+                <a:solidFill>
+                  <a:srgbClr val="14161C"/>
+                </a:solidFill>
+                <a:latin typeface="Be Vietnam Pro" pitchFamily="34" charset="0"/>
+                <a:ea typeface="Be Vietnam Pro" pitchFamily="34" charset="-122"/>
+                <a:cs typeface="Be Vietnam Pro" pitchFamily="34" charset="-120"/>
+              </a:rPr>
+              <a:t> khi</a:t>
+            </a:r>
+            <a:r>
+              <a:rPr lang="en-US" sz="2700" dirty="0" spc="-3" kern="0">
+                <a:solidFill>
+                  <a:srgbClr val="14161C"/>
+                </a:solidFill>
+                <a:latin typeface="Be Vietnam Pro" pitchFamily="34" charset="0"/>
+                <a:ea typeface="Be Vietnam Pro" pitchFamily="34" charset="-122"/>
+                <a:cs typeface="Be Vietnam Pro" pitchFamily="34" charset="-120"/>
+              </a:rPr>
+              <a:t> dữ</a:t>
+            </a:r>
+            <a:r>
               <a:rPr lang="en-US" sz="2700" dirty="0" spc="-1" kern="0">
                 <a:solidFill>
                   <a:srgbClr val="14161C"/>
@@ -14227,7 +14260,29 @@
                 <a:ea typeface="Be Vietnam Pro" pitchFamily="34" charset="-122"/>
                 <a:cs typeface="Be Vietnam Pro" pitchFamily="34" charset="-120"/>
               </a:rPr>
-              <a:t> luồng</a:t>
+              <a:t> liệu</a:t>
+            </a:r>
+            <a:r>
+              <a:rPr lang="en-US" sz="2700" dirty="0" spc="8" kern="0">
+                <a:solidFill>
+                  <a:srgbClr val="14161C"/>
+                </a:solidFill>
+                <a:latin typeface="Be Vietnam Pro" pitchFamily="34" charset="0"/>
+                <a:ea typeface="Be Vietnam Pro" pitchFamily="34" charset="-122"/>
+                <a:cs typeface="Be Vietnam Pro" pitchFamily="34" charset="-120"/>
+              </a:rPr>
+              <a:t> đến.</a:t>
+            </a:r>
+            <a:r>
+              <a:rPr lang="en-US" sz="2700" dirty="0" spc="-2" kern="0">
+                <a:solidFill>
+                  <a:srgbClr val="14161C"/>
+                </a:solidFill>
+                <a:latin typeface="Be Vietnam Pro" pitchFamily="34" charset="0"/>
+                <a:ea typeface="Be Vietnam Pro" pitchFamily="34" charset="-122"/>
+                <a:cs typeface="Be Vietnam Pro" pitchFamily="34" charset="-120"/>
+              </a:rPr>
+              <a:t> Đồng</a:t>
             </a:r>
             <a:r>
               <a:rPr lang="en-US" sz="2700" dirty="0" spc="0" kern="0">
@@ -14238,10 +14293,10 @@
                 <a:ea typeface="Be Vietnam Pro" pitchFamily="34" charset="-122"/>
                 <a:cs typeface="Be Vietnam Pro" pitchFamily="34" charset="-120"/>
               </a:rPr>
-              <a:t> có</a:t>
-            </a:r>
-            <a:r>
-              <a:rPr lang="en-US" sz="2700" dirty="0" spc="20" kern="0">
+              <a:t> thời:</a:t>
+            </a:r>
+            <a:r>
+              <a:rPr lang="en-US" sz="2700" dirty="0" spc="1" kern="0">
                 <a:solidFill>
                   <a:srgbClr val="14161C"/>
                 </a:solidFill>
@@ -14249,10 +14304,10 @@
                 <a:ea typeface="Be Vietnam Pro" pitchFamily="34" charset="-122"/>
                 <a:cs typeface="Be Vietnam Pro" pitchFamily="34" charset="-120"/>
               </a:rPr>
-              <a:t> điều</a:t>
-            </a:r>
-            <a:r>
-              <a:rPr lang="en-US" sz="2700" dirty="0" spc="-5" kern="0">
+              <a:t> các</a:t>
+            </a:r>
+            <a:r>
+              <a:rPr lang="en-US" sz="2700" dirty="0" spc="-2" kern="0">
                 <a:solidFill>
                   <a:srgbClr val="14161C"/>
                 </a:solidFill>
@@ -14260,10 +14315,10 @@
                 <a:ea typeface="Be Vietnam Pro" pitchFamily="34" charset="-122"/>
                 <a:cs typeface="Be Vietnam Pro" pitchFamily="34" charset="-120"/>
               </a:rPr>
-              <a:t> tiết</a:t>
-            </a:r>
-            <a:r>
-              <a:rPr lang="en-US" sz="2700" dirty="0" spc="22" kern="0">
+              <a:t> phần</a:t>
+            </a:r>
+            <a:r>
+              <a:rPr lang="en-US" sz="2700" dirty="0" spc="-8" kern="0">
                 <a:solidFill>
                   <a:srgbClr val="14161C"/>
                 </a:solidFill>
@@ -14271,10 +14326,10 @@
                 <a:ea typeface="Be Vietnam Pro" pitchFamily="34" charset="-122"/>
                 <a:cs typeface="Be Vietnam Pro" pitchFamily="34" charset="-120"/>
               </a:rPr>
-              <a:t> lưu</a:t>
-            </a:r>
-            <a:r>
-              <a:rPr lang="en-US" sz="2700" dirty="0" spc="5" kern="0">
+              <a:t> chạy</a:t>
+            </a:r>
+            <a:r>
+              <a:rPr lang="en-US" sz="2700" dirty="0" spc="10" kern="0">
                 <a:solidFill>
                   <a:srgbClr val="14161C"/>
                 </a:solidFill>
@@ -14282,76 +14337,10 @@
                 <a:ea typeface="Be Vietnam Pro" pitchFamily="34" charset="-122"/>
                 <a:cs typeface="Be Vietnam Pro" pitchFamily="34" charset="-120"/>
               </a:rPr>
-              <a:t> lượng.</a:t>
+              <a:t> độc</a:t>
             </a:r>
             <a:r>
               <a:rPr lang="en-US" sz="2700" dirty="0" spc="-2" kern="0">
-                <a:solidFill>
-                  <a:srgbClr val="14161C"/>
-                </a:solidFill>
-                <a:latin typeface="Be Vietnam Pro" pitchFamily="34" charset="0"/>
-                <a:ea typeface="Be Vietnam Pro" pitchFamily="34" charset="-122"/>
-                <a:cs typeface="Be Vietnam Pro" pitchFamily="34" charset="-120"/>
-              </a:rPr>
-              <a:t> Đồng</a:t>
-            </a:r>
-            <a:r>
-              <a:rPr lang="en-US" sz="2700" dirty="0" spc="-1" kern="0">
-                <a:solidFill>
-                  <a:srgbClr val="14161C"/>
-                </a:solidFill>
-                <a:latin typeface="Be Vietnam Pro" pitchFamily="34" charset="0"/>
-                <a:ea typeface="Be Vietnam Pro" pitchFamily="34" charset="-122"/>
-                <a:cs typeface="Be Vietnam Pro" pitchFamily="34" charset="-120"/>
-              </a:rPr>
-              <a:t> thời:</a:t>
-            </a:r>
-            <a:r>
-              <a:rPr lang="en-US" sz="2700" dirty="0" spc="2" kern="0">
-                <a:solidFill>
-                  <a:srgbClr val="14161C"/>
-                </a:solidFill>
-                <a:latin typeface="Be Vietnam Pro" pitchFamily="34" charset="0"/>
-                <a:ea typeface="Be Vietnam Pro" pitchFamily="34" charset="-122"/>
-                <a:cs typeface="Be Vietnam Pro" pitchFamily="34" charset="-120"/>
-              </a:rPr>
-              <a:t> các</a:t>
-            </a:r>
-            <a:r>
-              <a:rPr lang="en-US" sz="2700" dirty="0" spc="-2" kern="0">
-                <a:solidFill>
-                  <a:srgbClr val="14161C"/>
-                </a:solidFill>
-                <a:latin typeface="Be Vietnam Pro" pitchFamily="34" charset="0"/>
-                <a:ea typeface="Be Vietnam Pro" pitchFamily="34" charset="-122"/>
-                <a:cs typeface="Be Vietnam Pro" pitchFamily="34" charset="-120"/>
-              </a:rPr>
-              <a:t> phần</a:t>
-            </a:r>
-            <a:r>
-              <a:rPr lang="en-US" sz="2700" dirty="0" spc="-8" kern="0">
-                <a:solidFill>
-                  <a:srgbClr val="14161C"/>
-                </a:solidFill>
-                <a:latin typeface="Be Vietnam Pro" pitchFamily="34" charset="0"/>
-                <a:ea typeface="Be Vietnam Pro" pitchFamily="34" charset="-122"/>
-                <a:cs typeface="Be Vietnam Pro" pitchFamily="34" charset="-120"/>
-              </a:rPr>
-              <a:t> chạy</a:t>
-            </a:r>
-            <a:r>
-              <a:rPr lang="en-US" sz="2700" dirty="0" spc="10" kern="0">
-                <a:solidFill>
-                  <a:srgbClr val="14161C"/>
-                </a:solidFill>
-                <a:latin typeface="Be Vietnam Pro" pitchFamily="34" charset="0"/>
-                <a:ea typeface="Be Vietnam Pro" pitchFamily="34" charset="-122"/>
-                <a:cs typeface="Be Vietnam Pro" pitchFamily="34" charset="-120"/>
-              </a:rPr>
-              <a:t> độc</a:t>
-            </a:r>
-            <a:r>
-              <a:rPr lang="en-US" sz="2700" dirty="0" spc="-1" kern="0">
                 <a:solidFill>
                   <a:srgbClr val="14161C"/>
                 </a:solidFill>
@@ -14570,7 +14559,7 @@
               <a:buNone/>
             </a:pPr>
             <a:r>
-              <a:rPr lang="en-US" sz="2550" dirty="0" spc="-23" kern="0">
+              <a:rPr lang="en-US" sz="2550" dirty="0" spc="2" kern="0">
                 <a:solidFill>
                   <a:srgbClr val="14161C"/>
                 </a:solidFill>
@@ -14578,10 +14567,10 @@
                 <a:ea typeface="Be Vietnam Pro" pitchFamily="34" charset="-122"/>
                 <a:cs typeface="Be Vietnam Pro" pitchFamily="34" charset="-120"/>
               </a:rPr>
-              <a:t>Reactive</a:t>
-            </a:r>
-            <a:r>
-              <a:rPr lang="en-US" sz="2550" dirty="0" spc="-13" kern="0">
+              <a:t>Ví</a:t>
+            </a:r>
+            <a:r>
+              <a:rPr lang="en-US" sz="2550" dirty="0" spc="0" kern="0">
                 <a:solidFill>
                   <a:srgbClr val="14161C"/>
                 </a:solidFill>
@@ -14589,10 +14578,10 @@
                 <a:ea typeface="Be Vietnam Pro" pitchFamily="34" charset="-122"/>
                 <a:cs typeface="Be Vietnam Pro" pitchFamily="34" charset="-120"/>
               </a:rPr>
-              <a:t> Streams:</a:t>
-            </a:r>
-            <a:r>
-              <a:rPr lang="en-US" sz="2550" dirty="0" spc="1" kern="0">
+              <a:t> dụ:</a:t>
+            </a:r>
+            <a:r>
+              <a:rPr lang="en-US" sz="2550" dirty="0" spc="-21" kern="0">
                 <a:solidFill>
                   <a:srgbClr val="14161C"/>
                 </a:solidFill>
@@ -14600,6 +14589,28 @@
                 <a:ea typeface="Be Vietnam Pro" pitchFamily="34" charset="-122"/>
                 <a:cs typeface="Be Vietnam Pro" pitchFamily="34" charset="-120"/>
               </a:rPr>
+              <a:t> Reactive</a:t>
+            </a:r>
+            <a:r>
+              <a:rPr lang="en-US" sz="2550" dirty="0" spc="-14" kern="0">
+                <a:solidFill>
+                  <a:srgbClr val="14161C"/>
+                </a:solidFill>
+                <a:latin typeface="Be Vietnam Pro" pitchFamily="34" charset="0"/>
+                <a:ea typeface="Be Vietnam Pro" pitchFamily="34" charset="-122"/>
+                <a:cs typeface="Be Vietnam Pro" pitchFamily="34" charset="-120"/>
+              </a:rPr>
+              <a:t> Streams,</a:t>
+            </a:r>
+            <a:r>
+              <a:rPr lang="en-US" sz="2550" dirty="0" spc="2" kern="0">
+                <a:solidFill>
+                  <a:srgbClr val="14161C"/>
+                </a:solidFill>
+                <a:latin typeface="Be Vietnam Pro" pitchFamily="34" charset="0"/>
+                <a:ea typeface="Be Vietnam Pro" pitchFamily="34" charset="-122"/>
+                <a:cs typeface="Be Vietnam Pro" pitchFamily="34" charset="-120"/>
+              </a:rPr>
               <a:t> luồng</a:t>
             </a:r>
             <a:r>
@@ -14614,7 +14625,7 @@
               <a:t> bất</a:t>
             </a:r>
             <a:r>
-              <a:rPr lang="en-US" sz="2550" dirty="0" spc="11" kern="0">
+              <a:rPr lang="en-US" sz="2550" dirty="0" spc="10" kern="0">
                 <a:solidFill>
                   <a:srgbClr val="14161C"/>
                 </a:solidFill>
@@ -14625,7 +14636,7 @@
               <a:t> đồng</a:t>
             </a:r>
             <a:r>
-              <a:rPr lang="en-US" sz="2550" dirty="0" spc="-4" kern="0">
+              <a:rPr lang="en-US" sz="2550" dirty="0" spc="-2" kern="0">
                 <a:solidFill>
                   <a:srgbClr val="14161C"/>
                 </a:solidFill>
@@ -14633,18 +14644,7 @@
                 <a:ea typeface="Be Vietnam Pro" pitchFamily="34" charset="-122"/>
                 <a:cs typeface="Be Vietnam Pro" pitchFamily="34" charset="-120"/>
               </a:rPr>
-              <a:t> bộ,</a:t>
-            </a:r>
-            <a:r>
-              <a:rPr lang="en-US" sz="2550" dirty="0" spc="-15" kern="0">
-                <a:solidFill>
-                  <a:srgbClr val="14161C"/>
-                </a:solidFill>
-                <a:latin typeface="Be Vietnam Pro" pitchFamily="34" charset="0"/>
-                <a:ea typeface="Be Vietnam Pro" pitchFamily="34" charset="-122"/>
-                <a:cs typeface="Be Vietnam Pro" pitchFamily="34" charset="-120"/>
-              </a:rPr>
-              <a:t> backpressure.</a:t>
+              <a:t> bộ.</a:t>
             </a:r>
             <a:endParaRPr lang="en-US" sz="2550" dirty="0"/>
           </a:p>
@@ -14732,10 +14732,10 @@
                 <a:ea typeface="Be Vietnam Pro" pitchFamily="34" charset="-122"/>
                 <a:cs typeface="Be Vietnam Pro" pitchFamily="34" charset="-120"/>
               </a:rPr>
-              <a:t> ·</a:t>
-            </a:r>
-            <a:r>
-              <a:rPr lang="en-US" sz="1800" b="1" spc="225" kern="0" dirty="0">
+              <a:t> · VÍ</a:t>
+            </a:r>
+            <a:r>
+              <a:rPr lang="en-US" sz="1800" b="1" spc="228" kern="0" dirty="0">
                 <a:solidFill>
                   <a:srgbClr val="0F766E"/>
                 </a:solidFill>
@@ -14743,10 +14743,10 @@
                 <a:ea typeface="Be Vietnam Pro" pitchFamily="34" charset="-122"/>
                 <a:cs typeface="Be Vietnam Pro" pitchFamily="34" charset="-120"/>
               </a:rPr>
-              <a:t> LUỒNG</a:t>
-            </a:r>
-            <a:r>
-              <a:rPr lang="en-US" sz="1800" b="1" spc="227" kern="0" dirty="0">
+              <a:t> DỤ</a:t>
+            </a:r>
+            <a:r>
+              <a:rPr lang="en-US" sz="1800" b="1" spc="210" kern="0" dirty="0">
                 <a:solidFill>
                   <a:srgbClr val="0F766E"/>
                 </a:solidFill>
@@ -14754,10 +14754,10 @@
                 <a:ea typeface="Be Vietnam Pro" pitchFamily="34" charset="-122"/>
                 <a:cs typeface="Be Vietnam Pro" pitchFamily="34" charset="-120"/>
               </a:rPr>
-              <a:t> DỮ</a:t>
-            </a:r>
-            <a:r>
-              <a:rPr lang="en-US" sz="1800" b="1" spc="224" kern="0" dirty="0">
+              <a:t> REACTIVE</a:t>
+            </a:r>
+            <a:r>
+              <a:rPr lang="en-US" sz="1800" b="1" spc="219" kern="0" dirty="0">
                 <a:solidFill>
                   <a:srgbClr val="0F766E"/>
                 </a:solidFill>
@@ -14765,40 +14765,7 @@
                 <a:ea typeface="Be Vietnam Pro" pitchFamily="34" charset="-122"/>
                 <a:cs typeface="Be Vietnam Pro" pitchFamily="34" charset="-120"/>
               </a:rPr>
-              <a:t> LIỆU</a:t>
-            </a:r>
-            <a:r>
-              <a:rPr lang="en-US" sz="1800" b="1" spc="175" kern="0" dirty="0">
-                <a:solidFill>
-                  <a:srgbClr val="0F766E"/>
-                </a:solidFill>
-                <a:latin typeface="Be Vietnam Pro" pitchFamily="34" charset="0"/>
-                <a:ea typeface="Be Vietnam Pro" pitchFamily="34" charset="-122"/>
-                <a:cs typeface="Be Vietnam Pro" pitchFamily="34" charset="-120"/>
-              </a:rPr>
-              <a:t> BẤT</a:t>
-            </a:r>
-            <a:r>
-              <a:rPr lang="en-US" sz="1800" b="1" spc="224" kern="0" dirty="0">
-                <a:solidFill>
-                  <a:srgbClr val="0F766E"/>
-                </a:solidFill>
-                <a:latin typeface="Be Vietnam Pro" pitchFamily="34" charset="0"/>
-                <a:ea typeface="Be Vietnam Pro" pitchFamily="34" charset="-122"/>
-                <a:cs typeface="Be Vietnam Pro" pitchFamily="34" charset="-120"/>
-              </a:rPr>
-              <a:t> ĐỒNG</a:t>
-            </a:r>
-            <a:r>
-              <a:rPr lang="en-US" sz="1800" b="1" spc="220" kern="0" dirty="0">
-                <a:solidFill>
-                  <a:srgbClr val="0F766E"/>
-                </a:solidFill>
-                <a:latin typeface="Be Vietnam Pro" pitchFamily="34" charset="0"/>
-                <a:ea typeface="Be Vietnam Pro" pitchFamily="34" charset="-122"/>
-                <a:cs typeface="Be Vietnam Pro" pitchFamily="34" charset="-120"/>
-              </a:rPr>
-              <a:t> BỘ</a:t>
+              <a:t> STREAMS</a:t>
             </a:r>
             <a:endParaRPr lang="en-US" sz="1800" dirty="0"/>
           </a:p>

</xml_diff>

<commit_message>
Lesson sd-10-020: also name the imperative reading as unchecked in the lesson, figure, metadata and deck
Co-Authored-By: Claude Sonnet 5.5 <noreply@anthropic.com>
Claude-Session: https://claude.ai/code/session_011dmt3ZFdN8sjiTfDnyUVN7
</commit_message>
<xml_diff>
--- a/system-design-101/vi/lessons/sd-10-020/slides/sd-10-020.pptx
+++ b/system-design-101/vi/lessons/sd-10-020/slides/sd-10-020.pptx
@@ -16504,17 +16504,6 @@
               <a:t> nghĩa</a:t>
             </a:r>
             <a:r>
-              <a:rPr lang="en-US" sz="2700" dirty="0" spc="0" kern="0">
-                <a:solidFill>
-                  <a:srgbClr val="F3EEE3"/>
-                </a:solidFill>
-                <a:latin typeface="Be Vietnam Pro" pitchFamily="34" charset="0"/>
-                <a:ea typeface="Be Vietnam Pro" pitchFamily="34" charset="-122"/>
-                <a:cs typeface="Be Vietnam Pro" pitchFamily="34" charset="-120"/>
-              </a:rPr>
-              <a:t> chung</a:t>
-            </a:r>
-            <a:r>
               <a:rPr lang="en-US" sz="2700" dirty="0" spc="-2" kern="0">
                 <a:solidFill>
                   <a:srgbClr val="F3EEE3"/>
@@ -16523,18 +16512,73 @@
                 <a:ea typeface="Be Vietnam Pro" pitchFamily="34" charset="-122"/>
                 <a:cs typeface="Be Vietnam Pro" pitchFamily="34" charset="-120"/>
               </a:rPr>
-              <a:t> của phản</a:t>
-            </a:r>
-            <a:r>
-              <a:rPr lang="en-US" sz="2700" dirty="0" spc="19" kern="0">
-                <a:solidFill>
-                  <a:srgbClr val="F3EEE3"/>
-                </a:solidFill>
-                <a:latin typeface="Be Vietnam Pro" pitchFamily="34" charset="0"/>
-                <a:ea typeface="Be Vietnam Pro" pitchFamily="34" charset="-122"/>
-                <a:cs typeface="Be Vietnam Pro" pitchFamily="34" charset="-120"/>
-              </a:rPr>
-              <a:t> ứng.</a:t>
+              <a:t> phản</a:t>
+            </a:r>
+            <a:r>
+              <a:rPr lang="en-US" sz="2700" dirty="0" spc="24" kern="0">
+                <a:solidFill>
+                  <a:srgbClr val="F3EEE3"/>
+                </a:solidFill>
+                <a:latin typeface="Be Vietnam Pro" pitchFamily="34" charset="0"/>
+                <a:ea typeface="Be Vietnam Pro" pitchFamily="34" charset="-122"/>
+                <a:cs typeface="Be Vietnam Pro" pitchFamily="34" charset="-120"/>
+              </a:rPr>
+              <a:t> ứng</a:t>
+            </a:r>
+            <a:r>
+              <a:rPr lang="en-US" sz="2700" dirty="0" spc="-18" kern="0">
+                <a:solidFill>
+                  <a:srgbClr val="F3EEE3"/>
+                </a:solidFill>
+                <a:latin typeface="Be Vietnam Pro" pitchFamily="34" charset="0"/>
+                <a:ea typeface="Be Vietnam Pro" pitchFamily="34" charset="-122"/>
+                <a:cs typeface="Be Vietnam Pro" pitchFamily="34" charset="-120"/>
+              </a:rPr>
+              <a:t> và</a:t>
+            </a:r>
+            <a:r>
+              <a:rPr lang="en-US" sz="2700" dirty="0" spc="1" kern="0">
+                <a:solidFill>
+                  <a:srgbClr val="F3EEE3"/>
+                </a:solidFill>
+                <a:latin typeface="Be Vietnam Pro" pitchFamily="34" charset="0"/>
+                <a:ea typeface="Be Vietnam Pro" pitchFamily="34" charset="-122"/>
+                <a:cs typeface="Be Vietnam Pro" pitchFamily="34" charset="-120"/>
+              </a:rPr>
+              <a:t> cách</a:t>
+            </a:r>
+            <a:r>
+              <a:rPr lang="en-US" sz="2700" dirty="0" spc="10" kern="0">
+                <a:solidFill>
+                  <a:srgbClr val="F3EEE3"/>
+                </a:solidFill>
+                <a:latin typeface="Be Vietnam Pro" pitchFamily="34" charset="0"/>
+                <a:ea typeface="Be Vietnam Pro" pitchFamily="34" charset="-122"/>
+                <a:cs typeface="Be Vietnam Pro" pitchFamily="34" charset="-120"/>
+              </a:rPr>
+              <a:t> đọc</a:t>
+            </a:r>
+            <a:r>
+              <a:rPr lang="en-US" sz="2700" dirty="0" spc="-3" kern="0">
+                <a:solidFill>
+                  <a:srgbClr val="F3EEE3"/>
+                </a:solidFill>
+                <a:latin typeface="Be Vietnam Pro" pitchFamily="34" charset="0"/>
+                <a:ea typeface="Be Vietnam Pro" pitchFamily="34" charset="-122"/>
+                <a:cs typeface="Be Vietnam Pro" pitchFamily="34" charset="-120"/>
+              </a:rPr>
+              <a:t> mệnh</a:t>
+            </a:r>
+            <a:r>
+              <a:rPr lang="en-US" sz="2700" dirty="0" spc="-2" kern="0">
+                <a:solidFill>
+                  <a:srgbClr val="F3EEE3"/>
+                </a:solidFill>
+                <a:latin typeface="Be Vietnam Pro" pitchFamily="34" charset="0"/>
+                <a:ea typeface="Be Vietnam Pro" pitchFamily="34" charset="-122"/>
+                <a:cs typeface="Be Vietnam Pro" pitchFamily="34" charset="-120"/>
+              </a:rPr>
+              <a:t> lệnh.</a:t>
             </a:r>
             <a:endParaRPr lang="en-US" sz="2700" dirty="0"/>
           </a:p>

</xml_diff>

<commit_message>
Lessons sd-10-020, 021: define the abbreviations the deck uses, describe generic code as parameterized by a type, and acknowledge the name overlap with the source's algorithm list
Co-Authored-By: Claude Sonnet 5.5 <noreply@anthropic.com>
Claude-Session: https://claude.ai/code/session_011dmt3ZFdN8sjiTfDnyUVN7
</commit_message>
<xml_diff>
--- a/system-design-101/vi/lessons/sd-10-020/slides/sd-10-020.pptx
+++ b/system-design-101/vi/lessons/sd-10-020/slides/sd-10-020.pptx
@@ -4500,7 +4500,7 @@
         <p:spPr>
           <a:xfrm>
             <a:off x="914400" y="8191500"/>
-            <a:ext cx="16459200" cy="381000"/>
+            <a:ext cx="16459200" cy="857250"/>
           </a:xfrm>
           <a:prstGeom prst="rect">
             <a:avLst/>
@@ -4657,6 +4657,155 @@
                 <a:cs typeface="Be Vietnam Pro" pitchFamily="34" charset="-120"/>
               </a:rPr>
               <a:t> Streams.</a:t>
+            </a:r>
+            <a:endParaRPr lang="en-US" sz="1950" dirty="0"/>
+          </a:p>
+          <a:p>
+            <a:pPr algn="l" indent="0" marL="0">
+              <a:buNone/>
+            </a:pPr>
+            <a:r>
+              <a:rPr lang="en-US" sz="1950" dirty="0" spc="8" kern="0">
+                <a:solidFill>
+                  <a:srgbClr val="C4C8D6"/>
+                </a:solidFill>
+                <a:latin typeface="Be Vietnam Pro" pitchFamily="34" charset="0"/>
+                <a:ea typeface="Be Vietnam Pro" pitchFamily="34" charset="-122"/>
+                <a:cs typeface="Be Vietnam Pro" pitchFamily="34" charset="-120"/>
+              </a:rPr>
+              <a:t>SQL:</a:t>
+            </a:r>
+            <a:r>
+              <a:rPr lang="en-US" sz="1950" dirty="0" spc="-8" kern="0">
+                <a:solidFill>
+                  <a:srgbClr val="C4C8D6"/>
+                </a:solidFill>
+                <a:latin typeface="Be Vietnam Pro" pitchFamily="34" charset="0"/>
+                <a:ea typeface="Be Vietnam Pro" pitchFamily="34" charset="-122"/>
+                <a:cs typeface="Be Vietnam Pro" pitchFamily="34" charset="-120"/>
+              </a:rPr>
+              <a:t> Structured</a:t>
+            </a:r>
+            <a:r>
+              <a:rPr lang="en-US" sz="1950" dirty="0" spc="2" kern="0">
+                <a:solidFill>
+                  <a:srgbClr val="C4C8D6"/>
+                </a:solidFill>
+                <a:latin typeface="Be Vietnam Pro" pitchFamily="34" charset="0"/>
+                <a:ea typeface="Be Vietnam Pro" pitchFamily="34" charset="-122"/>
+                <a:cs typeface="Be Vietnam Pro" pitchFamily="34" charset="-120"/>
+              </a:rPr>
+              <a:t> Query</a:t>
+            </a:r>
+            <a:r>
+              <a:rPr lang="en-US" sz="1950" dirty="0" spc="-10" kern="0">
+                <a:solidFill>
+                  <a:srgbClr val="C4C8D6"/>
+                </a:solidFill>
+                <a:latin typeface="Be Vietnam Pro" pitchFamily="34" charset="0"/>
+                <a:ea typeface="Be Vietnam Pro" pitchFamily="34" charset="-122"/>
+                <a:cs typeface="Be Vietnam Pro" pitchFamily="34" charset="-120"/>
+              </a:rPr>
+              <a:t> Language</a:t>
+            </a:r>
+            <a:r>
+              <a:rPr lang="en-US" sz="1950" dirty="0" spc="0" kern="0">
+                <a:solidFill>
+                  <a:srgbClr val="C4C8D6"/>
+                </a:solidFill>
+                <a:latin typeface="Be Vietnam Pro" pitchFamily="34" charset="0"/>
+                <a:ea typeface="Be Vietnam Pro" pitchFamily="34" charset="-122"/>
+                <a:cs typeface="Be Vietnam Pro" pitchFamily="34" charset="-120"/>
+              </a:rPr>
+              <a:t> ·</a:t>
+            </a:r>
+            <a:r>
+              <a:rPr lang="en-US" sz="1950" dirty="0" spc="-4" kern="0">
+                <a:solidFill>
+                  <a:srgbClr val="C4C8D6"/>
+                </a:solidFill>
+                <a:latin typeface="Be Vietnam Pro" pitchFamily="34" charset="0"/>
+                <a:ea typeface="Be Vietnam Pro" pitchFamily="34" charset="-122"/>
+                <a:cs typeface="Be Vietnam Pro" pitchFamily="34" charset="-120"/>
+              </a:rPr>
+              <a:t> JDK:</a:t>
+            </a:r>
+            <a:r>
+              <a:rPr lang="en-US" sz="1950" dirty="0" spc="-16" kern="0">
+                <a:solidFill>
+                  <a:srgbClr val="C4C8D6"/>
+                </a:solidFill>
+                <a:latin typeface="Be Vietnam Pro" pitchFamily="34" charset="0"/>
+                <a:ea typeface="Be Vietnam Pro" pitchFamily="34" charset="-122"/>
+                <a:cs typeface="Be Vietnam Pro" pitchFamily="34" charset="-120"/>
+              </a:rPr>
+              <a:t> Java</a:t>
+            </a:r>
+            <a:r>
+              <a:rPr lang="en-US" sz="1950" dirty="0" spc="-9" kern="0">
+                <a:solidFill>
+                  <a:srgbClr val="C4C8D6"/>
+                </a:solidFill>
+                <a:latin typeface="Be Vietnam Pro" pitchFamily="34" charset="0"/>
+                <a:ea typeface="Be Vietnam Pro" pitchFamily="34" charset="-122"/>
+                <a:cs typeface="Be Vietnam Pro" pitchFamily="34" charset="-120"/>
+              </a:rPr>
+              <a:t> Development</a:t>
+            </a:r>
+            <a:r>
+              <a:rPr lang="en-US" sz="1950" dirty="0" spc="-1" kern="0">
+                <a:solidFill>
+                  <a:srgbClr val="C4C8D6"/>
+                </a:solidFill>
+                <a:latin typeface="Be Vietnam Pro" pitchFamily="34" charset="0"/>
+                <a:ea typeface="Be Vietnam Pro" pitchFamily="34" charset="-122"/>
+                <a:cs typeface="Be Vietnam Pro" pitchFamily="34" charset="-120"/>
+              </a:rPr>
+              <a:t> Kit</a:t>
+            </a:r>
+            <a:r>
+              <a:rPr lang="en-US" sz="1950" dirty="0" spc="-2" kern="0">
+                <a:solidFill>
+                  <a:srgbClr val="C4C8D6"/>
+                </a:solidFill>
+                <a:latin typeface="Be Vietnam Pro" pitchFamily="34" charset="0"/>
+                <a:ea typeface="Be Vietnam Pro" pitchFamily="34" charset="-122"/>
+                <a:cs typeface="Be Vietnam Pro" pitchFamily="34" charset="-120"/>
+              </a:rPr>
+              <a:t> · MDN:</a:t>
+            </a:r>
+            <a:r>
+              <a:rPr lang="en-US" sz="1950" dirty="0" spc="1" kern="0">
+                <a:solidFill>
+                  <a:srgbClr val="C4C8D6"/>
+                </a:solidFill>
+                <a:latin typeface="Be Vietnam Pro" pitchFamily="34" charset="0"/>
+                <a:ea typeface="Be Vietnam Pro" pitchFamily="34" charset="-122"/>
+                <a:cs typeface="Be Vietnam Pro" pitchFamily="34" charset="-120"/>
+              </a:rPr>
+              <a:t> Mozilla</a:t>
+            </a:r>
+            <a:r>
+              <a:rPr lang="en-US" sz="1950" dirty="0" spc="-9" kern="0">
+                <a:solidFill>
+                  <a:srgbClr val="C4C8D6"/>
+                </a:solidFill>
+                <a:latin typeface="Be Vietnam Pro" pitchFamily="34" charset="0"/>
+                <a:ea typeface="Be Vietnam Pro" pitchFamily="34" charset="-122"/>
+                <a:cs typeface="Be Vietnam Pro" pitchFamily="34" charset="-120"/>
+              </a:rPr>
+              <a:t> Developer</a:t>
+            </a:r>
+            <a:r>
+              <a:rPr lang="en-US" sz="1950" dirty="0" spc="-7" kern="0">
+                <a:solidFill>
+                  <a:srgbClr val="C4C8D6"/>
+                </a:solidFill>
+                <a:latin typeface="Be Vietnam Pro" pitchFamily="34" charset="0"/>
+                <a:ea typeface="Be Vietnam Pro" pitchFamily="34" charset="-122"/>
+                <a:cs typeface="Be Vietnam Pro" pitchFamily="34" charset="-120"/>
+              </a:rPr>
+              <a:t> Network</a:t>
             </a:r>
             <a:endParaRPr lang="en-US" sz="1950" dirty="0"/>
           </a:p>
@@ -11920,7 +12069,7 @@
               <a:buNone/>
             </a:pPr>
             <a:r>
-              <a:rPr lang="en-US" sz="6900" dirty="0" spc="-3" kern="0">
+              <a:rPr lang="en-US" sz="6900" dirty="0" spc="8" kern="0">
                 <a:solidFill>
                   <a:srgbClr val="F3EEE3"/>
                 </a:solidFill>
@@ -11928,7 +12077,7 @@
                 <a:ea typeface="Bricolage Grotesque ExtraBold" pitchFamily="34" charset="-122"/>
                 <a:cs typeface="Bricolage Grotesque ExtraBold" pitchFamily="34" charset="-120"/>
               </a:rPr>
-              <a:t>Mã</a:t>
+              <a:t>Kiểu</a:t>
             </a:r>
             <a:r>
               <a:rPr lang="en-US" sz="6900" dirty="0" spc="0" kern="0">
@@ -11939,7 +12088,7 @@
                 <a:ea typeface="Bricolage Grotesque ExtraBold" pitchFamily="34" charset="-122"/>
                 <a:cs typeface="Bricolage Grotesque ExtraBold" pitchFamily="34" charset="-120"/>
               </a:rPr>
-              <a:t> không</a:t>
+              <a:t> là</a:t>
             </a:r>
             <a:endParaRPr lang="en-US" sz="6900" dirty="0"/>
           </a:p>
@@ -11948,7 +12097,7 @@
               <a:buNone/>
             </a:pPr>
             <a:r>
-              <a:rPr lang="en-US" sz="6900" dirty="0" spc="7" kern="0">
+              <a:rPr lang="en-US" sz="6900" dirty="0" spc="1" kern="0">
                 <a:solidFill>
                   <a:srgbClr val="F3EEE3"/>
                 </a:solidFill>
@@ -11956,10 +12105,10 @@
                 <a:ea typeface="Bricolage Grotesque ExtraBold" pitchFamily="34" charset="-122"/>
                 <a:cs typeface="Bricolage Grotesque ExtraBold" pitchFamily="34" charset="-120"/>
               </a:rPr>
-              <a:t>phụ</a:t>
-            </a:r>
-            <a:r>
-              <a:rPr lang="en-US" sz="6900" dirty="0" spc="1" kern="0">
+              <a:t>tham</a:t>
+            </a:r>
+            <a:r>
+              <a:rPr lang="en-US" sz="6900" dirty="0" spc="2" kern="0">
                 <a:solidFill>
                   <a:srgbClr val="F3EEE3"/>
                 </a:solidFill>
@@ -11967,10 +12116,10 @@
                 <a:ea typeface="Bricolage Grotesque ExtraBold" pitchFamily="34" charset="-122"/>
                 <a:cs typeface="Bricolage Grotesque ExtraBold" pitchFamily="34" charset="-120"/>
               </a:rPr>
-              <a:t> thuộc</a:t>
-            </a:r>
-            <a:r>
-              <a:rPr lang="en-US" sz="6900" dirty="0" spc="6" kern="0">
+              <a:t> số</a:t>
+            </a:r>
+            <a:r>
+              <a:rPr lang="en-US" sz="6900" dirty="0" spc="-1" kern="0">
                 <a:solidFill>
                   <a:srgbClr val="F3EEE3"/>
                 </a:solidFill>
@@ -11978,7 +12127,18 @@
                 <a:ea typeface="Bricolage Grotesque ExtraBold" pitchFamily="34" charset="-122"/>
                 <a:cs typeface="Bricolage Grotesque ExtraBold" pitchFamily="34" charset="-120"/>
               </a:rPr>
-              <a:t> kiểu</a:t>
+              <a:t> của</a:t>
+            </a:r>
+            <a:r>
+              <a:rPr lang="en-US" sz="6900" dirty="0" spc="-2" kern="0">
+                <a:solidFill>
+                  <a:srgbClr val="F3EEE3"/>
+                </a:solidFill>
+                <a:latin typeface="Bricolage Grotesque ExtraBold" pitchFamily="34" charset="0"/>
+                <a:ea typeface="Bricolage Grotesque ExtraBold" pitchFamily="34" charset="-122"/>
+                <a:cs typeface="Bricolage Grotesque ExtraBold" pitchFamily="34" charset="-120"/>
+              </a:rPr>
+              <a:t> mã</a:t>
             </a:r>
             <a:endParaRPr lang="en-US" sz="6900" dirty="0"/>
           </a:p>

</xml_diff>

<commit_message>
Lessons sd-10-017, 020: explain ML in the glossary and on the deck's terms slide, rename that slide's heading and list MDN in the 017 gloss record
Co-Authored-By: Claude Sonnet 5.5 <noreply@anthropic.com>
Claude-Session: https://claude.ai/code/session_011dmt3ZFdN8sjiTfDnyUVN7
</commit_message>
<xml_diff>
--- a/system-design-101/vi/lessons/sd-10-020/slides/sd-10-020.pptx
+++ b/system-design-101/vi/lessons/sd-10-020/slides/sd-10-020.pptx
@@ -3457,7 +3457,7 @@
               <a:buNone/>
             </a:pPr>
             <a:r>
-              <a:rPr lang="en-US" sz="1950" b="1" spc="214" kern="0" dirty="0">
+              <a:rPr lang="en-US" sz="1950" b="1" spc="227" kern="0" dirty="0">
                 <a:solidFill>
                   <a:srgbClr val="FF6A4D"/>
                 </a:solidFill>
@@ -3465,21 +3465,10 @@
                 <a:ea typeface="Be Vietnam Pro" pitchFamily="34" charset="-122"/>
                 <a:cs typeface="Be Vietnam Pro" pitchFamily="34" charset="-120"/>
               </a:rPr>
-              <a:t>BA</a:t>
+              <a:t>TỪ</a:t>
             </a:r>
             <a:r>
               <a:rPr lang="en-US" sz="1950" b="1" spc="226" kern="0" dirty="0">
-                <a:solidFill>
-                  <a:srgbClr val="FF6A4D"/>
-                </a:solidFill>
-                <a:latin typeface="Be Vietnam Pro" pitchFamily="34" charset="0"/>
-                <a:ea typeface="Be Vietnam Pro" pitchFamily="34" charset="-122"/>
-                <a:cs typeface="Be Vietnam Pro" pitchFamily="34" charset="-120"/>
-              </a:rPr>
-              <a:t> TỪ</a:t>
-            </a:r>
-            <a:r>
-              <a:rPr lang="en-US" sz="1950" b="1" spc="225" kern="0" dirty="0">
                 <a:solidFill>
                   <a:srgbClr val="FF6A4D"/>
                 </a:solidFill>
@@ -4499,8 +4488,8 @@
         </p:nvSpPr>
         <p:spPr>
           <a:xfrm>
-            <a:off x="914400" y="8191500"/>
-            <a:ext cx="16459200" cy="857250"/>
+            <a:off x="914400" y="8058150"/>
+            <a:ext cx="16459200" cy="1143000"/>
           </a:xfrm>
           <a:prstGeom prst="rect">
             <a:avLst/>
@@ -4665,7 +4654,7 @@
               <a:buNone/>
             </a:pPr>
             <a:r>
-              <a:rPr lang="en-US" sz="1950" dirty="0" spc="8" kern="0">
+              <a:rPr lang="en-US" sz="1950" dirty="0" spc="0" kern="0">
                 <a:solidFill>
                   <a:srgbClr val="C4C8D6"/>
                 </a:solidFill>
@@ -4673,7 +4662,95 @@
                 <a:ea typeface="Be Vietnam Pro" pitchFamily="34" charset="-122"/>
                 <a:cs typeface="Be Vietnam Pro" pitchFamily="34" charset="-120"/>
               </a:rPr>
-              <a:t>SQL:</a:t>
+              <a:t>ML:</a:t>
+            </a:r>
+            <a:r>
+              <a:rPr lang="en-US" sz="1950" dirty="0" spc="-11" kern="0">
+                <a:solidFill>
+                  <a:srgbClr val="C4C8D6"/>
+                </a:solidFill>
+                <a:latin typeface="Be Vietnam Pro" pitchFamily="34" charset="0"/>
+                <a:ea typeface="Be Vietnam Pro" pitchFamily="34" charset="-122"/>
+                <a:cs typeface="Be Vietnam Pro" pitchFamily="34" charset="-120"/>
+              </a:rPr>
+              <a:t> Meta</a:t>
+            </a:r>
+            <a:r>
+              <a:rPr lang="en-US" sz="1950" dirty="0" spc="-8" kern="0">
+                <a:solidFill>
+                  <a:srgbClr val="C4C8D6"/>
+                </a:solidFill>
+                <a:latin typeface="Be Vietnam Pro" pitchFamily="34" charset="0"/>
+                <a:ea typeface="Be Vietnam Pro" pitchFamily="34" charset="-122"/>
+                <a:cs typeface="Be Vietnam Pro" pitchFamily="34" charset="-120"/>
+              </a:rPr>
+              <a:t> Language,</a:t>
+            </a:r>
+            <a:r>
+              <a:rPr lang="en-US" sz="1950" dirty="0" spc="-3" kern="0">
+                <a:solidFill>
+                  <a:srgbClr val="C4C8D6"/>
+                </a:solidFill>
+                <a:latin typeface="Be Vietnam Pro" pitchFamily="34" charset="0"/>
+                <a:ea typeface="Be Vietnam Pro" pitchFamily="34" charset="-122"/>
+                <a:cs typeface="Be Vietnam Pro" pitchFamily="34" charset="-120"/>
+              </a:rPr>
+              <a:t> họ</a:t>
+            </a:r>
+            <a:r>
+              <a:rPr lang="en-US" sz="1950" dirty="0" spc="-6" kern="0">
+                <a:solidFill>
+                  <a:srgbClr val="C4C8D6"/>
+                </a:solidFill>
+                <a:latin typeface="Be Vietnam Pro" pitchFamily="34" charset="0"/>
+                <a:ea typeface="Be Vietnam Pro" pitchFamily="34" charset="-122"/>
+                <a:cs typeface="Be Vietnam Pro" pitchFamily="34" charset="-120"/>
+              </a:rPr>
+              <a:t> ngôn</a:t>
+            </a:r>
+            <a:r>
+              <a:rPr lang="en-US" sz="1950" dirty="0" spc="2" kern="0">
+                <a:solidFill>
+                  <a:srgbClr val="C4C8D6"/>
+                </a:solidFill>
+                <a:latin typeface="Be Vietnam Pro" pitchFamily="34" charset="0"/>
+                <a:ea typeface="Be Vietnam Pro" pitchFamily="34" charset="-122"/>
+                <a:cs typeface="Be Vietnam Pro" pitchFamily="34" charset="-120"/>
+              </a:rPr>
+              <a:t> ngữ</a:t>
+            </a:r>
+            <a:r>
+              <a:rPr lang="en-US" sz="1950" dirty="0" spc="0" kern="0">
+                <a:solidFill>
+                  <a:srgbClr val="C4C8D6"/>
+                </a:solidFill>
+                <a:latin typeface="Be Vietnam Pro" pitchFamily="34" charset="0"/>
+                <a:ea typeface="Be Vietnam Pro" pitchFamily="34" charset="-122"/>
+                <a:cs typeface="Be Vietnam Pro" pitchFamily="34" charset="-120"/>
+              </a:rPr>
+              <a:t> hàm</a:t>
+            </a:r>
+            <a:r>
+              <a:rPr lang="en-US" sz="1950" dirty="0" spc="-2" kern="0">
+                <a:solidFill>
+                  <a:srgbClr val="C4C8D6"/>
+                </a:solidFill>
+                <a:latin typeface="Be Vietnam Pro" pitchFamily="34" charset="0"/>
+                <a:ea typeface="Be Vietnam Pro" pitchFamily="34" charset="-122"/>
+                <a:cs typeface="Be Vietnam Pro" pitchFamily="34" charset="-120"/>
+              </a:rPr>
+              <a:t> ·</a:t>
+            </a:r>
+            <a:r>
+              <a:rPr lang="en-US" sz="1950" dirty="0" spc="6" kern="0">
+                <a:solidFill>
+                  <a:srgbClr val="C4C8D6"/>
+                </a:solidFill>
+                <a:latin typeface="Be Vietnam Pro" pitchFamily="34" charset="0"/>
+                <a:ea typeface="Be Vietnam Pro" pitchFamily="34" charset="-122"/>
+                <a:cs typeface="Be Vietnam Pro" pitchFamily="34" charset="-120"/>
+              </a:rPr>
+              <a:t> SQL:</a:t>
             </a:r>
             <a:r>
               <a:rPr lang="en-US" sz="1950" dirty="0" spc="-8" kern="0">

</xml_diff>

<commit_message>
Lesson sd-10-020: add the ideal qualifier to the functional definition on the deck's teaching slide
Co-Authored-By: Claude Sonnet 5.5 <noreply@anthropic.com>
Claude-Session: https://claude.ai/code/session_011dmt3ZFdN8sjiTfDnyUVN7
</commit_message>
<xml_diff>
--- a/system-design-101/vi/lessons/sd-10-020/slides/sd-10-020.pptx
+++ b/system-design-101/vi/lessons/sd-10-020/slides/sd-10-020.pptx
@@ -9824,7 +9824,40 @@
                 <a:ea typeface="Be Vietnam Pro" pitchFamily="34" charset="-122"/>
                 <a:cs typeface="Be Vietnam Pro" pitchFamily="34" charset="-120"/>
               </a:rPr>
-              <a:t> hàm:</a:t>
+              <a:t> hàm;</a:t>
+            </a:r>
+            <a:r>
+              <a:rPr lang="en-US" sz="2400" dirty="0" spc="1" kern="0">
+                <a:solidFill>
+                  <a:srgbClr val="C4C8D6"/>
+                </a:solidFill>
+                <a:latin typeface="Be Vietnam Pro" pitchFamily="34" charset="0"/>
+                <a:ea typeface="Be Vietnam Pro" pitchFamily="34" charset="-122"/>
+                <a:cs typeface="Be Vietnam Pro" pitchFamily="34" charset="-120"/>
+              </a:rPr>
+              <a:t> lý</a:t>
+            </a:r>
+            <a:r>
+              <a:rPr lang="en-US" sz="2400" dirty="0" spc="7" kern="0">
+                <a:solidFill>
+                  <a:srgbClr val="C4C8D6"/>
+                </a:solidFill>
+                <a:latin typeface="Be Vietnam Pro" pitchFamily="34" charset="0"/>
+                <a:ea typeface="Be Vietnam Pro" pitchFamily="34" charset="-122"/>
+                <a:cs typeface="Be Vietnam Pro" pitchFamily="34" charset="-120"/>
+              </a:rPr>
+              <a:t> tưởng</a:t>
+            </a:r>
+            <a:r>
+              <a:rPr lang="en-US" sz="2400" dirty="0" spc="0" kern="0">
+                <a:solidFill>
+                  <a:srgbClr val="C4C8D6"/>
+                </a:solidFill>
+                <a:latin typeface="Be Vietnam Pro" pitchFamily="34" charset="0"/>
+                <a:ea typeface="Be Vietnam Pro" pitchFamily="34" charset="-122"/>
+                <a:cs typeface="Be Vietnam Pro" pitchFamily="34" charset="-120"/>
+              </a:rPr>
+              <a:t> chỉ</a:t>
             </a:r>
             <a:r>
               <a:rPr lang="en-US" sz="2400" dirty="0" spc="1" kern="0">

</xml_diff>